<commit_message>
Đổi toàn bộ bộ tài liệu sang phong cách tối giản: mực than, ngà, đồng nhũ
Co-Authored-By: Claude Opus 5.5 <noreply@anthropic.com>
Claude-Session: https://claude.ai/code/session_016W4H5FXW9gSiS33Aau8aSB
</commit_message>
<xml_diff>
--- a/02-Slide/Day-cung-AI-Gioi-thieu.pptx
+++ b/02-Slide/Day-cung-AI-Gioi-thieu.pptx
@@ -2815,7 +2815,7 @@
     <p:bg>
       <p:bgPr>
         <a:solidFill>
-          <a:srgbClr val="1F4E47"/>
+          <a:srgbClr val="1B1F24"/>
         </a:solidFill>
       </p:bgPr>
     </p:bg>
@@ -2835,36 +2835,14 @@
       </p:grpSpPr>
       <p:sp>
         <p:nvSpPr>
-          <p:cNvPr id="2" name="Shape 0"/>
-          <p:cNvSpPr/>
-          <p:nvPr/>
-        </p:nvSpPr>
-        <p:spPr>
-          <a:xfrm>
-            <a:off x="548640" y="548640"/>
-            <a:ext cx="2103120" cy="384048"/>
-          </a:xfrm>
-          <a:prstGeom prst="roundRect">
-            <a:avLst>
-              <a:gd name="adj" fmla="val 47619"/>
-            </a:avLst>
-          </a:prstGeom>
-          <a:solidFill>
-            <a:srgbClr val="F2B134"/>
-          </a:solidFill>
-          <a:ln/>
-        </p:spPr>
-      </p:sp>
-      <p:sp>
-        <p:nvSpPr>
-          <p:cNvPr id="3" name="Text 1"/>
+          <p:cNvPr id="2" name="Text 0"/>
           <p:cNvSpPr txBox="1"/>
           <p:nvPr/>
         </p:nvSpPr>
         <p:spPr>
           <a:xfrm>
-            <a:off x="548640" y="548640"/>
-            <a:ext cx="2103120" cy="384048"/>
+            <a:off x="548640" y="640080"/>
+            <a:ext cx="4572000" cy="365760"/>
           </a:xfrm>
           <a:prstGeom prst="rect">
             <a:avLst/>
@@ -2876,13 +2854,13 @@
           <a:bodyPr wrap="square" lIns="0" tIns="0" rIns="0" bIns="0" rtlCol="0" anchor="ctr"/>
           <a:lstStyle/>
           <a:p>
-            <a:pPr algn="ctr" indent="0" marL="0">
+            <a:pPr indent="0" marL="0">
               <a:buNone/>
             </a:pPr>
             <a:r>
-              <a:rPr lang="en-US" sz="1300" b="1" dirty="0">
+              <a:rPr lang="en-US" sz="1200" spc="1000" kern="0" dirty="0">
                 <a:solidFill>
-                  <a:srgbClr val="1F4E47"/>
+                  <a:srgbClr val="A67C3D"/>
                 </a:solidFill>
                 <a:latin typeface="Arial" pitchFamily="34" charset="0"/>
                 <a:ea typeface="Arial" pitchFamily="34" charset="-122"/>
@@ -2890,13 +2868,13 @@
               </a:rPr>
               <a:t>SỔ TAY THỰC HÀNH</a:t>
             </a:r>
-            <a:endParaRPr lang="en-US" sz="1300" dirty="0"/>
-          </a:p>
-        </p:txBody>
-      </p:sp>
-      <p:sp>
-        <p:nvSpPr>
-          <p:cNvPr id="4" name="Text 2"/>
+            <a:endParaRPr lang="en-US" sz="1200" dirty="0"/>
+          </a:p>
+        </p:txBody>
+      </p:sp>
+      <p:sp>
+        <p:nvSpPr>
+          <p:cNvPr id="3" name="Text 1"/>
           <p:cNvSpPr txBox="1"/>
           <p:nvPr/>
         </p:nvSpPr>
@@ -2919,29 +2897,29 @@
               <a:buNone/>
             </a:pPr>
             <a:r>
-              <a:rPr lang="en-US" sz="6400" b="1" dirty="0">
+              <a:rPr lang="en-US" sz="6600" dirty="0">
                 <a:solidFill>
-                  <a:srgbClr val="FFFFFF"/>
+                  <a:srgbClr val="F7F5F0"/>
                 </a:solidFill>
-                <a:latin typeface="Arial" pitchFamily="34" charset="0"/>
-                <a:ea typeface="Arial" pitchFamily="34" charset="-122"/>
-                <a:cs typeface="Arial" pitchFamily="34" charset="-120"/>
+                <a:latin typeface="Cambria" pitchFamily="34" charset="0"/>
+                <a:ea typeface="Cambria" pitchFamily="34" charset="-122"/>
+                <a:cs typeface="Cambria" pitchFamily="34" charset="-120"/>
               </a:rPr>
-              <a:t>DẠY CÙNG AI</a:t>
-            </a:r>
-            <a:endParaRPr lang="en-US" sz="6400" dirty="0"/>
-          </a:p>
-        </p:txBody>
-      </p:sp>
-      <p:sp>
-        <p:nvSpPr>
-          <p:cNvPr id="5" name="Text 3"/>
+              <a:t>Dạy cùng AI</a:t>
+            </a:r>
+            <a:endParaRPr lang="en-US" sz="6600" dirty="0"/>
+          </a:p>
+        </p:txBody>
+      </p:sp>
+      <p:sp>
+        <p:nvSpPr>
+          <p:cNvPr id="4" name="Text 2"/>
           <p:cNvSpPr txBox="1"/>
           <p:nvPr/>
         </p:nvSpPr>
         <p:spPr>
           <a:xfrm>
-            <a:off x="548640" y="2286000"/>
+            <a:off x="548640" y="2331720"/>
             <a:ext cx="8046720" cy="548640"/>
           </a:xfrm>
           <a:prstGeom prst="rect">
@@ -2958,23 +2936,23 @@
               <a:buNone/>
             </a:pPr>
             <a:r>
-              <a:rPr lang="en-US" sz="2600" dirty="0">
+              <a:rPr lang="en-US" sz="2400" i="1" dirty="0">
                 <a:solidFill>
-                  <a:srgbClr val="F2B134"/>
+                  <a:srgbClr val="A67C3D"/>
                 </a:solidFill>
-                <a:latin typeface="Arial" pitchFamily="34" charset="0"/>
-                <a:ea typeface="Arial" pitchFamily="34" charset="-122"/>
-                <a:cs typeface="Arial" pitchFamily="34" charset="-120"/>
+                <a:latin typeface="Cambria" pitchFamily="34" charset="0"/>
+                <a:ea typeface="Cambria" pitchFamily="34" charset="-122"/>
+                <a:cs typeface="Cambria" pitchFamily="34" charset="-120"/>
               </a:rPr>
               <a:t>Từ câu lệnh đầu tiên đến trợ giảng ảo</a:t>
             </a:r>
-            <a:endParaRPr lang="en-US" sz="2600" dirty="0"/>
-          </a:p>
-        </p:txBody>
-      </p:sp>
-      <p:sp>
-        <p:nvSpPr>
-          <p:cNvPr id="6" name="Text 4"/>
+            <a:endParaRPr lang="en-US" sz="2400" dirty="0"/>
+          </a:p>
+        </p:txBody>
+      </p:sp>
+      <p:sp>
+        <p:nvSpPr>
+          <p:cNvPr id="5" name="Text 3"/>
           <p:cNvSpPr txBox="1"/>
           <p:nvPr/>
         </p:nvSpPr>
@@ -2997,9 +2975,9 @@
               <a:buNone/>
             </a:pPr>
             <a:r>
-              <a:rPr lang="en-US" sz="1800" b="1" dirty="0">
+              <a:rPr lang="en-US" sz="1300" spc="600" kern="0" dirty="0">
                 <a:solidFill>
-                  <a:srgbClr val="FFFFFF"/>
+                  <a:srgbClr val="F7F5F0"/>
                 </a:solidFill>
                 <a:latin typeface="Arial" pitchFamily="34" charset="0"/>
                 <a:ea typeface="Arial" pitchFamily="34" charset="-122"/>
@@ -3007,13 +2985,13 @@
               </a:rPr>
               <a:t>Dành cho giáo viên Mầm non · Tiểu học · THCS</a:t>
             </a:r>
-            <a:endParaRPr lang="en-US" sz="1800" dirty="0"/>
-          </a:p>
-        </p:txBody>
-      </p:sp>
-      <p:sp>
-        <p:nvSpPr>
-          <p:cNvPr id="7" name="Text 5"/>
+            <a:endParaRPr lang="en-US" sz="1300" dirty="0"/>
+          </a:p>
+        </p:txBody>
+      </p:sp>
+      <p:sp>
+        <p:nvSpPr>
+          <p:cNvPr id="6" name="Text 4"/>
           <p:cNvSpPr txBox="1"/>
           <p:nvPr/>
         </p:nvSpPr>
@@ -3038,7 +3016,7 @@
             <a:r>
               <a:rPr lang="en-US" sz="1400" dirty="0">
                 <a:solidFill>
-                  <a:srgbClr val="FFFFFF"/>
+                  <a:srgbClr val="F7F5F0"/>
                 </a:solidFill>
                 <a:latin typeface="Arial" pitchFamily="34" charset="0"/>
                 <a:ea typeface="Arial" pitchFamily="34" charset="-122"/>
@@ -3064,7 +3042,7 @@
     <p:bg>
       <p:bgPr>
         <a:solidFill>
-          <a:srgbClr val="F2B134"/>
+          <a:srgbClr val="F7F5F0"/>
         </a:solidFill>
       </p:bgPr>
     </p:bg>
@@ -3090,16 +3068,21 @@
         </p:nvSpPr>
         <p:spPr>
           <a:xfrm>
-            <a:off x="6309360" y="1005840"/>
-            <a:ext cx="3108960" cy="3108960"/>
+            <a:off x="6035040" y="1005840"/>
+            <a:ext cx="2926080" cy="2926080"/>
           </a:xfrm>
           <a:prstGeom prst="ellipse">
             <a:avLst/>
           </a:prstGeom>
           <a:solidFill>
-            <a:srgbClr val="1F4E47"/>
+            <a:srgbClr val="F7F5F0"/>
           </a:solidFill>
-          <a:ln/>
+          <a:ln w="12700">
+            <a:solidFill>
+              <a:srgbClr val="A67C3D"/>
+            </a:solidFill>
+            <a:prstDash val="solid"/>
+          </a:ln>
         </p:spPr>
       </p:sp>
       <p:sp>
@@ -3110,8 +3093,8 @@
         </p:nvSpPr>
         <p:spPr>
           <a:xfrm>
-            <a:off x="6309360" y="1005840"/>
-            <a:ext cx="3108960" cy="3108960"/>
+            <a:off x="6035040" y="1005840"/>
+            <a:ext cx="2926080" cy="2926080"/>
           </a:xfrm>
           <a:prstGeom prst="rect">
             <a:avLst/>
@@ -3127,17 +3110,17 @@
               <a:buNone/>
             </a:pPr>
             <a:r>
-              <a:rPr lang="en-US" sz="12000" b="1" dirty="0">
+              <a:rPr lang="en-US" sz="11000" i="1" dirty="0">
                 <a:solidFill>
-                  <a:srgbClr val="F2B134"/>
+                  <a:srgbClr val="A67C3D"/>
                 </a:solidFill>
-                <a:latin typeface="Arial" pitchFamily="34" charset="0"/>
-                <a:ea typeface="Arial" pitchFamily="34" charset="-122"/>
-                <a:cs typeface="Arial" pitchFamily="34" charset="-120"/>
+                <a:latin typeface="Cambria" pitchFamily="34" charset="0"/>
+                <a:ea typeface="Cambria" pitchFamily="34" charset="-122"/>
+                <a:cs typeface="Cambria" pitchFamily="34" charset="-120"/>
               </a:rPr>
               <a:t>2</a:t>
             </a:r>
-            <a:endParaRPr lang="en-US" sz="12000" dirty="0"/>
+            <a:endParaRPr lang="en-US" sz="11000" dirty="0"/>
           </a:p>
         </p:txBody>
       </p:sp>
@@ -3166,9 +3149,9 @@
               <a:buNone/>
             </a:pPr>
             <a:r>
-              <a:rPr lang="en-US" sz="1600" b="1" spc="400" kern="0" dirty="0">
+              <a:rPr lang="en-US" sz="1200" spc="800" kern="0" dirty="0">
                 <a:solidFill>
-                  <a:srgbClr val="1F4E47"/>
+                  <a:srgbClr val="A67C3D"/>
                 </a:solidFill>
                 <a:latin typeface="Arial" pitchFamily="34" charset="0"/>
                 <a:ea typeface="Arial" pitchFamily="34" charset="-122"/>
@@ -3176,7 +3159,7 @@
               </a:rPr>
               <a:t>BUỔI 2</a:t>
             </a:r>
-            <a:endParaRPr lang="en-US" sz="1600" dirty="0"/>
+            <a:endParaRPr lang="en-US" sz="1200" dirty="0"/>
           </a:p>
         </p:txBody>
       </p:sp>
@@ -3189,7 +3172,7 @@
         <p:spPr>
           <a:xfrm>
             <a:off x="548640" y="1645920"/>
-            <a:ext cx="5486400" cy="1463040"/>
+            <a:ext cx="5303520" cy="1463040"/>
           </a:xfrm>
           <a:prstGeom prst="rect">
             <a:avLst/>
@@ -3205,17 +3188,17 @@
               <a:buNone/>
             </a:pPr>
             <a:r>
-              <a:rPr lang="en-US" sz="4000" b="1" dirty="0">
+              <a:rPr lang="en-US" sz="3800" dirty="0">
                 <a:solidFill>
-                  <a:srgbClr val="1F4E47"/>
+                  <a:srgbClr val="1B1F24"/>
                 </a:solidFill>
-                <a:latin typeface="Arial" pitchFamily="34" charset="0"/>
-                <a:ea typeface="Arial" pitchFamily="34" charset="-122"/>
-                <a:cs typeface="Arial" pitchFamily="34" charset="-120"/>
+                <a:latin typeface="Cambria" pitchFamily="34" charset="0"/>
+                <a:ea typeface="Cambria" pitchFamily="34" charset="-122"/>
+                <a:cs typeface="Cambria" pitchFamily="34" charset="-120"/>
               </a:rPr>
               <a:t>Kế hoạch bài dạy và kiểm tra đánh giá</a:t>
             </a:r>
-            <a:endParaRPr lang="en-US" sz="4000" dirty="0"/>
+            <a:endParaRPr lang="en-US" sz="3800" dirty="0"/>
           </a:p>
         </p:txBody>
       </p:sp>
@@ -3227,8 +3210,8 @@
         </p:nvSpPr>
         <p:spPr>
           <a:xfrm>
-            <a:off x="548640" y="3200400"/>
-            <a:ext cx="5303520" cy="914400"/>
+            <a:off x="548640" y="3291840"/>
+            <a:ext cx="5120640" cy="914400"/>
           </a:xfrm>
           <a:prstGeom prst="rect">
             <a:avLst/>
@@ -3244,9 +3227,9 @@
               <a:buNone/>
             </a:pPr>
             <a:r>
-              <a:rPr lang="en-US" sz="1600" dirty="0">
+              <a:rPr lang="en-US" sz="1300" dirty="0">
                 <a:solidFill>
-                  <a:srgbClr val="1F4E47"/>
+                  <a:srgbClr val="1B1F24"/>
                 </a:solidFill>
                 <a:latin typeface="Arial" pitchFamily="34" charset="0"/>
                 <a:ea typeface="Arial" pitchFamily="34" charset="-122"/>
@@ -3254,7 +3237,7 @@
               </a:rPr>
               <a:t>Góc trạm · STEM · Đề tự luận · Trắc nghiệm theo ma trận · Rubric · Overleaf</a:t>
             </a:r>
-            <a:endParaRPr lang="en-US" sz="1600" dirty="0"/>
+            <a:endParaRPr lang="en-US" sz="1300" dirty="0"/>
           </a:p>
         </p:txBody>
       </p:sp>
@@ -3272,7 +3255,7 @@
     <p:bg>
       <p:bgPr>
         <a:solidFill>
-          <a:srgbClr val="FFFFFF"/>
+          <a:srgbClr val="F7F5F0"/>
         </a:solidFill>
       </p:bgPr>
     </p:bg>
@@ -3328,7 +3311,7 @@
     <p:bg>
       <p:bgPr>
         <a:solidFill>
-          <a:srgbClr val="FFFFFF"/>
+          <a:srgbClr val="F7F5F0"/>
         </a:solidFill>
       </p:bgPr>
     </p:bg>
@@ -3384,7 +3367,7 @@
     <p:bg>
       <p:bgPr>
         <a:solidFill>
-          <a:srgbClr val="FFFFFF"/>
+          <a:srgbClr val="F7F5F0"/>
         </a:solidFill>
       </p:bgPr>
     </p:bg>
@@ -3440,7 +3423,7 @@
     <p:bg>
       <p:bgPr>
         <a:solidFill>
-          <a:srgbClr val="F2B134"/>
+          <a:srgbClr val="F7F5F0"/>
         </a:solidFill>
       </p:bgPr>
     </p:bg>
@@ -3466,16 +3449,21 @@
         </p:nvSpPr>
         <p:spPr>
           <a:xfrm>
-            <a:off x="6309360" y="1005840"/>
-            <a:ext cx="3108960" cy="3108960"/>
+            <a:off x="6035040" y="1005840"/>
+            <a:ext cx="2926080" cy="2926080"/>
           </a:xfrm>
           <a:prstGeom prst="ellipse">
             <a:avLst/>
           </a:prstGeom>
           <a:solidFill>
-            <a:srgbClr val="1F4E47"/>
+            <a:srgbClr val="F7F5F0"/>
           </a:solidFill>
-          <a:ln/>
+          <a:ln w="12700">
+            <a:solidFill>
+              <a:srgbClr val="A67C3D"/>
+            </a:solidFill>
+            <a:prstDash val="solid"/>
+          </a:ln>
         </p:spPr>
       </p:sp>
       <p:sp>
@@ -3486,8 +3474,8 @@
         </p:nvSpPr>
         <p:spPr>
           <a:xfrm>
-            <a:off x="6309360" y="1005840"/>
-            <a:ext cx="3108960" cy="3108960"/>
+            <a:off x="6035040" y="1005840"/>
+            <a:ext cx="2926080" cy="2926080"/>
           </a:xfrm>
           <a:prstGeom prst="rect">
             <a:avLst/>
@@ -3503,17 +3491,17 @@
               <a:buNone/>
             </a:pPr>
             <a:r>
-              <a:rPr lang="en-US" sz="12000" b="1" dirty="0">
+              <a:rPr lang="en-US" sz="11000" i="1" dirty="0">
                 <a:solidFill>
-                  <a:srgbClr val="F2B134"/>
+                  <a:srgbClr val="A67C3D"/>
                 </a:solidFill>
-                <a:latin typeface="Arial" pitchFamily="34" charset="0"/>
-                <a:ea typeface="Arial" pitchFamily="34" charset="-122"/>
-                <a:cs typeface="Arial" pitchFamily="34" charset="-120"/>
+                <a:latin typeface="Cambria" pitchFamily="34" charset="0"/>
+                <a:ea typeface="Cambria" pitchFamily="34" charset="-122"/>
+                <a:cs typeface="Cambria" pitchFamily="34" charset="-120"/>
               </a:rPr>
               <a:t>3</a:t>
             </a:r>
-            <a:endParaRPr lang="en-US" sz="12000" dirty="0"/>
+            <a:endParaRPr lang="en-US" sz="11000" dirty="0"/>
           </a:p>
         </p:txBody>
       </p:sp>
@@ -3542,9 +3530,9 @@
               <a:buNone/>
             </a:pPr>
             <a:r>
-              <a:rPr lang="en-US" sz="1600" b="1" spc="400" kern="0" dirty="0">
+              <a:rPr lang="en-US" sz="1200" spc="800" kern="0" dirty="0">
                 <a:solidFill>
-                  <a:srgbClr val="1F4E47"/>
+                  <a:srgbClr val="A67C3D"/>
                 </a:solidFill>
                 <a:latin typeface="Arial" pitchFamily="34" charset="0"/>
                 <a:ea typeface="Arial" pitchFamily="34" charset="-122"/>
@@ -3552,7 +3540,7 @@
               </a:rPr>
               <a:t>BUỔI 3</a:t>
             </a:r>
-            <a:endParaRPr lang="en-US" sz="1600" dirty="0"/>
+            <a:endParaRPr lang="en-US" sz="1200" dirty="0"/>
           </a:p>
         </p:txBody>
       </p:sp>
@@ -3565,7 +3553,7 @@
         <p:spPr>
           <a:xfrm>
             <a:off x="548640" y="1645920"/>
-            <a:ext cx="5486400" cy="1463040"/>
+            <a:ext cx="5303520" cy="1463040"/>
           </a:xfrm>
           <a:prstGeom prst="rect">
             <a:avLst/>
@@ -3581,17 +3569,17 @@
               <a:buNone/>
             </a:pPr>
             <a:r>
-              <a:rPr lang="en-US" sz="4000" b="1" dirty="0">
+              <a:rPr lang="en-US" sz="3800" dirty="0">
                 <a:solidFill>
-                  <a:srgbClr val="1F4E47"/>
+                  <a:srgbClr val="1B1F24"/>
                 </a:solidFill>
-                <a:latin typeface="Arial" pitchFamily="34" charset="0"/>
-                <a:ea typeface="Arial" pitchFamily="34" charset="-122"/>
-                <a:cs typeface="Arial" pitchFamily="34" charset="-120"/>
+                <a:latin typeface="Cambria" pitchFamily="34" charset="0"/>
+                <a:ea typeface="Cambria" pitchFamily="34" charset="-122"/>
+                <a:cs typeface="Cambria" pitchFamily="34" charset="-120"/>
               </a:rPr>
               <a:t>Sản phẩm đa phương tiện</a:t>
             </a:r>
-            <a:endParaRPr lang="en-US" sz="4000" dirty="0"/>
+            <a:endParaRPr lang="en-US" sz="3800" dirty="0"/>
           </a:p>
         </p:txBody>
       </p:sp>
@@ -3603,8 +3591,8 @@
         </p:nvSpPr>
         <p:spPr>
           <a:xfrm>
-            <a:off x="548640" y="3200400"/>
-            <a:ext cx="5303520" cy="914400"/>
+            <a:off x="548640" y="3291840"/>
+            <a:ext cx="5120640" cy="914400"/>
           </a:xfrm>
           <a:prstGeom prst="rect">
             <a:avLst/>
@@ -3620,9 +3608,9 @@
               <a:buNone/>
             </a:pPr>
             <a:r>
-              <a:rPr lang="en-US" sz="1600" dirty="0">
+              <a:rPr lang="en-US" sz="1300" dirty="0">
                 <a:solidFill>
-                  <a:srgbClr val="1F4E47"/>
+                  <a:srgbClr val="1B1F24"/>
                 </a:solidFill>
                 <a:latin typeface="Arial" pitchFamily="34" charset="0"/>
                 <a:ea typeface="Arial" pitchFamily="34" charset="-122"/>
@@ -3630,7 +3618,7 @@
               </a:rPr>
               <a:t>Ảnh · Trò chơi · Truyện tranh · Bài hát · Giọng đọc · Hội thoại</a:t>
             </a:r>
-            <a:endParaRPr lang="en-US" sz="1600" dirty="0"/>
+            <a:endParaRPr lang="en-US" sz="1300" dirty="0"/>
           </a:p>
         </p:txBody>
       </p:sp>
@@ -3648,7 +3636,7 @@
     <p:bg>
       <p:bgPr>
         <a:solidFill>
-          <a:srgbClr val="FFFFFF"/>
+          <a:srgbClr val="F7F5F0"/>
         </a:solidFill>
       </p:bgPr>
     </p:bg>
@@ -3704,7 +3692,7 @@
     <p:bg>
       <p:bgPr>
         <a:solidFill>
-          <a:srgbClr val="FFFFFF"/>
+          <a:srgbClr val="F7F5F0"/>
         </a:solidFill>
       </p:bgPr>
     </p:bg>
@@ -3760,7 +3748,7 @@
     <p:bg>
       <p:bgPr>
         <a:solidFill>
-          <a:srgbClr val="F2B134"/>
+          <a:srgbClr val="F7F5F0"/>
         </a:solidFill>
       </p:bgPr>
     </p:bg>
@@ -3786,16 +3774,21 @@
         </p:nvSpPr>
         <p:spPr>
           <a:xfrm>
-            <a:off x="6309360" y="1005840"/>
-            <a:ext cx="3108960" cy="3108960"/>
+            <a:off x="6035040" y="1005840"/>
+            <a:ext cx="2926080" cy="2926080"/>
           </a:xfrm>
           <a:prstGeom prst="ellipse">
             <a:avLst/>
           </a:prstGeom>
           <a:solidFill>
-            <a:srgbClr val="1F4E47"/>
+            <a:srgbClr val="F7F5F0"/>
           </a:solidFill>
-          <a:ln/>
+          <a:ln w="12700">
+            <a:solidFill>
+              <a:srgbClr val="A67C3D"/>
+            </a:solidFill>
+            <a:prstDash val="solid"/>
+          </a:ln>
         </p:spPr>
       </p:sp>
       <p:sp>
@@ -3806,8 +3799,8 @@
         </p:nvSpPr>
         <p:spPr>
           <a:xfrm>
-            <a:off x="6309360" y="1005840"/>
-            <a:ext cx="3108960" cy="3108960"/>
+            <a:off x="6035040" y="1005840"/>
+            <a:ext cx="2926080" cy="2926080"/>
           </a:xfrm>
           <a:prstGeom prst="rect">
             <a:avLst/>
@@ -3823,17 +3816,17 @@
               <a:buNone/>
             </a:pPr>
             <a:r>
-              <a:rPr lang="en-US" sz="12000" b="1" dirty="0">
+              <a:rPr lang="en-US" sz="11000" i="1" dirty="0">
                 <a:solidFill>
-                  <a:srgbClr val="F2B134"/>
+                  <a:srgbClr val="A67C3D"/>
                 </a:solidFill>
-                <a:latin typeface="Arial" pitchFamily="34" charset="0"/>
-                <a:ea typeface="Arial" pitchFamily="34" charset="-122"/>
-                <a:cs typeface="Arial" pitchFamily="34" charset="-120"/>
+                <a:latin typeface="Cambria" pitchFamily="34" charset="0"/>
+                <a:ea typeface="Cambria" pitchFamily="34" charset="-122"/>
+                <a:cs typeface="Cambria" pitchFamily="34" charset="-120"/>
               </a:rPr>
               <a:t>4</a:t>
             </a:r>
-            <a:endParaRPr lang="en-US" sz="12000" dirty="0"/>
+            <a:endParaRPr lang="en-US" sz="11000" dirty="0"/>
           </a:p>
         </p:txBody>
       </p:sp>
@@ -3862,9 +3855,9 @@
               <a:buNone/>
             </a:pPr>
             <a:r>
-              <a:rPr lang="en-US" sz="1600" b="1" spc="400" kern="0" dirty="0">
+              <a:rPr lang="en-US" sz="1200" spc="800" kern="0" dirty="0">
                 <a:solidFill>
-                  <a:srgbClr val="1F4E47"/>
+                  <a:srgbClr val="A67C3D"/>
                 </a:solidFill>
                 <a:latin typeface="Arial" pitchFamily="34" charset="0"/>
                 <a:ea typeface="Arial" pitchFamily="34" charset="-122"/>
@@ -3872,7 +3865,7 @@
               </a:rPr>
               <a:t>BUỔI 4</a:t>
             </a:r>
-            <a:endParaRPr lang="en-US" sz="1600" dirty="0"/>
+            <a:endParaRPr lang="en-US" sz="1200" dirty="0"/>
           </a:p>
         </p:txBody>
       </p:sp>
@@ -3885,7 +3878,7 @@
         <p:spPr>
           <a:xfrm>
             <a:off x="548640" y="1645920"/>
-            <a:ext cx="5486400" cy="1463040"/>
+            <a:ext cx="5303520" cy="1463040"/>
           </a:xfrm>
           <a:prstGeom prst="rect">
             <a:avLst/>
@@ -3901,17 +3894,17 @@
               <a:buNone/>
             </a:pPr>
             <a:r>
-              <a:rPr lang="en-US" sz="4000" b="1" dirty="0">
+              <a:rPr lang="en-US" sz="3800" dirty="0">
                 <a:solidFill>
-                  <a:srgbClr val="1F4E47"/>
+                  <a:srgbClr val="1B1F24"/>
                 </a:solidFill>
-                <a:latin typeface="Arial" pitchFamily="34" charset="0"/>
-                <a:ea typeface="Arial" pitchFamily="34" charset="-122"/>
-                <a:cs typeface="Arial" pitchFamily="34" charset="-120"/>
+                <a:latin typeface="Cambria" pitchFamily="34" charset="0"/>
+                <a:ea typeface="Cambria" pitchFamily="34" charset="-122"/>
+                <a:cs typeface="Cambria" pitchFamily="34" charset="-120"/>
               </a:rPr>
               <a:t>Deep Research và trợ lý chatbot</a:t>
             </a:r>
-            <a:endParaRPr lang="en-US" sz="4000" dirty="0"/>
+            <a:endParaRPr lang="en-US" sz="3800" dirty="0"/>
           </a:p>
         </p:txBody>
       </p:sp>
@@ -3923,8 +3916,8 @@
         </p:nvSpPr>
         <p:spPr>
           <a:xfrm>
-            <a:off x="548640" y="3200400"/>
-            <a:ext cx="5303520" cy="914400"/>
+            <a:off x="548640" y="3291840"/>
+            <a:ext cx="5120640" cy="914400"/>
           </a:xfrm>
           <a:prstGeom prst="rect">
             <a:avLst/>
@@ -3940,9 +3933,9 @@
               <a:buNone/>
             </a:pPr>
             <a:r>
-              <a:rPr lang="en-US" sz="1600" dirty="0">
+              <a:rPr lang="en-US" sz="1300" dirty="0">
                 <a:solidFill>
-                  <a:srgbClr val="1F4E47"/>
+                  <a:srgbClr val="1B1F24"/>
                 </a:solidFill>
                 <a:latin typeface="Arial" pitchFamily="34" charset="0"/>
                 <a:ea typeface="Arial" pitchFamily="34" charset="-122"/>
@@ -3950,7 +3943,7 @@
               </a:rPr>
               <a:t>Báo cáo có nguồn · Kiểm chứng thông tin · Gem · Poe · Magic School</a:t>
             </a:r>
-            <a:endParaRPr lang="en-US" sz="1600" dirty="0"/>
+            <a:endParaRPr lang="en-US" sz="1300" dirty="0"/>
           </a:p>
         </p:txBody>
       </p:sp>
@@ -3968,7 +3961,7 @@
     <p:bg>
       <p:bgPr>
         <a:solidFill>
-          <a:srgbClr val="FFFFFF"/>
+          <a:srgbClr val="F7F5F0"/>
         </a:solidFill>
       </p:bgPr>
     </p:bg>
@@ -4024,7 +4017,7 @@
     <p:bg>
       <p:bgPr>
         <a:solidFill>
-          <a:srgbClr val="FFFFFF"/>
+          <a:srgbClr val="F7F5F0"/>
         </a:solidFill>
       </p:bgPr>
     </p:bg>
@@ -4080,7 +4073,7 @@
     <p:bg>
       <p:bgPr>
         <a:solidFill>
-          <a:srgbClr val="FFFFFF"/>
+          <a:srgbClr val="F7F5F0"/>
         </a:solidFill>
       </p:bgPr>
     </p:bg>
@@ -4106,7 +4099,7 @@
         </p:nvSpPr>
         <p:spPr>
           <a:xfrm>
-            <a:off x="548640" y="411480"/>
+            <a:off x="548640" y="457200"/>
             <a:ext cx="8046720" cy="640080"/>
           </a:xfrm>
           <a:prstGeom prst="rect">
@@ -4123,13 +4116,13 @@
               <a:buNone/>
             </a:pPr>
             <a:r>
-              <a:rPr lang="en-US" sz="3000" b="1" dirty="0">
+              <a:rPr lang="en-US" sz="3000" dirty="0">
                 <a:solidFill>
-                  <a:srgbClr val="1F4E47"/>
+                  <a:srgbClr val="1B1F24"/>
                 </a:solidFill>
-                <a:latin typeface="Arial" pitchFamily="34" charset="0"/>
-                <a:ea typeface="Arial" pitchFamily="34" charset="-122"/>
-                <a:cs typeface="Arial" pitchFamily="34" charset="-120"/>
+                <a:latin typeface="Cambria" pitchFamily="34" charset="0"/>
+                <a:ea typeface="Cambria" pitchFamily="34" charset="-122"/>
+                <a:cs typeface="Cambria" pitchFamily="34" charset="-120"/>
               </a:rPr>
               <a:t>Sau cuốn sách, thầy cô tự làm được</a:t>
             </a:r>
@@ -4150,13 +4143,18 @@
           </a:xfrm>
           <a:prstGeom prst="roundRect">
             <a:avLst>
-              <a:gd name="adj" fmla="val 7317"/>
+              <a:gd name="adj" fmla="val 1463"/>
             </a:avLst>
           </a:prstGeom>
           <a:solidFill>
-            <a:srgbClr val="E9EFEE"/>
+            <a:srgbClr val="F7F5F0"/>
           </a:solidFill>
-          <a:ln/>
+          <a:ln w="9525">
+            <a:solidFill>
+              <a:srgbClr val="CFCAC0"/>
+            </a:solidFill>
+            <a:prstDash val="solid"/>
+          </a:ln>
         </p:spPr>
       </p:sp>
       <p:sp>
@@ -4168,15 +4166,20 @@
         <p:spPr>
           <a:xfrm>
             <a:off x="777240" y="1600200"/>
-            <a:ext cx="640080" cy="640080"/>
+            <a:ext cx="548640" cy="548640"/>
           </a:xfrm>
           <a:prstGeom prst="ellipse">
             <a:avLst/>
           </a:prstGeom>
           <a:solidFill>
-            <a:srgbClr val="F2B134"/>
+            <a:srgbClr val="F7F5F0"/>
           </a:solidFill>
-          <a:ln/>
+          <a:ln w="9525">
+            <a:solidFill>
+              <a:srgbClr val="A67C3D"/>
+            </a:solidFill>
+            <a:prstDash val="solid"/>
+          </a:ln>
         </p:spPr>
       </p:sp>
       <p:sp>
@@ -4188,7 +4191,7 @@
         <p:spPr>
           <a:xfrm>
             <a:off x="777240" y="1600200"/>
-            <a:ext cx="640080" cy="640080"/>
+            <a:ext cx="548640" cy="548640"/>
           </a:xfrm>
           <a:prstGeom prst="rect">
             <a:avLst/>
@@ -4204,17 +4207,17 @@
               <a:buNone/>
             </a:pPr>
             <a:r>
-              <a:rPr lang="en-US" sz="2400" b="1" dirty="0">
+              <a:rPr lang="en-US" sz="1800" dirty="0">
                 <a:solidFill>
-                  <a:srgbClr val="1F4E47"/>
+                  <a:srgbClr val="A67C3D"/>
                 </a:solidFill>
-                <a:latin typeface="Arial" pitchFamily="34" charset="0"/>
-                <a:ea typeface="Arial" pitchFamily="34" charset="-122"/>
-                <a:cs typeface="Arial" pitchFamily="34" charset="-120"/>
+                <a:latin typeface="Cambria" pitchFamily="34" charset="0"/>
+                <a:ea typeface="Cambria" pitchFamily="34" charset="-122"/>
+                <a:cs typeface="Cambria" pitchFamily="34" charset="-120"/>
               </a:rPr>
               <a:t>1</a:t>
             </a:r>
-            <a:endParaRPr lang="en-US" sz="2400" dirty="0"/>
+            <a:endParaRPr lang="en-US" sz="1800" dirty="0"/>
           </a:p>
         </p:txBody>
       </p:sp>
@@ -4243,13 +4246,13 @@
               <a:buNone/>
             </a:pPr>
             <a:r>
-              <a:rPr lang="en-US" sz="1900" b="1" dirty="0">
+              <a:rPr lang="en-US" sz="1900" dirty="0">
                 <a:solidFill>
-                  <a:srgbClr val="1F4E47"/>
+                  <a:srgbClr val="1B1F24"/>
                 </a:solidFill>
-                <a:latin typeface="Arial" pitchFamily="34" charset="0"/>
-                <a:ea typeface="Arial" pitchFamily="34" charset="-122"/>
-                <a:cs typeface="Arial" pitchFamily="34" charset="-120"/>
+                <a:latin typeface="Cambria" pitchFamily="34" charset="0"/>
+                <a:ea typeface="Cambria" pitchFamily="34" charset="-122"/>
+                <a:cs typeface="Cambria" pitchFamily="34" charset="-120"/>
               </a:rPr>
               <a:t>Soạn bài</a:t>
             </a:r>
@@ -4284,7 +4287,7 @@
             <a:r>
               <a:rPr lang="en-US" sz="1300" dirty="0">
                 <a:solidFill>
-                  <a:srgbClr val="1F4E47"/>
+                  <a:srgbClr val="1B1F24"/>
                 </a:solidFill>
                 <a:latin typeface="Arial" pitchFamily="34" charset="0"/>
                 <a:ea typeface="Arial" pitchFamily="34" charset="-122"/>
@@ -4309,13 +4312,18 @@
           </a:xfrm>
           <a:prstGeom prst="roundRect">
             <a:avLst>
-              <a:gd name="adj" fmla="val 7317"/>
+              <a:gd name="adj" fmla="val 1463"/>
             </a:avLst>
           </a:prstGeom>
           <a:solidFill>
-            <a:srgbClr val="E9EFEE"/>
+            <a:srgbClr val="F7F5F0"/>
           </a:solidFill>
-          <a:ln/>
+          <a:ln w="9525">
+            <a:solidFill>
+              <a:srgbClr val="CFCAC0"/>
+            </a:solidFill>
+            <a:prstDash val="solid"/>
+          </a:ln>
         </p:spPr>
       </p:sp>
       <p:sp>
@@ -4327,15 +4335,20 @@
         <p:spPr>
           <a:xfrm>
             <a:off x="2834640" y="1600200"/>
-            <a:ext cx="640080" cy="640080"/>
+            <a:ext cx="548640" cy="548640"/>
           </a:xfrm>
           <a:prstGeom prst="ellipse">
             <a:avLst/>
           </a:prstGeom>
           <a:solidFill>
-            <a:srgbClr val="F2B134"/>
+            <a:srgbClr val="F7F5F0"/>
           </a:solidFill>
-          <a:ln/>
+          <a:ln w="9525">
+            <a:solidFill>
+              <a:srgbClr val="A67C3D"/>
+            </a:solidFill>
+            <a:prstDash val="solid"/>
+          </a:ln>
         </p:spPr>
       </p:sp>
       <p:sp>
@@ -4347,7 +4360,7 @@
         <p:spPr>
           <a:xfrm>
             <a:off x="2834640" y="1600200"/>
-            <a:ext cx="640080" cy="640080"/>
+            <a:ext cx="548640" cy="548640"/>
           </a:xfrm>
           <a:prstGeom prst="rect">
             <a:avLst/>
@@ -4363,17 +4376,17 @@
               <a:buNone/>
             </a:pPr>
             <a:r>
-              <a:rPr lang="en-US" sz="2400" b="1" dirty="0">
+              <a:rPr lang="en-US" sz="1800" dirty="0">
                 <a:solidFill>
-                  <a:srgbClr val="1F4E47"/>
+                  <a:srgbClr val="A67C3D"/>
                 </a:solidFill>
-                <a:latin typeface="Arial" pitchFamily="34" charset="0"/>
-                <a:ea typeface="Arial" pitchFamily="34" charset="-122"/>
-                <a:cs typeface="Arial" pitchFamily="34" charset="-120"/>
+                <a:latin typeface="Cambria" pitchFamily="34" charset="0"/>
+                <a:ea typeface="Cambria" pitchFamily="34" charset="-122"/>
+                <a:cs typeface="Cambria" pitchFamily="34" charset="-120"/>
               </a:rPr>
               <a:t>2</a:t>
             </a:r>
-            <a:endParaRPr lang="en-US" sz="2400" dirty="0"/>
+            <a:endParaRPr lang="en-US" sz="1800" dirty="0"/>
           </a:p>
         </p:txBody>
       </p:sp>
@@ -4402,13 +4415,13 @@
               <a:buNone/>
             </a:pPr>
             <a:r>
-              <a:rPr lang="en-US" sz="1900" b="1" dirty="0">
+              <a:rPr lang="en-US" sz="1900" dirty="0">
                 <a:solidFill>
-                  <a:srgbClr val="1F4E47"/>
+                  <a:srgbClr val="1B1F24"/>
                 </a:solidFill>
-                <a:latin typeface="Arial" pitchFamily="34" charset="0"/>
-                <a:ea typeface="Arial" pitchFamily="34" charset="-122"/>
-                <a:cs typeface="Arial" pitchFamily="34" charset="-120"/>
+                <a:latin typeface="Cambria" pitchFamily="34" charset="0"/>
+                <a:ea typeface="Cambria" pitchFamily="34" charset="-122"/>
+                <a:cs typeface="Cambria" pitchFamily="34" charset="-120"/>
               </a:rPr>
               <a:t>Ra đề</a:t>
             </a:r>
@@ -4443,7 +4456,7 @@
             <a:r>
               <a:rPr lang="en-US" sz="1300" dirty="0">
                 <a:solidFill>
-                  <a:srgbClr val="1F4E47"/>
+                  <a:srgbClr val="1B1F24"/>
                 </a:solidFill>
                 <a:latin typeface="Arial" pitchFamily="34" charset="0"/>
                 <a:ea typeface="Arial" pitchFamily="34" charset="-122"/>
@@ -4468,13 +4481,18 @@
           </a:xfrm>
           <a:prstGeom prst="roundRect">
             <a:avLst>
-              <a:gd name="adj" fmla="val 7317"/>
+              <a:gd name="adj" fmla="val 1463"/>
             </a:avLst>
           </a:prstGeom>
           <a:solidFill>
-            <a:srgbClr val="E9EFEE"/>
+            <a:srgbClr val="F7F5F0"/>
           </a:solidFill>
-          <a:ln/>
+          <a:ln w="9525">
+            <a:solidFill>
+              <a:srgbClr val="CFCAC0"/>
+            </a:solidFill>
+            <a:prstDash val="solid"/>
+          </a:ln>
         </p:spPr>
       </p:sp>
       <p:sp>
@@ -4486,15 +4504,20 @@
         <p:spPr>
           <a:xfrm>
             <a:off x="4892040" y="1600200"/>
-            <a:ext cx="640080" cy="640080"/>
+            <a:ext cx="548640" cy="548640"/>
           </a:xfrm>
           <a:prstGeom prst="ellipse">
             <a:avLst/>
           </a:prstGeom>
           <a:solidFill>
-            <a:srgbClr val="F2B134"/>
+            <a:srgbClr val="F7F5F0"/>
           </a:solidFill>
-          <a:ln/>
+          <a:ln w="9525">
+            <a:solidFill>
+              <a:srgbClr val="A67C3D"/>
+            </a:solidFill>
+            <a:prstDash val="solid"/>
+          </a:ln>
         </p:spPr>
       </p:sp>
       <p:sp>
@@ -4506,7 +4529,7 @@
         <p:spPr>
           <a:xfrm>
             <a:off x="4892040" y="1600200"/>
-            <a:ext cx="640080" cy="640080"/>
+            <a:ext cx="548640" cy="548640"/>
           </a:xfrm>
           <a:prstGeom prst="rect">
             <a:avLst/>
@@ -4522,17 +4545,17 @@
               <a:buNone/>
             </a:pPr>
             <a:r>
-              <a:rPr lang="en-US" sz="2400" b="1" dirty="0">
+              <a:rPr lang="en-US" sz="1800" dirty="0">
                 <a:solidFill>
-                  <a:srgbClr val="1F4E47"/>
+                  <a:srgbClr val="A67C3D"/>
                 </a:solidFill>
-                <a:latin typeface="Arial" pitchFamily="34" charset="0"/>
-                <a:ea typeface="Arial" pitchFamily="34" charset="-122"/>
-                <a:cs typeface="Arial" pitchFamily="34" charset="-120"/>
+                <a:latin typeface="Cambria" pitchFamily="34" charset="0"/>
+                <a:ea typeface="Cambria" pitchFamily="34" charset="-122"/>
+                <a:cs typeface="Cambria" pitchFamily="34" charset="-120"/>
               </a:rPr>
               <a:t>3</a:t>
             </a:r>
-            <a:endParaRPr lang="en-US" sz="2400" dirty="0"/>
+            <a:endParaRPr lang="en-US" sz="1800" dirty="0"/>
           </a:p>
         </p:txBody>
       </p:sp>
@@ -4561,13 +4584,13 @@
               <a:buNone/>
             </a:pPr>
             <a:r>
-              <a:rPr lang="en-US" sz="1900" b="1" dirty="0">
+              <a:rPr lang="en-US" sz="1900" dirty="0">
                 <a:solidFill>
-                  <a:srgbClr val="1F4E47"/>
+                  <a:srgbClr val="1B1F24"/>
                 </a:solidFill>
-                <a:latin typeface="Arial" pitchFamily="34" charset="0"/>
-                <a:ea typeface="Arial" pitchFamily="34" charset="-122"/>
-                <a:cs typeface="Arial" pitchFamily="34" charset="-120"/>
+                <a:latin typeface="Cambria" pitchFamily="34" charset="0"/>
+                <a:ea typeface="Cambria" pitchFamily="34" charset="-122"/>
+                <a:cs typeface="Cambria" pitchFamily="34" charset="-120"/>
               </a:rPr>
               <a:t>Làm học liệu</a:t>
             </a:r>
@@ -4602,7 +4625,7 @@
             <a:r>
               <a:rPr lang="en-US" sz="1300" dirty="0">
                 <a:solidFill>
-                  <a:srgbClr val="1F4E47"/>
+                  <a:srgbClr val="1B1F24"/>
                 </a:solidFill>
                 <a:latin typeface="Arial" pitchFamily="34" charset="0"/>
                 <a:ea typeface="Arial" pitchFamily="34" charset="-122"/>
@@ -4627,13 +4650,18 @@
           </a:xfrm>
           <a:prstGeom prst="roundRect">
             <a:avLst>
-              <a:gd name="adj" fmla="val 7317"/>
+              <a:gd name="adj" fmla="val 1463"/>
             </a:avLst>
           </a:prstGeom>
           <a:solidFill>
-            <a:srgbClr val="1F4E47"/>
+            <a:srgbClr val="1B1F24"/>
           </a:solidFill>
-          <a:ln/>
+          <a:ln w="9525">
+            <a:solidFill>
+              <a:srgbClr val="1B1F24"/>
+            </a:solidFill>
+            <a:prstDash val="solid"/>
+          </a:ln>
         </p:spPr>
       </p:sp>
       <p:sp>
@@ -4645,15 +4673,20 @@
         <p:spPr>
           <a:xfrm>
             <a:off x="6949440" y="1600200"/>
-            <a:ext cx="640080" cy="640080"/>
+            <a:ext cx="548640" cy="548640"/>
           </a:xfrm>
           <a:prstGeom prst="ellipse">
             <a:avLst/>
           </a:prstGeom>
           <a:solidFill>
-            <a:srgbClr val="F2B134"/>
+            <a:srgbClr val="1B1F24"/>
           </a:solidFill>
-          <a:ln/>
+          <a:ln w="9525">
+            <a:solidFill>
+              <a:srgbClr val="A67C3D"/>
+            </a:solidFill>
+            <a:prstDash val="solid"/>
+          </a:ln>
         </p:spPr>
       </p:sp>
       <p:sp>
@@ -4665,7 +4698,7 @@
         <p:spPr>
           <a:xfrm>
             <a:off x="6949440" y="1600200"/>
-            <a:ext cx="640080" cy="640080"/>
+            <a:ext cx="548640" cy="548640"/>
           </a:xfrm>
           <a:prstGeom prst="rect">
             <a:avLst/>
@@ -4681,17 +4714,17 @@
               <a:buNone/>
             </a:pPr>
             <a:r>
-              <a:rPr lang="en-US" sz="2400" b="1" dirty="0">
+              <a:rPr lang="en-US" sz="1800" dirty="0">
                 <a:solidFill>
-                  <a:srgbClr val="1F4E47"/>
+                  <a:srgbClr val="A67C3D"/>
                 </a:solidFill>
-                <a:latin typeface="Arial" pitchFamily="34" charset="0"/>
-                <a:ea typeface="Arial" pitchFamily="34" charset="-122"/>
-                <a:cs typeface="Arial" pitchFamily="34" charset="-120"/>
+                <a:latin typeface="Cambria" pitchFamily="34" charset="0"/>
+                <a:ea typeface="Cambria" pitchFamily="34" charset="-122"/>
+                <a:cs typeface="Cambria" pitchFamily="34" charset="-120"/>
               </a:rPr>
               <a:t>4</a:t>
             </a:r>
-            <a:endParaRPr lang="en-US" sz="2400" dirty="0"/>
+            <a:endParaRPr lang="en-US" sz="1800" dirty="0"/>
           </a:p>
         </p:txBody>
       </p:sp>
@@ -4720,13 +4753,13 @@
               <a:buNone/>
             </a:pPr>
             <a:r>
-              <a:rPr lang="en-US" sz="1900" b="1" dirty="0">
+              <a:rPr lang="en-US" sz="1900" dirty="0">
                 <a:solidFill>
-                  <a:srgbClr val="FFFFFF"/>
+                  <a:srgbClr val="F7F5F0"/>
                 </a:solidFill>
-                <a:latin typeface="Arial" pitchFamily="34" charset="0"/>
-                <a:ea typeface="Arial" pitchFamily="34" charset="-122"/>
-                <a:cs typeface="Arial" pitchFamily="34" charset="-120"/>
+                <a:latin typeface="Cambria" pitchFamily="34" charset="0"/>
+                <a:ea typeface="Cambria" pitchFamily="34" charset="-122"/>
+                <a:cs typeface="Cambria" pitchFamily="34" charset="-120"/>
               </a:rPr>
               <a:t>Tạo trợ giảng</a:t>
             </a:r>
@@ -4761,7 +4794,7 @@
             <a:r>
               <a:rPr lang="en-US" sz="1300" dirty="0">
                 <a:solidFill>
-                  <a:srgbClr val="FFFFFF"/>
+                  <a:srgbClr val="F7F5F0"/>
                 </a:solidFill>
                 <a:latin typeface="Arial" pitchFamily="34" charset="0"/>
                 <a:ea typeface="Arial" pitchFamily="34" charset="-122"/>
@@ -4787,7 +4820,7 @@
     <p:bg>
       <p:bgPr>
         <a:solidFill>
-          <a:srgbClr val="FFFFFF"/>
+          <a:srgbClr val="F7F5F0"/>
         </a:solidFill>
       </p:bgPr>
     </p:bg>
@@ -4843,7 +4876,7 @@
     <p:bg>
       <p:bgPr>
         <a:solidFill>
-          <a:srgbClr val="FFFFFF"/>
+          <a:srgbClr val="F7F5F0"/>
         </a:solidFill>
       </p:bgPr>
     </p:bg>
@@ -4899,7 +4932,7 @@
     <p:bg>
       <p:bgPr>
         <a:solidFill>
-          <a:srgbClr val="FFFFFF"/>
+          <a:srgbClr val="F7F5F0"/>
         </a:solidFill>
       </p:bgPr>
     </p:bg>
@@ -4955,7 +4988,7 @@
     <p:bg>
       <p:bgPr>
         <a:solidFill>
-          <a:srgbClr val="1F4E47"/>
+          <a:srgbClr val="1B1F24"/>
         </a:solidFill>
       </p:bgPr>
     </p:bg>
@@ -4998,17 +5031,17 @@
               <a:buNone/>
             </a:pPr>
             <a:r>
-              <a:rPr lang="en-US" sz="3200" b="1" dirty="0">
+              <a:rPr lang="en-US" sz="2800" dirty="0">
                 <a:solidFill>
-                  <a:srgbClr val="FFFFFF"/>
+                  <a:srgbClr val="F7F5F0"/>
                 </a:solidFill>
-                <a:latin typeface="Arial" pitchFamily="34" charset="0"/>
-                <a:ea typeface="Arial" pitchFamily="34" charset="-122"/>
-                <a:cs typeface="Arial" pitchFamily="34" charset="-120"/>
+                <a:latin typeface="Cambria" pitchFamily="34" charset="0"/>
+                <a:ea typeface="Cambria" pitchFamily="34" charset="-122"/>
+                <a:cs typeface="Cambria" pitchFamily="34" charset="-120"/>
               </a:rPr>
-              <a:t>Bắt đầu ngay hôm nay với 1 câu lệnh</a:t>
-            </a:r>
-            <a:endParaRPr lang="en-US" sz="3200" dirty="0"/>
+              <a:t>Bắt đầu ngay hôm nay với một câu lệnh</a:t>
+            </a:r>
+            <a:endParaRPr lang="en-US" sz="2800" dirty="0"/>
           </a:p>
         </p:txBody>
       </p:sp>
@@ -5023,15 +5056,18 @@
             <a:off x="548640" y="1554480"/>
             <a:ext cx="8046720" cy="1371600"/>
           </a:xfrm>
-          <a:prstGeom prst="roundRect">
-            <a:avLst>
-              <a:gd name="adj" fmla="val 10000"/>
-            </a:avLst>
+          <a:prstGeom prst="rect">
+            <a:avLst/>
           </a:prstGeom>
           <a:solidFill>
-            <a:srgbClr val="FFFFFF"/>
+            <a:srgbClr val="1B1F24"/>
           </a:solidFill>
-          <a:ln/>
+          <a:ln w="9525">
+            <a:solidFill>
+              <a:srgbClr val="A67C3D"/>
+            </a:solidFill>
+            <a:prstDash val="solid"/>
+          </a:ln>
         </p:spPr>
       </p:sp>
       <p:sp>
@@ -5059,13 +5095,13 @@
               <a:buNone/>
             </a:pPr>
             <a:r>
-              <a:rPr lang="en-US" sz="2200" dirty="0">
+              <a:rPr lang="en-US" sz="2200" i="1" dirty="0">
                 <a:solidFill>
-                  <a:srgbClr val="1F4E47"/>
+                  <a:srgbClr val="F7F5F0"/>
                 </a:solidFill>
-                <a:latin typeface="Arial" pitchFamily="34" charset="0"/>
-                <a:ea typeface="Arial" pitchFamily="34" charset="-122"/>
-                <a:cs typeface="Arial" pitchFamily="34" charset="-120"/>
+                <a:latin typeface="Cambria" pitchFamily="34" charset="0"/>
+                <a:ea typeface="Cambria" pitchFamily="34" charset="-122"/>
+                <a:cs typeface="Cambria" pitchFamily="34" charset="-120"/>
               </a:rPr>
               <a:t>Cho tôi gợi ý bài giảng về chủ đề [bài thầy cô dạy tuần này] cho học sinh [lớp mấy].</a:t>
             </a:r>
@@ -5098,17 +5134,17 @@
               <a:buNone/>
             </a:pPr>
             <a:r>
-              <a:rPr lang="en-US" sz="2600" b="1" dirty="0">
+              <a:rPr lang="en-US" sz="2400" dirty="0">
                 <a:solidFill>
-                  <a:srgbClr val="F2B134"/>
+                  <a:srgbClr val="A67C3D"/>
                 </a:solidFill>
-                <a:latin typeface="Arial" pitchFamily="34" charset="0"/>
-                <a:ea typeface="Arial" pitchFamily="34" charset="-122"/>
-                <a:cs typeface="Arial" pitchFamily="34" charset="-120"/>
+                <a:latin typeface="Cambria" pitchFamily="34" charset="0"/>
+                <a:ea typeface="Cambria" pitchFamily="34" charset="-122"/>
+                <a:cs typeface="Cambria" pitchFamily="34" charset="-120"/>
               </a:rPr>
               <a:t>Hỏi  ·  Đọc  ·  Sửa  ·  Kiểm</a:t>
             </a:r>
-            <a:endParaRPr lang="en-US" sz="2600" dirty="0"/>
+            <a:endParaRPr lang="en-US" sz="2400" dirty="0"/>
           </a:p>
         </p:txBody>
       </p:sp>
@@ -5139,7 +5175,7 @@
             <a:r>
               <a:rPr lang="en-US" sz="1500" dirty="0">
                 <a:solidFill>
-                  <a:srgbClr val="FFFFFF"/>
+                  <a:srgbClr val="F7F5F0"/>
                 </a:solidFill>
                 <a:latin typeface="Arial" pitchFamily="34" charset="0"/>
                 <a:ea typeface="Arial" pitchFamily="34" charset="-122"/>
@@ -5165,7 +5201,7 @@
     <p:bg>
       <p:bgPr>
         <a:solidFill>
-          <a:srgbClr val="FFFFFF"/>
+          <a:srgbClr val="F7F5F0"/>
         </a:solidFill>
       </p:bgPr>
     </p:bg>
@@ -5221,7 +5257,7 @@
     <p:bg>
       <p:bgPr>
         <a:solidFill>
-          <a:srgbClr val="FFFFFF"/>
+          <a:srgbClr val="F7F5F0"/>
         </a:solidFill>
       </p:bgPr>
     </p:bg>
@@ -5277,7 +5313,7 @@
     <p:bg>
       <p:bgPr>
         <a:solidFill>
-          <a:srgbClr val="FFFFFF"/>
+          <a:srgbClr val="F7F5F0"/>
         </a:solidFill>
       </p:bgPr>
     </p:bg>
@@ -5333,7 +5369,7 @@
     <p:bg>
       <p:bgPr>
         <a:solidFill>
-          <a:srgbClr val="F2B134"/>
+          <a:srgbClr val="F7F5F0"/>
         </a:solidFill>
       </p:bgPr>
     </p:bg>
@@ -5359,16 +5395,21 @@
         </p:nvSpPr>
         <p:spPr>
           <a:xfrm>
-            <a:off x="6309360" y="1005840"/>
-            <a:ext cx="3108960" cy="3108960"/>
+            <a:off x="6035040" y="1005840"/>
+            <a:ext cx="2926080" cy="2926080"/>
           </a:xfrm>
           <a:prstGeom prst="ellipse">
             <a:avLst/>
           </a:prstGeom>
           <a:solidFill>
-            <a:srgbClr val="1F4E47"/>
+            <a:srgbClr val="F7F5F0"/>
           </a:solidFill>
-          <a:ln/>
+          <a:ln w="12700">
+            <a:solidFill>
+              <a:srgbClr val="A67C3D"/>
+            </a:solidFill>
+            <a:prstDash val="solid"/>
+          </a:ln>
         </p:spPr>
       </p:sp>
       <p:sp>
@@ -5379,8 +5420,8 @@
         </p:nvSpPr>
         <p:spPr>
           <a:xfrm>
-            <a:off x="6309360" y="1005840"/>
-            <a:ext cx="3108960" cy="3108960"/>
+            <a:off x="6035040" y="1005840"/>
+            <a:ext cx="2926080" cy="2926080"/>
           </a:xfrm>
           <a:prstGeom prst="rect">
             <a:avLst/>
@@ -5396,17 +5437,17 @@
               <a:buNone/>
             </a:pPr>
             <a:r>
-              <a:rPr lang="en-US" sz="12000" b="1" dirty="0">
+              <a:rPr lang="en-US" sz="11000" i="1" dirty="0">
                 <a:solidFill>
-                  <a:srgbClr val="F2B134"/>
+                  <a:srgbClr val="A67C3D"/>
                 </a:solidFill>
-                <a:latin typeface="Arial" pitchFamily="34" charset="0"/>
-                <a:ea typeface="Arial" pitchFamily="34" charset="-122"/>
-                <a:cs typeface="Arial" pitchFamily="34" charset="-120"/>
+                <a:latin typeface="Cambria" pitchFamily="34" charset="0"/>
+                <a:ea typeface="Cambria" pitchFamily="34" charset="-122"/>
+                <a:cs typeface="Cambria" pitchFamily="34" charset="-120"/>
               </a:rPr>
               <a:t>1</a:t>
             </a:r>
-            <a:endParaRPr lang="en-US" sz="12000" dirty="0"/>
+            <a:endParaRPr lang="en-US" sz="11000" dirty="0"/>
           </a:p>
         </p:txBody>
       </p:sp>
@@ -5435,9 +5476,9 @@
               <a:buNone/>
             </a:pPr>
             <a:r>
-              <a:rPr lang="en-US" sz="1600" b="1" spc="400" kern="0" dirty="0">
+              <a:rPr lang="en-US" sz="1200" spc="800" kern="0" dirty="0">
                 <a:solidFill>
-                  <a:srgbClr val="1F4E47"/>
+                  <a:srgbClr val="A67C3D"/>
                 </a:solidFill>
                 <a:latin typeface="Arial" pitchFamily="34" charset="0"/>
                 <a:ea typeface="Arial" pitchFamily="34" charset="-122"/>
@@ -5445,7 +5486,7 @@
               </a:rPr>
               <a:t>BUỔI 1</a:t>
             </a:r>
-            <a:endParaRPr lang="en-US" sz="1600" dirty="0"/>
+            <a:endParaRPr lang="en-US" sz="1200" dirty="0"/>
           </a:p>
         </p:txBody>
       </p:sp>
@@ -5458,7 +5499,7 @@
         <p:spPr>
           <a:xfrm>
             <a:off x="548640" y="1645920"/>
-            <a:ext cx="5486400" cy="1463040"/>
+            <a:ext cx="5303520" cy="1463040"/>
           </a:xfrm>
           <a:prstGeom prst="rect">
             <a:avLst/>
@@ -5474,17 +5515,17 @@
               <a:buNone/>
             </a:pPr>
             <a:r>
-              <a:rPr lang="en-US" sz="4000" b="1" dirty="0">
+              <a:rPr lang="en-US" sz="3800" dirty="0">
                 <a:solidFill>
-                  <a:srgbClr val="1F4E47"/>
+                  <a:srgbClr val="1B1F24"/>
                 </a:solidFill>
-                <a:latin typeface="Arial" pitchFamily="34" charset="0"/>
-                <a:ea typeface="Arial" pitchFamily="34" charset="-122"/>
-                <a:cs typeface="Arial" pitchFamily="34" charset="-120"/>
+                <a:latin typeface="Cambria" pitchFamily="34" charset="0"/>
+                <a:ea typeface="Cambria" pitchFamily="34" charset="-122"/>
+                <a:cs typeface="Cambria" pitchFamily="34" charset="-120"/>
               </a:rPr>
               <a:t>Kỹ thuật viết câu lệnh</a:t>
             </a:r>
-            <a:endParaRPr lang="en-US" sz="4000" dirty="0"/>
+            <a:endParaRPr lang="en-US" sz="3800" dirty="0"/>
           </a:p>
         </p:txBody>
       </p:sp>
@@ -5496,8 +5537,8 @@
         </p:nvSpPr>
         <p:spPr>
           <a:xfrm>
-            <a:off x="548640" y="3200400"/>
-            <a:ext cx="5303520" cy="914400"/>
+            <a:off x="548640" y="3291840"/>
+            <a:ext cx="5120640" cy="914400"/>
           </a:xfrm>
           <a:prstGeom prst="rect">
             <a:avLst/>
@@ -5513,9 +5554,9 @@
               <a:buNone/>
             </a:pPr>
             <a:r>
-              <a:rPr lang="en-US" sz="1600" dirty="0">
+              <a:rPr lang="en-US" sz="1300" dirty="0">
                 <a:solidFill>
-                  <a:srgbClr val="1F4E47"/>
+                  <a:srgbClr val="1B1F24"/>
                 </a:solidFill>
                 <a:latin typeface="Arial" pitchFamily="34" charset="0"/>
                 <a:ea typeface="Arial" pitchFamily="34" charset="-122"/>
@@ -5523,7 +5564,7 @@
               </a:rPr>
               <a:t>Zero-shot · Nhập vai · Đảo ngược · Kết hợp nhiều yếu tố · TPACK</a:t>
             </a:r>
-            <a:endParaRPr lang="en-US" sz="1600" dirty="0"/>
+            <a:endParaRPr lang="en-US" sz="1300" dirty="0"/>
           </a:p>
         </p:txBody>
       </p:sp>
@@ -5541,7 +5582,7 @@
     <p:bg>
       <p:bgPr>
         <a:solidFill>
-          <a:srgbClr val="FFFFFF"/>
+          <a:srgbClr val="F7F5F0"/>
         </a:solidFill>
       </p:bgPr>
     </p:bg>
@@ -5597,7 +5638,7 @@
     <p:bg>
       <p:bgPr>
         <a:solidFill>
-          <a:srgbClr val="FFFFFF"/>
+          <a:srgbClr val="F7F5F0"/>
         </a:solidFill>
       </p:bgPr>
     </p:bg>
@@ -5653,7 +5694,7 @@
     <p:bg>
       <p:bgPr>
         <a:solidFill>
-          <a:srgbClr val="FFFFFF"/>
+          <a:srgbClr val="F7F5F0"/>
         </a:solidFill>
       </p:bgPr>
     </p:bg>

</xml_diff>

<commit_message>
Bản final: căn cứ văn bản 2025-2030, ảnh bán hàng dựng từ trang thật, giá 220.000đ
Co-Authored-By: Claude Opus 5.5 <noreply@anthropic.com>
Claude-Session: https://claude.ai/code/session_016W4H5FXW9gSiS33Aau8aSB
</commit_message>
<xml_diff>
--- a/02-Slide/Day-cung-AI-Gioi-thieu.pptx
+++ b/02-Slide/Day-cung-AI-Gioi-thieu.pptx
@@ -28,9 +28,10 @@
     <p:sldId id="276" r:id="rId22"/>
     <p:sldId id="277" r:id="rId23"/>
     <p:sldId id="278" r:id="rId24"/>
+    <p:sldId id="279" r:id="rId25"/>
   </p:sldIdLst>
   <p:notesMasterIdLst>
-    <p:notesMasterId r:id="rId25"/>
+    <p:notesMasterId r:id="rId26"/>
   </p:notesMasterIdLst>
   <p:sldSz cx="9144000" cy="5143500"/>
   <p:notesSz cx="5143500" cy="9144000"/>
@@ -612,7 +613,7 @@
           <a:p>
             <a:r>
               <a:rPr lang="en-US" dirty="0"/>
-              <a:t>Phần C trong sách, bài C1 đến C9.</a:t>
+              <a:t>TPACK: điền đủ 3 dòng CK, PK, TK trong câu lệnh. Sách bài B7.</a:t>
             </a:r>
             <a:endParaRPr lang="en-US" dirty="0"/>
           </a:p>
@@ -700,7 +701,7 @@
           <a:p>
             <a:r>
               <a:rPr lang="en-US" dirty="0"/>
-              <a:t>Câu lệnh dài chia 4 ngăn có tiêu đề #. Dấu ## đặt tên cho từng tài liệu đính kèm. Sách bài C5.</a:t>
+              <a:t>Phần C trong sách, bài C1 đến C9.</a:t>
             </a:r>
             <a:endParaRPr lang="en-US" dirty="0"/>
           </a:p>
@@ -788,7 +789,7 @@
           <a:p>
             <a:r>
               <a:rPr lang="en-US" dirty="0"/>
-              <a:t>Dán nguyên văn định nghĩa 4 mức độ nhận thức vào câu lệnh để AI phân loại câu hỏi đúng. Sách bài C6.</a:t>
+              <a:t>Câu lệnh dài chia 4 ngăn có tiêu đề #. Dấu ## đặt tên cho từng tài liệu đính kèm. Sách bài C5.</a:t>
             </a:r>
             <a:endParaRPr lang="en-US" dirty="0"/>
           </a:p>
@@ -876,7 +877,7 @@
           <a:p>
             <a:r>
               <a:rPr lang="en-US" dirty="0"/>
-              <a:t>AI kẻ sẵn bảng tiêu chí 4 mức, giáo viên duyệt. Sách bài C7.</a:t>
+              <a:t>Dán nguyên văn định nghĩa 4 mức độ nhận thức vào câu lệnh để AI phân loại câu hỏi đúng. Sách bài C6.</a:t>
             </a:r>
             <a:endParaRPr lang="en-US" dirty="0"/>
           </a:p>
@@ -964,7 +965,7 @@
           <a:p>
             <a:r>
               <a:rPr lang="en-US" dirty="0"/>
-              <a:t>Phần D trong sách, bài D1 đến D8.</a:t>
+              <a:t>AI kẻ sẵn bảng tiêu chí 4 mức, giáo viên duyệt. Sách bài C7.</a:t>
             </a:r>
             <a:endParaRPr lang="en-US" dirty="0"/>
           </a:p>
@@ -1052,7 +1053,7 @@
           <a:p>
             <a:r>
               <a:rPr lang="en-US" dirty="0"/>
-              <a:t>Chọn công cụ theo sản phẩm. Tên nút có thể thay đổi, hướng dẫn học viên tìm theo chức năng.</a:t>
+              <a:t>Phần D trong sách, bài D1 đến D8.</a:t>
             </a:r>
             <a:endParaRPr lang="en-US" dirty="0"/>
           </a:p>
@@ -1140,7 +1141,7 @@
           <a:p>
             <a:r>
               <a:rPr lang="en-US" dirty="0"/>
-              <a:t>Công thức tạo ảnh: Nội dung + Phong cách. Thử cùng một nội dung với Pixar, Anime, Ghibli. Sách bài D1, D2.</a:t>
+              <a:t>Chọn công cụ theo sản phẩm. Tên nút có thể thay đổi, hướng dẫn học viên tìm theo chức năng.</a:t>
             </a:r>
             <a:endParaRPr lang="en-US" dirty="0"/>
           </a:p>
@@ -1228,7 +1229,7 @@
           <a:p>
             <a:r>
               <a:rPr lang="en-US" dirty="0"/>
-              <a:t>Phần E trong sách, bài E1 đến E6.</a:t>
+              <a:t>Công thức tạo ảnh: Nội dung + Phong cách. Thử cùng một nội dung với Pixar, Anime, Ghibli. Sách bài D1, D2.</a:t>
             </a:r>
             <a:endParaRPr lang="en-US" dirty="0"/>
           </a:p>
@@ -1316,7 +1317,7 @@
           <a:p>
             <a:r>
               <a:rPr lang="en-US" dirty="0"/>
-              <a:t>Deep Research: giao đề bài, duyệt kế hoạch, chờ báo cáo, tự mở từng link để kiểm chứng. Sách bài E1, E2.</a:t>
+              <a:t>Phần E trong sách, bài E1 đến E6.</a:t>
             </a:r>
             <a:endParaRPr lang="en-US" dirty="0"/>
           </a:p>
@@ -1404,7 +1405,7 @@
           <a:p>
             <a:r>
               <a:rPr lang="en-US" dirty="0"/>
-              <a:t>Tạo trợ giảng ảo 4 bước. Câu quan trọng nhất: không đưa ra ngay đáp án. Sách bài E4, E5.</a:t>
+              <a:t>Deep Research: giao đề bài, duyệt kế hoạch, chờ báo cáo, tự mở từng link để kiểm chứng. Sách bài E1, E2.</a:t>
             </a:r>
             <a:endParaRPr lang="en-US" dirty="0"/>
           </a:p>
@@ -1580,7 +1581,7 @@
           <a:p>
             <a:r>
               <a:rPr lang="en-US" dirty="0"/>
-              <a:t>Khung năng lực AI cho giáo viên của UNESCO: 5 lĩnh vực, 3 cấp độ. Sách phần F1.</a:t>
+              <a:t>Tạo trợ giảng ảo 4 bước. Câu quan trọng nhất: không đưa ra ngay đáp án. Sách bài E4, E5.</a:t>
             </a:r>
             <a:endParaRPr lang="en-US" dirty="0"/>
           </a:p>
@@ -1668,7 +1669,7 @@
           <a:p>
             <a:r>
               <a:rPr lang="en-US" dirty="0"/>
-              <a:t>Ba màu đèn trước khi dán thông tin vào AI. Nhấn mạnh: không đưa thông tin cá nhân học sinh. Sách phần F2.</a:t>
+              <a:t>Khung năng lực AI cho giáo viên của UNESCO: 5 lĩnh vực, 3 cấp độ. Sách phần F1.</a:t>
             </a:r>
             <a:endParaRPr lang="en-US" dirty="0"/>
           </a:p>
@@ -1756,7 +1757,7 @@
           <a:p>
             <a:r>
               <a:rPr lang="en-US" dirty="0"/>
-              <a:t>Gợi ý bắt đầu theo cấp học. Bảng tra đầy đủ ở Phụ lục P1 của sách.</a:t>
+              <a:t>Ba màu đèn trước khi dán thông tin vào AI. Nhấn mạnh: không đưa thông tin cá nhân học sinh. Sách phần F2.</a:t>
             </a:r>
             <a:endParaRPr lang="en-US" dirty="0"/>
           </a:p>
@@ -1844,6 +1845,94 @@
           <a:p>
             <a:r>
               <a:rPr lang="en-US" dirty="0"/>
+              <a:t>Gợi ý bắt đầu theo cấp học. Bảng tra đầy đủ ở Phụ lục P1 của sách.</a:t>
+            </a:r>
+            <a:endParaRPr lang="en-US" dirty="0"/>
+          </a:p>
+        </p:txBody>
+      </p:sp>
+      <p:sp>
+        <p:nvSpPr>
+          <p:cNvPr id="4" name="Slide Number Placeholder 3"/>
+          <p:cNvSpPr>
+            <a:spLocks noGrp="1"/>
+          </p:cNvSpPr>
+          <p:nvPr>
+            <p:ph type="sldNum" sz="quarter" idx="10"/>
+          </p:nvPr>
+        </p:nvSpPr>
+        <p:spPr/>
+        <p:txBody>
+          <a:bodyPr/>
+          <a:lstStyle/>
+          <a:p>
+            <a:fld id="{F7021451-1387-4CA6-816F-3879F97B5CBC}" type="slidenum">
+              <a:rPr lang="en-US"/>
+              <a:t>23</a:t>
+            </a:fld>
+            <a:endParaRPr lang="en-US"/>
+          </a:p>
+        </p:txBody>
+      </p:sp>
+    </p:spTree>
+    <p:extLst>
+      <p:ext uri="{BB962C8B-B14F-4D97-AF65-F5344CB8AC3E}">
+        <p14:creationId xmlns:p14="http://schemas.microsoft.com/office/powerpoint/2010/main" val="1024086991"/>
+      </p:ext>
+    </p:extLst>
+  </p:cSld>
+  <p:clrMapOvr>
+    <a:masterClrMapping/>
+  </p:clrMapOvr>
+</p:notes>
+</file>
+
+<file path=ppt/notesSlides/notesSlide24.xml><?xml version="1.0" encoding="utf-8"?>
+<p:notes xmlns:a="http://schemas.openxmlformats.org/drawingml/2006/main" xmlns:r="http://schemas.openxmlformats.org/officeDocument/2006/relationships" xmlns:p="http://schemas.openxmlformats.org/presentationml/2006/main">
+  <p:cSld>
+    <p:spTree>
+      <p:nvGrpSpPr>
+        <p:cNvPr id="1" name=""/>
+        <p:cNvGrpSpPr/>
+        <p:nvPr/>
+      </p:nvGrpSpPr>
+      <p:grpSpPr>
+        <a:xfrm>
+          <a:off x="0" y="0"/>
+          <a:ext cx="0" cy="0"/>
+          <a:chOff x="0" y="0"/>
+          <a:chExt cx="0" cy="0"/>
+        </a:xfrm>
+      </p:grpSpPr>
+      <p:sp>
+        <p:nvSpPr>
+          <p:cNvPr id="2" name="Slide Image Placeholder 1"/>
+          <p:cNvSpPr>
+            <a:spLocks noGrp="1" noRot="1" noChangeAspect="1"/>
+          </p:cNvSpPr>
+          <p:nvPr>
+            <p:ph type="sldImg"/>
+          </p:nvPr>
+        </p:nvSpPr>
+        <p:spPr/>
+      </p:sp>
+      <p:sp>
+        <p:nvSpPr>
+          <p:cNvPr id="3" name="Notes Placeholder 2"/>
+          <p:cNvSpPr>
+            <a:spLocks noGrp="1"/>
+          </p:cNvSpPr>
+          <p:nvPr>
+            <p:ph type="body" idx="1"/>
+          </p:nvPr>
+        </p:nvSpPr>
+        <p:spPr/>
+        <p:txBody>
+          <a:bodyPr/>
+          <a:lstStyle/>
+          <a:p>
+            <a:r>
+              <a:rPr lang="en-US" dirty="0"/>
               <a:t>Kết thúc: giao bài tập về nhà là chạy 1 câu lệnh cho bài dạy tuần này và mang kết quả đến buổi sau.</a:t>
             </a:r>
             <a:endParaRPr lang="en-US" dirty="0"/>
@@ -1867,7 +1956,7 @@
           <a:p>
             <a:fld id="{F7021451-1387-4CA6-816F-3879F97B5CBC}" type="slidenum">
               <a:rPr lang="en-US"/>
-              <a:t>23</a:t>
+              <a:t>24</a:t>
             </a:fld>
             <a:endParaRPr lang="en-US"/>
           </a:p>
@@ -1932,7 +2021,7 @@
           <a:p>
             <a:r>
               <a:rPr lang="en-US" dirty="0"/>
-              <a:t>Vòng làm việc Hỏi, Đọc, Sửa, Kiểm. Nhấn mạnh bước Kiểm: AI có thể bịa số liệu và nguồn. Sách phần A1.</a:t>
+              <a:t>Nhấn mạnh: bộ tài liệu được đối chiếu với văn bản pháp luật và hướng dẫn chuyên môn hiện hành. Sách là tài liệu tham khảo, không thay thế văn bản gốc.</a:t>
             </a:r>
             <a:endParaRPr lang="en-US" dirty="0"/>
           </a:p>
@@ -2020,7 +2109,7 @@
           <a:p>
             <a:r>
               <a:rPr lang="en-US" dirty="0"/>
-              <a:t>Sáu vị trí cần biết trên màn hình trò chuyện với AI. Cho học viên mở chatgpt.com hoặc gemini.google.com và tìm đủ 6 vị trí. Sách phần A2.</a:t>
+              <a:t>Vòng làm việc Hỏi, Đọc, Sửa, Kiểm. Nhấn mạnh bước Kiểm: AI có thể bịa số liệu và nguồn. Sách phần A1.</a:t>
             </a:r>
             <a:endParaRPr lang="en-US" dirty="0"/>
           </a:p>
@@ -2108,7 +2197,7 @@
           <a:p>
             <a:r>
               <a:rPr lang="en-US" dirty="0"/>
-              <a:t>Sáu mảnh ghép của câu lệnh tốt, tách từ câu lệnh mẫu về quang hợp. Sách phần A3.</a:t>
+              <a:t>Sáu vị trí cần biết trên màn hình trò chuyện với AI. Cho học viên mở chatgpt.com hoặc gemini.google.com và tìm đủ 6 vị trí. Sách phần A2.</a:t>
             </a:r>
             <a:endParaRPr lang="en-US" dirty="0"/>
           </a:p>
@@ -2196,7 +2285,7 @@
           <a:p>
             <a:r>
               <a:rPr lang="en-US" dirty="0"/>
-              <a:t>Phần B trong sách, bài B1 đến B7.</a:t>
+              <a:t>Sáu mảnh ghép của câu lệnh tốt, tách từ câu lệnh mẫu về quang hợp. Sách phần A3.</a:t>
             </a:r>
             <a:endParaRPr lang="en-US" dirty="0"/>
           </a:p>
@@ -2284,7 +2373,7 @@
           <a:p>
             <a:r>
               <a:rPr lang="en-US" dirty="0"/>
-              <a:t>Bốn kỹ thuật từ dễ đến đủ. Cho học viên thử lần lượt 4 câu lệnh gốc trên cùng một chủ đề của lớp mình.</a:t>
+              <a:t>Phần B trong sách, bài B1 đến B7.</a:t>
             </a:r>
             <a:endParaRPr lang="en-US" dirty="0"/>
           </a:p>
@@ -2372,7 +2461,7 @@
           <a:p>
             <a:r>
               <a:rPr lang="en-US" dirty="0"/>
-              <a:t>Đánh giá prompt: đối chiếu 6 mảnh ghép, thiếu gì thêm nấy. Các cụm tô vàng là mảnh ghép được bổ sung. Sách bài B5.</a:t>
+              <a:t>Bốn kỹ thuật từ dễ đến đủ. Cho học viên thử lần lượt 4 câu lệnh gốc trên cùng một chủ đề của lớp mình.</a:t>
             </a:r>
             <a:endParaRPr lang="en-US" dirty="0"/>
           </a:p>
@@ -2460,7 +2549,7 @@
           <a:p>
             <a:r>
               <a:rPr lang="en-US" dirty="0"/>
-              <a:t>TPACK: điền đủ 3 dòng CK, PK, TK trong câu lệnh. Sách bài B7.</a:t>
+              <a:t>Đánh giá prompt: đối chiếu 6 mảnh ghép, thiếu gì thêm nấy. Các cụm tô vàng là mảnh ghép được bổ sung. Sách bài B5.</a:t>
             </a:r>
             <a:endParaRPr lang="en-US" dirty="0"/>
           </a:p>
@@ -3060,6 +3149,62 @@
           <a:chExt cx="0" cy="0"/>
         </a:xfrm>
       </p:grpSpPr>
+      <p:pic>
+        <p:nvPicPr>
+          <p:cNvPr id="2" name="Image 0" descr="TPACK: điền đủ 3 dòng CK, PK, TK trong câu lệnh">    </p:cNvPr>
+          <p:cNvPicPr>
+            <a:picLocks noChangeAspect="1"/>
+          </p:cNvPicPr>
+          <p:nvPr/>
+        </p:nvPicPr>
+        <p:blipFill>
+          <a:blip r:embed="rId1"/>
+          <a:stretch>
+            <a:fillRect/>
+          </a:stretch>
+        </p:blipFill>
+        <p:spPr>
+          <a:xfrm>
+            <a:off x="0" y="0"/>
+            <a:ext cx="9144000" cy="5143500"/>
+          </a:xfrm>
+          <a:prstGeom prst="rect">
+            <a:avLst/>
+          </a:prstGeom>
+        </p:spPr>
+      </p:pic>
+    </p:spTree>
+  </p:cSld>
+  <p:clrMapOvr>
+    <a:masterClrMapping/>
+  </p:clrMapOvr>
+</p:sld>
+</file>
+
+<file path=ppt/slides/slide11.xml><?xml version="1.0" encoding="utf-8"?>
+<p:sld xmlns:a="http://schemas.openxmlformats.org/drawingml/2006/main" xmlns:r="http://schemas.openxmlformats.org/officeDocument/2006/relationships" xmlns:p="http://schemas.openxmlformats.org/presentationml/2006/main">
+  <p:cSld name="Slide 11">
+    <p:bg>
+      <p:bgPr>
+        <a:solidFill>
+          <a:srgbClr val="F7F5F0"/>
+        </a:solidFill>
+      </p:bgPr>
+    </p:bg>
+    <p:spTree>
+      <p:nvGrpSpPr>
+        <p:cNvPr id="1" name=""/>
+        <p:cNvGrpSpPr/>
+        <p:nvPr/>
+      </p:nvGrpSpPr>
+      <p:grpSpPr>
+        <a:xfrm>
+          <a:off x="0" y="0"/>
+          <a:ext cx="0" cy="0"/>
+          <a:chOff x="0" y="0"/>
+          <a:chExt cx="0" cy="0"/>
+        </a:xfrm>
+      </p:grpSpPr>
       <p:sp>
         <p:nvSpPr>
           <p:cNvPr id="2" name="Shape 0"/>
@@ -3249,9 +3394,9 @@
 </p:sld>
 </file>
 
-<file path=ppt/slides/slide11.xml><?xml version="1.0" encoding="utf-8"?>
+<file path=ppt/slides/slide12.xml><?xml version="1.0" encoding="utf-8"?>
 <p:sld xmlns:a="http://schemas.openxmlformats.org/drawingml/2006/main" xmlns:r="http://schemas.openxmlformats.org/officeDocument/2006/relationships" xmlns:p="http://schemas.openxmlformats.org/presentationml/2006/main">
-  <p:cSld name="Slide 11">
+  <p:cSld name="Slide 12">
     <p:bg>
       <p:bgPr>
         <a:solidFill>
@@ -3305,9 +3450,9 @@
 </p:sld>
 </file>
 
-<file path=ppt/slides/slide12.xml><?xml version="1.0" encoding="utf-8"?>
+<file path=ppt/slides/slide13.xml><?xml version="1.0" encoding="utf-8"?>
 <p:sld xmlns:a="http://schemas.openxmlformats.org/drawingml/2006/main" xmlns:r="http://schemas.openxmlformats.org/officeDocument/2006/relationships" xmlns:p="http://schemas.openxmlformats.org/presentationml/2006/main">
-  <p:cSld name="Slide 12">
+  <p:cSld name="Slide 13">
     <p:bg>
       <p:bgPr>
         <a:solidFill>
@@ -3361,9 +3506,9 @@
 </p:sld>
 </file>
 
-<file path=ppt/slides/slide13.xml><?xml version="1.0" encoding="utf-8"?>
+<file path=ppt/slides/slide14.xml><?xml version="1.0" encoding="utf-8"?>
 <p:sld xmlns:a="http://schemas.openxmlformats.org/drawingml/2006/main" xmlns:r="http://schemas.openxmlformats.org/officeDocument/2006/relationships" xmlns:p="http://schemas.openxmlformats.org/presentationml/2006/main">
-  <p:cSld name="Slide 13">
+  <p:cSld name="Slide 14">
     <p:bg>
       <p:bgPr>
         <a:solidFill>
@@ -3417,9 +3562,9 @@
 </p:sld>
 </file>
 
-<file path=ppt/slides/slide14.xml><?xml version="1.0" encoding="utf-8"?>
+<file path=ppt/slides/slide15.xml><?xml version="1.0" encoding="utf-8"?>
 <p:sld xmlns:a="http://schemas.openxmlformats.org/drawingml/2006/main" xmlns:r="http://schemas.openxmlformats.org/officeDocument/2006/relationships" xmlns:p="http://schemas.openxmlformats.org/presentationml/2006/main">
-  <p:cSld name="Slide 14">
+  <p:cSld name="Slide 15">
     <p:bg>
       <p:bgPr>
         <a:solidFill>
@@ -3630,9 +3775,9 @@
 </p:sld>
 </file>
 
-<file path=ppt/slides/slide15.xml><?xml version="1.0" encoding="utf-8"?>
+<file path=ppt/slides/slide16.xml><?xml version="1.0" encoding="utf-8"?>
 <p:sld xmlns:a="http://schemas.openxmlformats.org/drawingml/2006/main" xmlns:r="http://schemas.openxmlformats.org/officeDocument/2006/relationships" xmlns:p="http://schemas.openxmlformats.org/presentationml/2006/main">
-  <p:cSld name="Slide 15">
+  <p:cSld name="Slide 16">
     <p:bg>
       <p:bgPr>
         <a:solidFill>
@@ -3686,9 +3831,9 @@
 </p:sld>
 </file>
 
-<file path=ppt/slides/slide16.xml><?xml version="1.0" encoding="utf-8"?>
+<file path=ppt/slides/slide17.xml><?xml version="1.0" encoding="utf-8"?>
 <p:sld xmlns:a="http://schemas.openxmlformats.org/drawingml/2006/main" xmlns:r="http://schemas.openxmlformats.org/officeDocument/2006/relationships" xmlns:p="http://schemas.openxmlformats.org/presentationml/2006/main">
-  <p:cSld name="Slide 16">
+  <p:cSld name="Slide 17">
     <p:bg>
       <p:bgPr>
         <a:solidFill>
@@ -3742,9 +3887,9 @@
 </p:sld>
 </file>
 
-<file path=ppt/slides/slide17.xml><?xml version="1.0" encoding="utf-8"?>
+<file path=ppt/slides/slide18.xml><?xml version="1.0" encoding="utf-8"?>
 <p:sld xmlns:a="http://schemas.openxmlformats.org/drawingml/2006/main" xmlns:r="http://schemas.openxmlformats.org/officeDocument/2006/relationships" xmlns:p="http://schemas.openxmlformats.org/presentationml/2006/main">
-  <p:cSld name="Slide 17">
+  <p:cSld name="Slide 18">
     <p:bg>
       <p:bgPr>
         <a:solidFill>
@@ -3955,9 +4100,9 @@
 </p:sld>
 </file>
 
-<file path=ppt/slides/slide18.xml><?xml version="1.0" encoding="utf-8"?>
+<file path=ppt/slides/slide19.xml><?xml version="1.0" encoding="utf-8"?>
 <p:sld xmlns:a="http://schemas.openxmlformats.org/drawingml/2006/main" xmlns:r="http://schemas.openxmlformats.org/officeDocument/2006/relationships" xmlns:p="http://schemas.openxmlformats.org/presentationml/2006/main">
-  <p:cSld name="Slide 18">
+  <p:cSld name="Slide 19">
     <p:bg>
       <p:bgPr>
         <a:solidFill>
@@ -4011,9 +4156,756 @@
 </p:sld>
 </file>
 
-<file path=ppt/slides/slide19.xml><?xml version="1.0" encoding="utf-8"?>
+<file path=ppt/slides/slide2.xml><?xml version="1.0" encoding="utf-8"?>
 <p:sld xmlns:a="http://schemas.openxmlformats.org/drawingml/2006/main" xmlns:r="http://schemas.openxmlformats.org/officeDocument/2006/relationships" xmlns:p="http://schemas.openxmlformats.org/presentationml/2006/main">
-  <p:cSld name="Slide 19">
+  <p:cSld name="Slide 2">
+    <p:bg>
+      <p:bgPr>
+        <a:solidFill>
+          <a:srgbClr val="F7F5F0"/>
+        </a:solidFill>
+      </p:bgPr>
+    </p:bg>
+    <p:spTree>
+      <p:nvGrpSpPr>
+        <p:cNvPr id="1" name=""/>
+        <p:cNvGrpSpPr/>
+        <p:nvPr/>
+      </p:nvGrpSpPr>
+      <p:grpSpPr>
+        <a:xfrm>
+          <a:off x="0" y="0"/>
+          <a:ext cx="0" cy="0"/>
+          <a:chOff x="0" y="0"/>
+          <a:chExt cx="0" cy="0"/>
+        </a:xfrm>
+      </p:grpSpPr>
+      <p:sp>
+        <p:nvSpPr>
+          <p:cNvPr id="2" name="Text 0"/>
+          <p:cNvSpPr txBox="1"/>
+          <p:nvPr/>
+        </p:nvSpPr>
+        <p:spPr>
+          <a:xfrm>
+            <a:off x="548640" y="457200"/>
+            <a:ext cx="8046720" cy="640080"/>
+          </a:xfrm>
+          <a:prstGeom prst="rect">
+            <a:avLst/>
+          </a:prstGeom>
+          <a:noFill/>
+          <a:ln/>
+        </p:spPr>
+        <p:txBody>
+          <a:bodyPr wrap="square" lIns="0" tIns="0" rIns="0" bIns="0" rtlCol="0" anchor="ctr"/>
+          <a:lstStyle/>
+          <a:p>
+            <a:pPr indent="0" marL="0">
+              <a:buNone/>
+            </a:pPr>
+            <a:r>
+              <a:rPr lang="en-US" sz="3000" dirty="0">
+                <a:solidFill>
+                  <a:srgbClr val="1B1F24"/>
+                </a:solidFill>
+                <a:latin typeface="Cambria" pitchFamily="34" charset="0"/>
+                <a:ea typeface="Cambria" pitchFamily="34" charset="-122"/>
+                <a:cs typeface="Cambria" pitchFamily="34" charset="-120"/>
+              </a:rPr>
+              <a:t>Sau cuốn sách, thầy cô tự làm được</a:t>
+            </a:r>
+            <a:endParaRPr lang="en-US" sz="3000" dirty="0"/>
+          </a:p>
+        </p:txBody>
+      </p:sp>
+      <p:sp>
+        <p:nvSpPr>
+          <p:cNvPr id="3" name="Shape 1"/>
+          <p:cNvSpPr/>
+          <p:nvPr/>
+        </p:nvSpPr>
+        <p:spPr>
+          <a:xfrm>
+            <a:off x="548640" y="1371600"/>
+            <a:ext cx="1874520" cy="3108960"/>
+          </a:xfrm>
+          <a:prstGeom prst="roundRect">
+            <a:avLst>
+              <a:gd name="adj" fmla="val 1463"/>
+            </a:avLst>
+          </a:prstGeom>
+          <a:solidFill>
+            <a:srgbClr val="F7F5F0"/>
+          </a:solidFill>
+          <a:ln w="9525">
+            <a:solidFill>
+              <a:srgbClr val="CFCAC0"/>
+            </a:solidFill>
+            <a:prstDash val="solid"/>
+          </a:ln>
+        </p:spPr>
+      </p:sp>
+      <p:sp>
+        <p:nvSpPr>
+          <p:cNvPr id="4" name="Shape 2"/>
+          <p:cNvSpPr/>
+          <p:nvPr/>
+        </p:nvSpPr>
+        <p:spPr>
+          <a:xfrm>
+            <a:off x="777240" y="1600200"/>
+            <a:ext cx="548640" cy="548640"/>
+          </a:xfrm>
+          <a:prstGeom prst="ellipse">
+            <a:avLst/>
+          </a:prstGeom>
+          <a:solidFill>
+            <a:srgbClr val="F7F5F0"/>
+          </a:solidFill>
+          <a:ln w="9525">
+            <a:solidFill>
+              <a:srgbClr val="A67C3D"/>
+            </a:solidFill>
+            <a:prstDash val="solid"/>
+          </a:ln>
+        </p:spPr>
+      </p:sp>
+      <p:sp>
+        <p:nvSpPr>
+          <p:cNvPr id="5" name="Text 3"/>
+          <p:cNvSpPr txBox="1"/>
+          <p:nvPr/>
+        </p:nvSpPr>
+        <p:spPr>
+          <a:xfrm>
+            <a:off x="777240" y="1600200"/>
+            <a:ext cx="548640" cy="548640"/>
+          </a:xfrm>
+          <a:prstGeom prst="rect">
+            <a:avLst/>
+          </a:prstGeom>
+          <a:noFill/>
+          <a:ln/>
+        </p:spPr>
+        <p:txBody>
+          <a:bodyPr wrap="square" lIns="0" tIns="0" rIns="0" bIns="0" rtlCol="0" anchor="ctr"/>
+          <a:lstStyle/>
+          <a:p>
+            <a:pPr algn="ctr" indent="0" marL="0">
+              <a:buNone/>
+            </a:pPr>
+            <a:r>
+              <a:rPr lang="en-US" sz="1800" dirty="0">
+                <a:solidFill>
+                  <a:srgbClr val="A67C3D"/>
+                </a:solidFill>
+                <a:latin typeface="Cambria" pitchFamily="34" charset="0"/>
+                <a:ea typeface="Cambria" pitchFamily="34" charset="-122"/>
+                <a:cs typeface="Cambria" pitchFamily="34" charset="-120"/>
+              </a:rPr>
+              <a:t>1</a:t>
+            </a:r>
+            <a:endParaRPr lang="en-US" sz="1800" dirty="0"/>
+          </a:p>
+        </p:txBody>
+      </p:sp>
+      <p:sp>
+        <p:nvSpPr>
+          <p:cNvPr id="6" name="Text 4"/>
+          <p:cNvSpPr txBox="1"/>
+          <p:nvPr/>
+        </p:nvSpPr>
+        <p:spPr>
+          <a:xfrm>
+            <a:off x="777240" y="2377440"/>
+            <a:ext cx="1554480" cy="731520"/>
+          </a:xfrm>
+          <a:prstGeom prst="rect">
+            <a:avLst/>
+          </a:prstGeom>
+          <a:noFill/>
+          <a:ln/>
+        </p:spPr>
+        <p:txBody>
+          <a:bodyPr wrap="square" lIns="0" tIns="0" rIns="0" bIns="0" rtlCol="0" anchor="t"/>
+          <a:lstStyle/>
+          <a:p>
+            <a:pPr indent="0" marL="0">
+              <a:buNone/>
+            </a:pPr>
+            <a:r>
+              <a:rPr lang="en-US" sz="1900" dirty="0">
+                <a:solidFill>
+                  <a:srgbClr val="1B1F24"/>
+                </a:solidFill>
+                <a:latin typeface="Cambria" pitchFamily="34" charset="0"/>
+                <a:ea typeface="Cambria" pitchFamily="34" charset="-122"/>
+                <a:cs typeface="Cambria" pitchFamily="34" charset="-120"/>
+              </a:rPr>
+              <a:t>Soạn bài</a:t>
+            </a:r>
+            <a:endParaRPr lang="en-US" sz="1900" dirty="0"/>
+          </a:p>
+        </p:txBody>
+      </p:sp>
+      <p:sp>
+        <p:nvSpPr>
+          <p:cNvPr id="7" name="Text 5"/>
+          <p:cNvSpPr txBox="1"/>
+          <p:nvPr/>
+        </p:nvSpPr>
+        <p:spPr>
+          <a:xfrm>
+            <a:off x="777240" y="3154680"/>
+            <a:ext cx="1508760" cy="1188720"/>
+          </a:xfrm>
+          <a:prstGeom prst="rect">
+            <a:avLst/>
+          </a:prstGeom>
+          <a:noFill/>
+          <a:ln/>
+        </p:spPr>
+        <p:txBody>
+          <a:bodyPr wrap="square" lIns="0" tIns="0" rIns="0" bIns="0" rtlCol="0" anchor="t"/>
+          <a:lstStyle/>
+          <a:p>
+            <a:pPr indent="0" marL="0">
+              <a:buNone/>
+            </a:pPr>
+            <a:r>
+              <a:rPr lang="en-US" sz="1300" dirty="0">
+                <a:solidFill>
+                  <a:srgbClr val="1B1F24"/>
+                </a:solidFill>
+                <a:latin typeface="Arial" pitchFamily="34" charset="0"/>
+                <a:ea typeface="Arial" pitchFamily="34" charset="-122"/>
+                <a:cs typeface="Arial" pitchFamily="34" charset="-120"/>
+              </a:rPr>
+              <a:t>Giáo án góc trạm, STEM, bài giảng 10 slide</a:t>
+            </a:r>
+            <a:endParaRPr lang="en-US" sz="1300" dirty="0"/>
+          </a:p>
+        </p:txBody>
+      </p:sp>
+      <p:sp>
+        <p:nvSpPr>
+          <p:cNvPr id="8" name="Shape 6"/>
+          <p:cNvSpPr/>
+          <p:nvPr/>
+        </p:nvSpPr>
+        <p:spPr>
+          <a:xfrm>
+            <a:off x="2606040" y="1371600"/>
+            <a:ext cx="1874520" cy="3108960"/>
+          </a:xfrm>
+          <a:prstGeom prst="roundRect">
+            <a:avLst>
+              <a:gd name="adj" fmla="val 1463"/>
+            </a:avLst>
+          </a:prstGeom>
+          <a:solidFill>
+            <a:srgbClr val="F7F5F0"/>
+          </a:solidFill>
+          <a:ln w="9525">
+            <a:solidFill>
+              <a:srgbClr val="CFCAC0"/>
+            </a:solidFill>
+            <a:prstDash val="solid"/>
+          </a:ln>
+        </p:spPr>
+      </p:sp>
+      <p:sp>
+        <p:nvSpPr>
+          <p:cNvPr id="9" name="Shape 7"/>
+          <p:cNvSpPr/>
+          <p:nvPr/>
+        </p:nvSpPr>
+        <p:spPr>
+          <a:xfrm>
+            <a:off x="2834640" y="1600200"/>
+            <a:ext cx="548640" cy="548640"/>
+          </a:xfrm>
+          <a:prstGeom prst="ellipse">
+            <a:avLst/>
+          </a:prstGeom>
+          <a:solidFill>
+            <a:srgbClr val="F7F5F0"/>
+          </a:solidFill>
+          <a:ln w="9525">
+            <a:solidFill>
+              <a:srgbClr val="A67C3D"/>
+            </a:solidFill>
+            <a:prstDash val="solid"/>
+          </a:ln>
+        </p:spPr>
+      </p:sp>
+      <p:sp>
+        <p:nvSpPr>
+          <p:cNvPr id="10" name="Text 8"/>
+          <p:cNvSpPr txBox="1"/>
+          <p:nvPr/>
+        </p:nvSpPr>
+        <p:spPr>
+          <a:xfrm>
+            <a:off x="2834640" y="1600200"/>
+            <a:ext cx="548640" cy="548640"/>
+          </a:xfrm>
+          <a:prstGeom prst="rect">
+            <a:avLst/>
+          </a:prstGeom>
+          <a:noFill/>
+          <a:ln/>
+        </p:spPr>
+        <p:txBody>
+          <a:bodyPr wrap="square" lIns="0" tIns="0" rIns="0" bIns="0" rtlCol="0" anchor="ctr"/>
+          <a:lstStyle/>
+          <a:p>
+            <a:pPr algn="ctr" indent="0" marL="0">
+              <a:buNone/>
+            </a:pPr>
+            <a:r>
+              <a:rPr lang="en-US" sz="1800" dirty="0">
+                <a:solidFill>
+                  <a:srgbClr val="A67C3D"/>
+                </a:solidFill>
+                <a:latin typeface="Cambria" pitchFamily="34" charset="0"/>
+                <a:ea typeface="Cambria" pitchFamily="34" charset="-122"/>
+                <a:cs typeface="Cambria" pitchFamily="34" charset="-120"/>
+              </a:rPr>
+              <a:t>2</a:t>
+            </a:r>
+            <a:endParaRPr lang="en-US" sz="1800" dirty="0"/>
+          </a:p>
+        </p:txBody>
+      </p:sp>
+      <p:sp>
+        <p:nvSpPr>
+          <p:cNvPr id="11" name="Text 9"/>
+          <p:cNvSpPr txBox="1"/>
+          <p:nvPr/>
+        </p:nvSpPr>
+        <p:spPr>
+          <a:xfrm>
+            <a:off x="2834640" y="2377440"/>
+            <a:ext cx="1554480" cy="731520"/>
+          </a:xfrm>
+          <a:prstGeom prst="rect">
+            <a:avLst/>
+          </a:prstGeom>
+          <a:noFill/>
+          <a:ln/>
+        </p:spPr>
+        <p:txBody>
+          <a:bodyPr wrap="square" lIns="0" tIns="0" rIns="0" bIns="0" rtlCol="0" anchor="t"/>
+          <a:lstStyle/>
+          <a:p>
+            <a:pPr indent="0" marL="0">
+              <a:buNone/>
+            </a:pPr>
+            <a:r>
+              <a:rPr lang="en-US" sz="1900" dirty="0">
+                <a:solidFill>
+                  <a:srgbClr val="1B1F24"/>
+                </a:solidFill>
+                <a:latin typeface="Cambria" pitchFamily="34" charset="0"/>
+                <a:ea typeface="Cambria" pitchFamily="34" charset="-122"/>
+                <a:cs typeface="Cambria" pitchFamily="34" charset="-120"/>
+              </a:rPr>
+              <a:t>Ra đề</a:t>
+            </a:r>
+            <a:endParaRPr lang="en-US" sz="1900" dirty="0"/>
+          </a:p>
+        </p:txBody>
+      </p:sp>
+      <p:sp>
+        <p:nvSpPr>
+          <p:cNvPr id="12" name="Text 10"/>
+          <p:cNvSpPr txBox="1"/>
+          <p:nvPr/>
+        </p:nvSpPr>
+        <p:spPr>
+          <a:xfrm>
+            <a:off x="2834640" y="3154680"/>
+            <a:ext cx="1508760" cy="1188720"/>
+          </a:xfrm>
+          <a:prstGeom prst="rect">
+            <a:avLst/>
+          </a:prstGeom>
+          <a:noFill/>
+          <a:ln/>
+        </p:spPr>
+        <p:txBody>
+          <a:bodyPr wrap="square" lIns="0" tIns="0" rIns="0" bIns="0" rtlCol="0" anchor="t"/>
+          <a:lstStyle/>
+          <a:p>
+            <a:pPr indent="0" marL="0">
+              <a:buNone/>
+            </a:pPr>
+            <a:r>
+              <a:rPr lang="en-US" sz="1300" dirty="0">
+                <a:solidFill>
+                  <a:srgbClr val="1B1F24"/>
+                </a:solidFill>
+                <a:latin typeface="Arial" pitchFamily="34" charset="0"/>
+                <a:ea typeface="Arial" pitchFamily="34" charset="-122"/>
+                <a:cs typeface="Arial" pitchFamily="34" charset="-120"/>
+              </a:rPr>
+              <a:t>Tự luận, trắc nghiệm theo ma trận, rubric</a:t>
+            </a:r>
+            <a:endParaRPr lang="en-US" sz="1300" dirty="0"/>
+          </a:p>
+        </p:txBody>
+      </p:sp>
+      <p:sp>
+        <p:nvSpPr>
+          <p:cNvPr id="13" name="Shape 11"/>
+          <p:cNvSpPr/>
+          <p:nvPr/>
+        </p:nvSpPr>
+        <p:spPr>
+          <a:xfrm>
+            <a:off x="4663440" y="1371600"/>
+            <a:ext cx="1874520" cy="3108960"/>
+          </a:xfrm>
+          <a:prstGeom prst="roundRect">
+            <a:avLst>
+              <a:gd name="adj" fmla="val 1463"/>
+            </a:avLst>
+          </a:prstGeom>
+          <a:solidFill>
+            <a:srgbClr val="F7F5F0"/>
+          </a:solidFill>
+          <a:ln w="9525">
+            <a:solidFill>
+              <a:srgbClr val="CFCAC0"/>
+            </a:solidFill>
+            <a:prstDash val="solid"/>
+          </a:ln>
+        </p:spPr>
+      </p:sp>
+      <p:sp>
+        <p:nvSpPr>
+          <p:cNvPr id="14" name="Shape 12"/>
+          <p:cNvSpPr/>
+          <p:nvPr/>
+        </p:nvSpPr>
+        <p:spPr>
+          <a:xfrm>
+            <a:off x="4892040" y="1600200"/>
+            <a:ext cx="548640" cy="548640"/>
+          </a:xfrm>
+          <a:prstGeom prst="ellipse">
+            <a:avLst/>
+          </a:prstGeom>
+          <a:solidFill>
+            <a:srgbClr val="F7F5F0"/>
+          </a:solidFill>
+          <a:ln w="9525">
+            <a:solidFill>
+              <a:srgbClr val="A67C3D"/>
+            </a:solidFill>
+            <a:prstDash val="solid"/>
+          </a:ln>
+        </p:spPr>
+      </p:sp>
+      <p:sp>
+        <p:nvSpPr>
+          <p:cNvPr id="15" name="Text 13"/>
+          <p:cNvSpPr txBox="1"/>
+          <p:nvPr/>
+        </p:nvSpPr>
+        <p:spPr>
+          <a:xfrm>
+            <a:off x="4892040" y="1600200"/>
+            <a:ext cx="548640" cy="548640"/>
+          </a:xfrm>
+          <a:prstGeom prst="rect">
+            <a:avLst/>
+          </a:prstGeom>
+          <a:noFill/>
+          <a:ln/>
+        </p:spPr>
+        <p:txBody>
+          <a:bodyPr wrap="square" lIns="0" tIns="0" rIns="0" bIns="0" rtlCol="0" anchor="ctr"/>
+          <a:lstStyle/>
+          <a:p>
+            <a:pPr algn="ctr" indent="0" marL="0">
+              <a:buNone/>
+            </a:pPr>
+            <a:r>
+              <a:rPr lang="en-US" sz="1800" dirty="0">
+                <a:solidFill>
+                  <a:srgbClr val="A67C3D"/>
+                </a:solidFill>
+                <a:latin typeface="Cambria" pitchFamily="34" charset="0"/>
+                <a:ea typeface="Cambria" pitchFamily="34" charset="-122"/>
+                <a:cs typeface="Cambria" pitchFamily="34" charset="-120"/>
+              </a:rPr>
+              <a:t>3</a:t>
+            </a:r>
+            <a:endParaRPr lang="en-US" sz="1800" dirty="0"/>
+          </a:p>
+        </p:txBody>
+      </p:sp>
+      <p:sp>
+        <p:nvSpPr>
+          <p:cNvPr id="16" name="Text 14"/>
+          <p:cNvSpPr txBox="1"/>
+          <p:nvPr/>
+        </p:nvSpPr>
+        <p:spPr>
+          <a:xfrm>
+            <a:off x="4892040" y="2377440"/>
+            <a:ext cx="1554480" cy="731520"/>
+          </a:xfrm>
+          <a:prstGeom prst="rect">
+            <a:avLst/>
+          </a:prstGeom>
+          <a:noFill/>
+          <a:ln/>
+        </p:spPr>
+        <p:txBody>
+          <a:bodyPr wrap="square" lIns="0" tIns="0" rIns="0" bIns="0" rtlCol="0" anchor="t"/>
+          <a:lstStyle/>
+          <a:p>
+            <a:pPr indent="0" marL="0">
+              <a:buNone/>
+            </a:pPr>
+            <a:r>
+              <a:rPr lang="en-US" sz="1900" dirty="0">
+                <a:solidFill>
+                  <a:srgbClr val="1B1F24"/>
+                </a:solidFill>
+                <a:latin typeface="Cambria" pitchFamily="34" charset="0"/>
+                <a:ea typeface="Cambria" pitchFamily="34" charset="-122"/>
+                <a:cs typeface="Cambria" pitchFamily="34" charset="-120"/>
+              </a:rPr>
+              <a:t>Làm học liệu</a:t>
+            </a:r>
+            <a:endParaRPr lang="en-US" sz="1900" dirty="0"/>
+          </a:p>
+        </p:txBody>
+      </p:sp>
+      <p:sp>
+        <p:nvSpPr>
+          <p:cNvPr id="17" name="Text 15"/>
+          <p:cNvSpPr txBox="1"/>
+          <p:nvPr/>
+        </p:nvSpPr>
+        <p:spPr>
+          <a:xfrm>
+            <a:off x="4892040" y="3154680"/>
+            <a:ext cx="1508760" cy="1188720"/>
+          </a:xfrm>
+          <a:prstGeom prst="rect">
+            <a:avLst/>
+          </a:prstGeom>
+          <a:noFill/>
+          <a:ln/>
+        </p:spPr>
+        <p:txBody>
+          <a:bodyPr wrap="square" lIns="0" tIns="0" rIns="0" bIns="0" rtlCol="0" anchor="t"/>
+          <a:lstStyle/>
+          <a:p>
+            <a:pPr indent="0" marL="0">
+              <a:buNone/>
+            </a:pPr>
+            <a:r>
+              <a:rPr lang="en-US" sz="1300" dirty="0">
+                <a:solidFill>
+                  <a:srgbClr val="1B1F24"/>
+                </a:solidFill>
+                <a:latin typeface="Arial" pitchFamily="34" charset="0"/>
+                <a:ea typeface="Arial" pitchFamily="34" charset="-122"/>
+                <a:cs typeface="Arial" pitchFamily="34" charset="-120"/>
+              </a:rPr>
+              <a:t>Ảnh, trò chơi, truyện tranh, bài hát, giọng đọc</a:t>
+            </a:r>
+            <a:endParaRPr lang="en-US" sz="1300" dirty="0"/>
+          </a:p>
+        </p:txBody>
+      </p:sp>
+      <p:sp>
+        <p:nvSpPr>
+          <p:cNvPr id="18" name="Shape 16"/>
+          <p:cNvSpPr/>
+          <p:nvPr/>
+        </p:nvSpPr>
+        <p:spPr>
+          <a:xfrm>
+            <a:off x="6720840" y="1371600"/>
+            <a:ext cx="1874520" cy="3108960"/>
+          </a:xfrm>
+          <a:prstGeom prst="roundRect">
+            <a:avLst>
+              <a:gd name="adj" fmla="val 1463"/>
+            </a:avLst>
+          </a:prstGeom>
+          <a:solidFill>
+            <a:srgbClr val="1B1F24"/>
+          </a:solidFill>
+          <a:ln w="9525">
+            <a:solidFill>
+              <a:srgbClr val="1B1F24"/>
+            </a:solidFill>
+            <a:prstDash val="solid"/>
+          </a:ln>
+        </p:spPr>
+      </p:sp>
+      <p:sp>
+        <p:nvSpPr>
+          <p:cNvPr id="19" name="Shape 17"/>
+          <p:cNvSpPr/>
+          <p:nvPr/>
+        </p:nvSpPr>
+        <p:spPr>
+          <a:xfrm>
+            <a:off x="6949440" y="1600200"/>
+            <a:ext cx="548640" cy="548640"/>
+          </a:xfrm>
+          <a:prstGeom prst="ellipse">
+            <a:avLst/>
+          </a:prstGeom>
+          <a:solidFill>
+            <a:srgbClr val="1B1F24"/>
+          </a:solidFill>
+          <a:ln w="9525">
+            <a:solidFill>
+              <a:srgbClr val="A67C3D"/>
+            </a:solidFill>
+            <a:prstDash val="solid"/>
+          </a:ln>
+        </p:spPr>
+      </p:sp>
+      <p:sp>
+        <p:nvSpPr>
+          <p:cNvPr id="20" name="Text 18"/>
+          <p:cNvSpPr txBox="1"/>
+          <p:nvPr/>
+        </p:nvSpPr>
+        <p:spPr>
+          <a:xfrm>
+            <a:off x="6949440" y="1600200"/>
+            <a:ext cx="548640" cy="548640"/>
+          </a:xfrm>
+          <a:prstGeom prst="rect">
+            <a:avLst/>
+          </a:prstGeom>
+          <a:noFill/>
+          <a:ln/>
+        </p:spPr>
+        <p:txBody>
+          <a:bodyPr wrap="square" lIns="0" tIns="0" rIns="0" bIns="0" rtlCol="0" anchor="ctr"/>
+          <a:lstStyle/>
+          <a:p>
+            <a:pPr algn="ctr" indent="0" marL="0">
+              <a:buNone/>
+            </a:pPr>
+            <a:r>
+              <a:rPr lang="en-US" sz="1800" dirty="0">
+                <a:solidFill>
+                  <a:srgbClr val="A67C3D"/>
+                </a:solidFill>
+                <a:latin typeface="Cambria" pitchFamily="34" charset="0"/>
+                <a:ea typeface="Cambria" pitchFamily="34" charset="-122"/>
+                <a:cs typeface="Cambria" pitchFamily="34" charset="-120"/>
+              </a:rPr>
+              <a:t>4</a:t>
+            </a:r>
+            <a:endParaRPr lang="en-US" sz="1800" dirty="0"/>
+          </a:p>
+        </p:txBody>
+      </p:sp>
+      <p:sp>
+        <p:nvSpPr>
+          <p:cNvPr id="21" name="Text 19"/>
+          <p:cNvSpPr txBox="1"/>
+          <p:nvPr/>
+        </p:nvSpPr>
+        <p:spPr>
+          <a:xfrm>
+            <a:off x="6949440" y="2377440"/>
+            <a:ext cx="1554480" cy="731520"/>
+          </a:xfrm>
+          <a:prstGeom prst="rect">
+            <a:avLst/>
+          </a:prstGeom>
+          <a:noFill/>
+          <a:ln/>
+        </p:spPr>
+        <p:txBody>
+          <a:bodyPr wrap="square" lIns="0" tIns="0" rIns="0" bIns="0" rtlCol="0" anchor="t"/>
+          <a:lstStyle/>
+          <a:p>
+            <a:pPr indent="0" marL="0">
+              <a:buNone/>
+            </a:pPr>
+            <a:r>
+              <a:rPr lang="en-US" sz="1900" dirty="0">
+                <a:solidFill>
+                  <a:srgbClr val="F7F5F0"/>
+                </a:solidFill>
+                <a:latin typeface="Cambria" pitchFamily="34" charset="0"/>
+                <a:ea typeface="Cambria" pitchFamily="34" charset="-122"/>
+                <a:cs typeface="Cambria" pitchFamily="34" charset="-120"/>
+              </a:rPr>
+              <a:t>Tạo trợ giảng</a:t>
+            </a:r>
+            <a:endParaRPr lang="en-US" sz="1900" dirty="0"/>
+          </a:p>
+        </p:txBody>
+      </p:sp>
+      <p:sp>
+        <p:nvSpPr>
+          <p:cNvPr id="22" name="Text 20"/>
+          <p:cNvSpPr txBox="1"/>
+          <p:nvPr/>
+        </p:nvSpPr>
+        <p:spPr>
+          <a:xfrm>
+            <a:off x="6949440" y="3154680"/>
+            <a:ext cx="1508760" cy="1188720"/>
+          </a:xfrm>
+          <a:prstGeom prst="rect">
+            <a:avLst/>
+          </a:prstGeom>
+          <a:noFill/>
+          <a:ln/>
+        </p:spPr>
+        <p:txBody>
+          <a:bodyPr wrap="square" lIns="0" tIns="0" rIns="0" bIns="0" rtlCol="0" anchor="t"/>
+          <a:lstStyle/>
+          <a:p>
+            <a:pPr indent="0" marL="0">
+              <a:buNone/>
+            </a:pPr>
+            <a:r>
+              <a:rPr lang="en-US" sz="1300" dirty="0">
+                <a:solidFill>
+                  <a:srgbClr val="F7F5F0"/>
+                </a:solidFill>
+                <a:latin typeface="Arial" pitchFamily="34" charset="0"/>
+                <a:ea typeface="Arial" pitchFamily="34" charset="-122"/>
+                <a:cs typeface="Arial" pitchFamily="34" charset="-120"/>
+              </a:rPr>
+              <a:t>Chatbot ôn tập không đưa đáp án ngay</a:t>
+            </a:r>
+            <a:endParaRPr lang="en-US" sz="1300" dirty="0"/>
+          </a:p>
+        </p:txBody>
+      </p:sp>
+    </p:spTree>
+  </p:cSld>
+  <p:clrMapOvr>
+    <a:masterClrMapping/>
+  </p:clrMapOvr>
+</p:sld>
+</file>
+
+<file path=ppt/slides/slide20.xml><?xml version="1.0" encoding="utf-8"?>
+<p:sld xmlns:a="http://schemas.openxmlformats.org/drawingml/2006/main" xmlns:r="http://schemas.openxmlformats.org/officeDocument/2006/relationships" xmlns:p="http://schemas.openxmlformats.org/presentationml/2006/main">
+  <p:cSld name="Slide 20">
     <p:bg>
       <p:bgPr>
         <a:solidFill>
@@ -4067,756 +4959,9 @@
 </p:sld>
 </file>
 
-<file path=ppt/slides/slide2.xml><?xml version="1.0" encoding="utf-8"?>
+<file path=ppt/slides/slide21.xml><?xml version="1.0" encoding="utf-8"?>
 <p:sld xmlns:a="http://schemas.openxmlformats.org/drawingml/2006/main" xmlns:r="http://schemas.openxmlformats.org/officeDocument/2006/relationships" xmlns:p="http://schemas.openxmlformats.org/presentationml/2006/main">
-  <p:cSld name="Slide 2">
-    <p:bg>
-      <p:bgPr>
-        <a:solidFill>
-          <a:srgbClr val="F7F5F0"/>
-        </a:solidFill>
-      </p:bgPr>
-    </p:bg>
-    <p:spTree>
-      <p:nvGrpSpPr>
-        <p:cNvPr id="1" name=""/>
-        <p:cNvGrpSpPr/>
-        <p:nvPr/>
-      </p:nvGrpSpPr>
-      <p:grpSpPr>
-        <a:xfrm>
-          <a:off x="0" y="0"/>
-          <a:ext cx="0" cy="0"/>
-          <a:chOff x="0" y="0"/>
-          <a:chExt cx="0" cy="0"/>
-        </a:xfrm>
-      </p:grpSpPr>
-      <p:sp>
-        <p:nvSpPr>
-          <p:cNvPr id="2" name="Text 0"/>
-          <p:cNvSpPr txBox="1"/>
-          <p:nvPr/>
-        </p:nvSpPr>
-        <p:spPr>
-          <a:xfrm>
-            <a:off x="548640" y="457200"/>
-            <a:ext cx="8046720" cy="640080"/>
-          </a:xfrm>
-          <a:prstGeom prst="rect">
-            <a:avLst/>
-          </a:prstGeom>
-          <a:noFill/>
-          <a:ln/>
-        </p:spPr>
-        <p:txBody>
-          <a:bodyPr wrap="square" lIns="0" tIns="0" rIns="0" bIns="0" rtlCol="0" anchor="ctr"/>
-          <a:lstStyle/>
-          <a:p>
-            <a:pPr indent="0" marL="0">
-              <a:buNone/>
-            </a:pPr>
-            <a:r>
-              <a:rPr lang="en-US" sz="3000" dirty="0">
-                <a:solidFill>
-                  <a:srgbClr val="1B1F24"/>
-                </a:solidFill>
-                <a:latin typeface="Cambria" pitchFamily="34" charset="0"/>
-                <a:ea typeface="Cambria" pitchFamily="34" charset="-122"/>
-                <a:cs typeface="Cambria" pitchFamily="34" charset="-120"/>
-              </a:rPr>
-              <a:t>Sau cuốn sách, thầy cô tự làm được</a:t>
-            </a:r>
-            <a:endParaRPr lang="en-US" sz="3000" dirty="0"/>
-          </a:p>
-        </p:txBody>
-      </p:sp>
-      <p:sp>
-        <p:nvSpPr>
-          <p:cNvPr id="3" name="Shape 1"/>
-          <p:cNvSpPr/>
-          <p:nvPr/>
-        </p:nvSpPr>
-        <p:spPr>
-          <a:xfrm>
-            <a:off x="548640" y="1371600"/>
-            <a:ext cx="1874520" cy="3108960"/>
-          </a:xfrm>
-          <a:prstGeom prst="roundRect">
-            <a:avLst>
-              <a:gd name="adj" fmla="val 1463"/>
-            </a:avLst>
-          </a:prstGeom>
-          <a:solidFill>
-            <a:srgbClr val="F7F5F0"/>
-          </a:solidFill>
-          <a:ln w="9525">
-            <a:solidFill>
-              <a:srgbClr val="CFCAC0"/>
-            </a:solidFill>
-            <a:prstDash val="solid"/>
-          </a:ln>
-        </p:spPr>
-      </p:sp>
-      <p:sp>
-        <p:nvSpPr>
-          <p:cNvPr id="4" name="Shape 2"/>
-          <p:cNvSpPr/>
-          <p:nvPr/>
-        </p:nvSpPr>
-        <p:spPr>
-          <a:xfrm>
-            <a:off x="777240" y="1600200"/>
-            <a:ext cx="548640" cy="548640"/>
-          </a:xfrm>
-          <a:prstGeom prst="ellipse">
-            <a:avLst/>
-          </a:prstGeom>
-          <a:solidFill>
-            <a:srgbClr val="F7F5F0"/>
-          </a:solidFill>
-          <a:ln w="9525">
-            <a:solidFill>
-              <a:srgbClr val="A67C3D"/>
-            </a:solidFill>
-            <a:prstDash val="solid"/>
-          </a:ln>
-        </p:spPr>
-      </p:sp>
-      <p:sp>
-        <p:nvSpPr>
-          <p:cNvPr id="5" name="Text 3"/>
-          <p:cNvSpPr txBox="1"/>
-          <p:nvPr/>
-        </p:nvSpPr>
-        <p:spPr>
-          <a:xfrm>
-            <a:off x="777240" y="1600200"/>
-            <a:ext cx="548640" cy="548640"/>
-          </a:xfrm>
-          <a:prstGeom prst="rect">
-            <a:avLst/>
-          </a:prstGeom>
-          <a:noFill/>
-          <a:ln/>
-        </p:spPr>
-        <p:txBody>
-          <a:bodyPr wrap="square" lIns="0" tIns="0" rIns="0" bIns="0" rtlCol="0" anchor="ctr"/>
-          <a:lstStyle/>
-          <a:p>
-            <a:pPr algn="ctr" indent="0" marL="0">
-              <a:buNone/>
-            </a:pPr>
-            <a:r>
-              <a:rPr lang="en-US" sz="1800" dirty="0">
-                <a:solidFill>
-                  <a:srgbClr val="A67C3D"/>
-                </a:solidFill>
-                <a:latin typeface="Cambria" pitchFamily="34" charset="0"/>
-                <a:ea typeface="Cambria" pitchFamily="34" charset="-122"/>
-                <a:cs typeface="Cambria" pitchFamily="34" charset="-120"/>
-              </a:rPr>
-              <a:t>1</a:t>
-            </a:r>
-            <a:endParaRPr lang="en-US" sz="1800" dirty="0"/>
-          </a:p>
-        </p:txBody>
-      </p:sp>
-      <p:sp>
-        <p:nvSpPr>
-          <p:cNvPr id="6" name="Text 4"/>
-          <p:cNvSpPr txBox="1"/>
-          <p:nvPr/>
-        </p:nvSpPr>
-        <p:spPr>
-          <a:xfrm>
-            <a:off x="777240" y="2377440"/>
-            <a:ext cx="1554480" cy="731520"/>
-          </a:xfrm>
-          <a:prstGeom prst="rect">
-            <a:avLst/>
-          </a:prstGeom>
-          <a:noFill/>
-          <a:ln/>
-        </p:spPr>
-        <p:txBody>
-          <a:bodyPr wrap="square" lIns="0" tIns="0" rIns="0" bIns="0" rtlCol="0" anchor="t"/>
-          <a:lstStyle/>
-          <a:p>
-            <a:pPr indent="0" marL="0">
-              <a:buNone/>
-            </a:pPr>
-            <a:r>
-              <a:rPr lang="en-US" sz="1900" dirty="0">
-                <a:solidFill>
-                  <a:srgbClr val="1B1F24"/>
-                </a:solidFill>
-                <a:latin typeface="Cambria" pitchFamily="34" charset="0"/>
-                <a:ea typeface="Cambria" pitchFamily="34" charset="-122"/>
-                <a:cs typeface="Cambria" pitchFamily="34" charset="-120"/>
-              </a:rPr>
-              <a:t>Soạn bài</a:t>
-            </a:r>
-            <a:endParaRPr lang="en-US" sz="1900" dirty="0"/>
-          </a:p>
-        </p:txBody>
-      </p:sp>
-      <p:sp>
-        <p:nvSpPr>
-          <p:cNvPr id="7" name="Text 5"/>
-          <p:cNvSpPr txBox="1"/>
-          <p:nvPr/>
-        </p:nvSpPr>
-        <p:spPr>
-          <a:xfrm>
-            <a:off x="777240" y="3154680"/>
-            <a:ext cx="1508760" cy="1188720"/>
-          </a:xfrm>
-          <a:prstGeom prst="rect">
-            <a:avLst/>
-          </a:prstGeom>
-          <a:noFill/>
-          <a:ln/>
-        </p:spPr>
-        <p:txBody>
-          <a:bodyPr wrap="square" lIns="0" tIns="0" rIns="0" bIns="0" rtlCol="0" anchor="t"/>
-          <a:lstStyle/>
-          <a:p>
-            <a:pPr indent="0" marL="0">
-              <a:buNone/>
-            </a:pPr>
-            <a:r>
-              <a:rPr lang="en-US" sz="1300" dirty="0">
-                <a:solidFill>
-                  <a:srgbClr val="1B1F24"/>
-                </a:solidFill>
-                <a:latin typeface="Arial" pitchFamily="34" charset="0"/>
-                <a:ea typeface="Arial" pitchFamily="34" charset="-122"/>
-                <a:cs typeface="Arial" pitchFamily="34" charset="-120"/>
-              </a:rPr>
-              <a:t>Giáo án góc trạm, STEM, bài giảng 10 slide</a:t>
-            </a:r>
-            <a:endParaRPr lang="en-US" sz="1300" dirty="0"/>
-          </a:p>
-        </p:txBody>
-      </p:sp>
-      <p:sp>
-        <p:nvSpPr>
-          <p:cNvPr id="8" name="Shape 6"/>
-          <p:cNvSpPr/>
-          <p:nvPr/>
-        </p:nvSpPr>
-        <p:spPr>
-          <a:xfrm>
-            <a:off x="2606040" y="1371600"/>
-            <a:ext cx="1874520" cy="3108960"/>
-          </a:xfrm>
-          <a:prstGeom prst="roundRect">
-            <a:avLst>
-              <a:gd name="adj" fmla="val 1463"/>
-            </a:avLst>
-          </a:prstGeom>
-          <a:solidFill>
-            <a:srgbClr val="F7F5F0"/>
-          </a:solidFill>
-          <a:ln w="9525">
-            <a:solidFill>
-              <a:srgbClr val="CFCAC0"/>
-            </a:solidFill>
-            <a:prstDash val="solid"/>
-          </a:ln>
-        </p:spPr>
-      </p:sp>
-      <p:sp>
-        <p:nvSpPr>
-          <p:cNvPr id="9" name="Shape 7"/>
-          <p:cNvSpPr/>
-          <p:nvPr/>
-        </p:nvSpPr>
-        <p:spPr>
-          <a:xfrm>
-            <a:off x="2834640" y="1600200"/>
-            <a:ext cx="548640" cy="548640"/>
-          </a:xfrm>
-          <a:prstGeom prst="ellipse">
-            <a:avLst/>
-          </a:prstGeom>
-          <a:solidFill>
-            <a:srgbClr val="F7F5F0"/>
-          </a:solidFill>
-          <a:ln w="9525">
-            <a:solidFill>
-              <a:srgbClr val="A67C3D"/>
-            </a:solidFill>
-            <a:prstDash val="solid"/>
-          </a:ln>
-        </p:spPr>
-      </p:sp>
-      <p:sp>
-        <p:nvSpPr>
-          <p:cNvPr id="10" name="Text 8"/>
-          <p:cNvSpPr txBox="1"/>
-          <p:nvPr/>
-        </p:nvSpPr>
-        <p:spPr>
-          <a:xfrm>
-            <a:off x="2834640" y="1600200"/>
-            <a:ext cx="548640" cy="548640"/>
-          </a:xfrm>
-          <a:prstGeom prst="rect">
-            <a:avLst/>
-          </a:prstGeom>
-          <a:noFill/>
-          <a:ln/>
-        </p:spPr>
-        <p:txBody>
-          <a:bodyPr wrap="square" lIns="0" tIns="0" rIns="0" bIns="0" rtlCol="0" anchor="ctr"/>
-          <a:lstStyle/>
-          <a:p>
-            <a:pPr algn="ctr" indent="0" marL="0">
-              <a:buNone/>
-            </a:pPr>
-            <a:r>
-              <a:rPr lang="en-US" sz="1800" dirty="0">
-                <a:solidFill>
-                  <a:srgbClr val="A67C3D"/>
-                </a:solidFill>
-                <a:latin typeface="Cambria" pitchFamily="34" charset="0"/>
-                <a:ea typeface="Cambria" pitchFamily="34" charset="-122"/>
-                <a:cs typeface="Cambria" pitchFamily="34" charset="-120"/>
-              </a:rPr>
-              <a:t>2</a:t>
-            </a:r>
-            <a:endParaRPr lang="en-US" sz="1800" dirty="0"/>
-          </a:p>
-        </p:txBody>
-      </p:sp>
-      <p:sp>
-        <p:nvSpPr>
-          <p:cNvPr id="11" name="Text 9"/>
-          <p:cNvSpPr txBox="1"/>
-          <p:nvPr/>
-        </p:nvSpPr>
-        <p:spPr>
-          <a:xfrm>
-            <a:off x="2834640" y="2377440"/>
-            <a:ext cx="1554480" cy="731520"/>
-          </a:xfrm>
-          <a:prstGeom prst="rect">
-            <a:avLst/>
-          </a:prstGeom>
-          <a:noFill/>
-          <a:ln/>
-        </p:spPr>
-        <p:txBody>
-          <a:bodyPr wrap="square" lIns="0" tIns="0" rIns="0" bIns="0" rtlCol="0" anchor="t"/>
-          <a:lstStyle/>
-          <a:p>
-            <a:pPr indent="0" marL="0">
-              <a:buNone/>
-            </a:pPr>
-            <a:r>
-              <a:rPr lang="en-US" sz="1900" dirty="0">
-                <a:solidFill>
-                  <a:srgbClr val="1B1F24"/>
-                </a:solidFill>
-                <a:latin typeface="Cambria" pitchFamily="34" charset="0"/>
-                <a:ea typeface="Cambria" pitchFamily="34" charset="-122"/>
-                <a:cs typeface="Cambria" pitchFamily="34" charset="-120"/>
-              </a:rPr>
-              <a:t>Ra đề</a:t>
-            </a:r>
-            <a:endParaRPr lang="en-US" sz="1900" dirty="0"/>
-          </a:p>
-        </p:txBody>
-      </p:sp>
-      <p:sp>
-        <p:nvSpPr>
-          <p:cNvPr id="12" name="Text 10"/>
-          <p:cNvSpPr txBox="1"/>
-          <p:nvPr/>
-        </p:nvSpPr>
-        <p:spPr>
-          <a:xfrm>
-            <a:off x="2834640" y="3154680"/>
-            <a:ext cx="1508760" cy="1188720"/>
-          </a:xfrm>
-          <a:prstGeom prst="rect">
-            <a:avLst/>
-          </a:prstGeom>
-          <a:noFill/>
-          <a:ln/>
-        </p:spPr>
-        <p:txBody>
-          <a:bodyPr wrap="square" lIns="0" tIns="0" rIns="0" bIns="0" rtlCol="0" anchor="t"/>
-          <a:lstStyle/>
-          <a:p>
-            <a:pPr indent="0" marL="0">
-              <a:buNone/>
-            </a:pPr>
-            <a:r>
-              <a:rPr lang="en-US" sz="1300" dirty="0">
-                <a:solidFill>
-                  <a:srgbClr val="1B1F24"/>
-                </a:solidFill>
-                <a:latin typeface="Arial" pitchFamily="34" charset="0"/>
-                <a:ea typeface="Arial" pitchFamily="34" charset="-122"/>
-                <a:cs typeface="Arial" pitchFamily="34" charset="-120"/>
-              </a:rPr>
-              <a:t>Tự luận, trắc nghiệm theo ma trận, rubric</a:t>
-            </a:r>
-            <a:endParaRPr lang="en-US" sz="1300" dirty="0"/>
-          </a:p>
-        </p:txBody>
-      </p:sp>
-      <p:sp>
-        <p:nvSpPr>
-          <p:cNvPr id="13" name="Shape 11"/>
-          <p:cNvSpPr/>
-          <p:nvPr/>
-        </p:nvSpPr>
-        <p:spPr>
-          <a:xfrm>
-            <a:off x="4663440" y="1371600"/>
-            <a:ext cx="1874520" cy="3108960"/>
-          </a:xfrm>
-          <a:prstGeom prst="roundRect">
-            <a:avLst>
-              <a:gd name="adj" fmla="val 1463"/>
-            </a:avLst>
-          </a:prstGeom>
-          <a:solidFill>
-            <a:srgbClr val="F7F5F0"/>
-          </a:solidFill>
-          <a:ln w="9525">
-            <a:solidFill>
-              <a:srgbClr val="CFCAC0"/>
-            </a:solidFill>
-            <a:prstDash val="solid"/>
-          </a:ln>
-        </p:spPr>
-      </p:sp>
-      <p:sp>
-        <p:nvSpPr>
-          <p:cNvPr id="14" name="Shape 12"/>
-          <p:cNvSpPr/>
-          <p:nvPr/>
-        </p:nvSpPr>
-        <p:spPr>
-          <a:xfrm>
-            <a:off x="4892040" y="1600200"/>
-            <a:ext cx="548640" cy="548640"/>
-          </a:xfrm>
-          <a:prstGeom prst="ellipse">
-            <a:avLst/>
-          </a:prstGeom>
-          <a:solidFill>
-            <a:srgbClr val="F7F5F0"/>
-          </a:solidFill>
-          <a:ln w="9525">
-            <a:solidFill>
-              <a:srgbClr val="A67C3D"/>
-            </a:solidFill>
-            <a:prstDash val="solid"/>
-          </a:ln>
-        </p:spPr>
-      </p:sp>
-      <p:sp>
-        <p:nvSpPr>
-          <p:cNvPr id="15" name="Text 13"/>
-          <p:cNvSpPr txBox="1"/>
-          <p:nvPr/>
-        </p:nvSpPr>
-        <p:spPr>
-          <a:xfrm>
-            <a:off x="4892040" y="1600200"/>
-            <a:ext cx="548640" cy="548640"/>
-          </a:xfrm>
-          <a:prstGeom prst="rect">
-            <a:avLst/>
-          </a:prstGeom>
-          <a:noFill/>
-          <a:ln/>
-        </p:spPr>
-        <p:txBody>
-          <a:bodyPr wrap="square" lIns="0" tIns="0" rIns="0" bIns="0" rtlCol="0" anchor="ctr"/>
-          <a:lstStyle/>
-          <a:p>
-            <a:pPr algn="ctr" indent="0" marL="0">
-              <a:buNone/>
-            </a:pPr>
-            <a:r>
-              <a:rPr lang="en-US" sz="1800" dirty="0">
-                <a:solidFill>
-                  <a:srgbClr val="A67C3D"/>
-                </a:solidFill>
-                <a:latin typeface="Cambria" pitchFamily="34" charset="0"/>
-                <a:ea typeface="Cambria" pitchFamily="34" charset="-122"/>
-                <a:cs typeface="Cambria" pitchFamily="34" charset="-120"/>
-              </a:rPr>
-              <a:t>3</a:t>
-            </a:r>
-            <a:endParaRPr lang="en-US" sz="1800" dirty="0"/>
-          </a:p>
-        </p:txBody>
-      </p:sp>
-      <p:sp>
-        <p:nvSpPr>
-          <p:cNvPr id="16" name="Text 14"/>
-          <p:cNvSpPr txBox="1"/>
-          <p:nvPr/>
-        </p:nvSpPr>
-        <p:spPr>
-          <a:xfrm>
-            <a:off x="4892040" y="2377440"/>
-            <a:ext cx="1554480" cy="731520"/>
-          </a:xfrm>
-          <a:prstGeom prst="rect">
-            <a:avLst/>
-          </a:prstGeom>
-          <a:noFill/>
-          <a:ln/>
-        </p:spPr>
-        <p:txBody>
-          <a:bodyPr wrap="square" lIns="0" tIns="0" rIns="0" bIns="0" rtlCol="0" anchor="t"/>
-          <a:lstStyle/>
-          <a:p>
-            <a:pPr indent="0" marL="0">
-              <a:buNone/>
-            </a:pPr>
-            <a:r>
-              <a:rPr lang="en-US" sz="1900" dirty="0">
-                <a:solidFill>
-                  <a:srgbClr val="1B1F24"/>
-                </a:solidFill>
-                <a:latin typeface="Cambria" pitchFamily="34" charset="0"/>
-                <a:ea typeface="Cambria" pitchFamily="34" charset="-122"/>
-                <a:cs typeface="Cambria" pitchFamily="34" charset="-120"/>
-              </a:rPr>
-              <a:t>Làm học liệu</a:t>
-            </a:r>
-            <a:endParaRPr lang="en-US" sz="1900" dirty="0"/>
-          </a:p>
-        </p:txBody>
-      </p:sp>
-      <p:sp>
-        <p:nvSpPr>
-          <p:cNvPr id="17" name="Text 15"/>
-          <p:cNvSpPr txBox="1"/>
-          <p:nvPr/>
-        </p:nvSpPr>
-        <p:spPr>
-          <a:xfrm>
-            <a:off x="4892040" y="3154680"/>
-            <a:ext cx="1508760" cy="1188720"/>
-          </a:xfrm>
-          <a:prstGeom prst="rect">
-            <a:avLst/>
-          </a:prstGeom>
-          <a:noFill/>
-          <a:ln/>
-        </p:spPr>
-        <p:txBody>
-          <a:bodyPr wrap="square" lIns="0" tIns="0" rIns="0" bIns="0" rtlCol="0" anchor="t"/>
-          <a:lstStyle/>
-          <a:p>
-            <a:pPr indent="0" marL="0">
-              <a:buNone/>
-            </a:pPr>
-            <a:r>
-              <a:rPr lang="en-US" sz="1300" dirty="0">
-                <a:solidFill>
-                  <a:srgbClr val="1B1F24"/>
-                </a:solidFill>
-                <a:latin typeface="Arial" pitchFamily="34" charset="0"/>
-                <a:ea typeface="Arial" pitchFamily="34" charset="-122"/>
-                <a:cs typeface="Arial" pitchFamily="34" charset="-120"/>
-              </a:rPr>
-              <a:t>Ảnh, trò chơi, truyện tranh, bài hát, giọng đọc</a:t>
-            </a:r>
-            <a:endParaRPr lang="en-US" sz="1300" dirty="0"/>
-          </a:p>
-        </p:txBody>
-      </p:sp>
-      <p:sp>
-        <p:nvSpPr>
-          <p:cNvPr id="18" name="Shape 16"/>
-          <p:cNvSpPr/>
-          <p:nvPr/>
-        </p:nvSpPr>
-        <p:spPr>
-          <a:xfrm>
-            <a:off x="6720840" y="1371600"/>
-            <a:ext cx="1874520" cy="3108960"/>
-          </a:xfrm>
-          <a:prstGeom prst="roundRect">
-            <a:avLst>
-              <a:gd name="adj" fmla="val 1463"/>
-            </a:avLst>
-          </a:prstGeom>
-          <a:solidFill>
-            <a:srgbClr val="1B1F24"/>
-          </a:solidFill>
-          <a:ln w="9525">
-            <a:solidFill>
-              <a:srgbClr val="1B1F24"/>
-            </a:solidFill>
-            <a:prstDash val="solid"/>
-          </a:ln>
-        </p:spPr>
-      </p:sp>
-      <p:sp>
-        <p:nvSpPr>
-          <p:cNvPr id="19" name="Shape 17"/>
-          <p:cNvSpPr/>
-          <p:nvPr/>
-        </p:nvSpPr>
-        <p:spPr>
-          <a:xfrm>
-            <a:off x="6949440" y="1600200"/>
-            <a:ext cx="548640" cy="548640"/>
-          </a:xfrm>
-          <a:prstGeom prst="ellipse">
-            <a:avLst/>
-          </a:prstGeom>
-          <a:solidFill>
-            <a:srgbClr val="1B1F24"/>
-          </a:solidFill>
-          <a:ln w="9525">
-            <a:solidFill>
-              <a:srgbClr val="A67C3D"/>
-            </a:solidFill>
-            <a:prstDash val="solid"/>
-          </a:ln>
-        </p:spPr>
-      </p:sp>
-      <p:sp>
-        <p:nvSpPr>
-          <p:cNvPr id="20" name="Text 18"/>
-          <p:cNvSpPr txBox="1"/>
-          <p:nvPr/>
-        </p:nvSpPr>
-        <p:spPr>
-          <a:xfrm>
-            <a:off x="6949440" y="1600200"/>
-            <a:ext cx="548640" cy="548640"/>
-          </a:xfrm>
-          <a:prstGeom prst="rect">
-            <a:avLst/>
-          </a:prstGeom>
-          <a:noFill/>
-          <a:ln/>
-        </p:spPr>
-        <p:txBody>
-          <a:bodyPr wrap="square" lIns="0" tIns="0" rIns="0" bIns="0" rtlCol="0" anchor="ctr"/>
-          <a:lstStyle/>
-          <a:p>
-            <a:pPr algn="ctr" indent="0" marL="0">
-              <a:buNone/>
-            </a:pPr>
-            <a:r>
-              <a:rPr lang="en-US" sz="1800" dirty="0">
-                <a:solidFill>
-                  <a:srgbClr val="A67C3D"/>
-                </a:solidFill>
-                <a:latin typeface="Cambria" pitchFamily="34" charset="0"/>
-                <a:ea typeface="Cambria" pitchFamily="34" charset="-122"/>
-                <a:cs typeface="Cambria" pitchFamily="34" charset="-120"/>
-              </a:rPr>
-              <a:t>4</a:t>
-            </a:r>
-            <a:endParaRPr lang="en-US" sz="1800" dirty="0"/>
-          </a:p>
-        </p:txBody>
-      </p:sp>
-      <p:sp>
-        <p:nvSpPr>
-          <p:cNvPr id="21" name="Text 19"/>
-          <p:cNvSpPr txBox="1"/>
-          <p:nvPr/>
-        </p:nvSpPr>
-        <p:spPr>
-          <a:xfrm>
-            <a:off x="6949440" y="2377440"/>
-            <a:ext cx="1554480" cy="731520"/>
-          </a:xfrm>
-          <a:prstGeom prst="rect">
-            <a:avLst/>
-          </a:prstGeom>
-          <a:noFill/>
-          <a:ln/>
-        </p:spPr>
-        <p:txBody>
-          <a:bodyPr wrap="square" lIns="0" tIns="0" rIns="0" bIns="0" rtlCol="0" anchor="t"/>
-          <a:lstStyle/>
-          <a:p>
-            <a:pPr indent="0" marL="0">
-              <a:buNone/>
-            </a:pPr>
-            <a:r>
-              <a:rPr lang="en-US" sz="1900" dirty="0">
-                <a:solidFill>
-                  <a:srgbClr val="F7F5F0"/>
-                </a:solidFill>
-                <a:latin typeface="Cambria" pitchFamily="34" charset="0"/>
-                <a:ea typeface="Cambria" pitchFamily="34" charset="-122"/>
-                <a:cs typeface="Cambria" pitchFamily="34" charset="-120"/>
-              </a:rPr>
-              <a:t>Tạo trợ giảng</a:t>
-            </a:r>
-            <a:endParaRPr lang="en-US" sz="1900" dirty="0"/>
-          </a:p>
-        </p:txBody>
-      </p:sp>
-      <p:sp>
-        <p:nvSpPr>
-          <p:cNvPr id="22" name="Text 20"/>
-          <p:cNvSpPr txBox="1"/>
-          <p:nvPr/>
-        </p:nvSpPr>
-        <p:spPr>
-          <a:xfrm>
-            <a:off x="6949440" y="3154680"/>
-            <a:ext cx="1508760" cy="1188720"/>
-          </a:xfrm>
-          <a:prstGeom prst="rect">
-            <a:avLst/>
-          </a:prstGeom>
-          <a:noFill/>
-          <a:ln/>
-        </p:spPr>
-        <p:txBody>
-          <a:bodyPr wrap="square" lIns="0" tIns="0" rIns="0" bIns="0" rtlCol="0" anchor="t"/>
-          <a:lstStyle/>
-          <a:p>
-            <a:pPr indent="0" marL="0">
-              <a:buNone/>
-            </a:pPr>
-            <a:r>
-              <a:rPr lang="en-US" sz="1300" dirty="0">
-                <a:solidFill>
-                  <a:srgbClr val="F7F5F0"/>
-                </a:solidFill>
-                <a:latin typeface="Arial" pitchFamily="34" charset="0"/>
-                <a:ea typeface="Arial" pitchFamily="34" charset="-122"/>
-                <a:cs typeface="Arial" pitchFamily="34" charset="-120"/>
-              </a:rPr>
-              <a:t>Chatbot ôn tập không đưa đáp án ngay</a:t>
-            </a:r>
-            <a:endParaRPr lang="en-US" sz="1300" dirty="0"/>
-          </a:p>
-        </p:txBody>
-      </p:sp>
-    </p:spTree>
-  </p:cSld>
-  <p:clrMapOvr>
-    <a:masterClrMapping/>
-  </p:clrMapOvr>
-</p:sld>
-</file>
-
-<file path=ppt/slides/slide20.xml><?xml version="1.0" encoding="utf-8"?>
-<p:sld xmlns:a="http://schemas.openxmlformats.org/drawingml/2006/main" xmlns:r="http://schemas.openxmlformats.org/officeDocument/2006/relationships" xmlns:p="http://schemas.openxmlformats.org/presentationml/2006/main">
-  <p:cSld name="Slide 20">
+  <p:cSld name="Slide 21">
     <p:bg>
       <p:bgPr>
         <a:solidFill>
@@ -4870,9 +5015,9 @@
 </p:sld>
 </file>
 
-<file path=ppt/slides/slide21.xml><?xml version="1.0" encoding="utf-8"?>
+<file path=ppt/slides/slide22.xml><?xml version="1.0" encoding="utf-8"?>
 <p:sld xmlns:a="http://schemas.openxmlformats.org/drawingml/2006/main" xmlns:r="http://schemas.openxmlformats.org/officeDocument/2006/relationships" xmlns:p="http://schemas.openxmlformats.org/presentationml/2006/main">
-  <p:cSld name="Slide 21">
+  <p:cSld name="Slide 22">
     <p:bg>
       <p:bgPr>
         <a:solidFill>
@@ -4926,9 +5071,9 @@
 </p:sld>
 </file>
 
-<file path=ppt/slides/slide22.xml><?xml version="1.0" encoding="utf-8"?>
+<file path=ppt/slides/slide23.xml><?xml version="1.0" encoding="utf-8"?>
 <p:sld xmlns:a="http://schemas.openxmlformats.org/drawingml/2006/main" xmlns:r="http://schemas.openxmlformats.org/officeDocument/2006/relationships" xmlns:p="http://schemas.openxmlformats.org/presentationml/2006/main">
-  <p:cSld name="Slide 22">
+  <p:cSld name="Slide 23">
     <p:bg>
       <p:bgPr>
         <a:solidFill>
@@ -4982,9 +5127,9 @@
 </p:sld>
 </file>
 
-<file path=ppt/slides/slide23.xml><?xml version="1.0" encoding="utf-8"?>
+<file path=ppt/slides/slide24.xml><?xml version="1.0" encoding="utf-8"?>
 <p:sld xmlns:a="http://schemas.openxmlformats.org/drawingml/2006/main" xmlns:r="http://schemas.openxmlformats.org/officeDocument/2006/relationships" xmlns:p="http://schemas.openxmlformats.org/presentationml/2006/main">
-  <p:cSld name="Slide 23">
+  <p:cSld name="Slide 24">
     <p:bg>
       <p:bgPr>
         <a:solidFill>
@@ -5198,6 +5343,1187 @@
 <file path=ppt/slides/slide3.xml><?xml version="1.0" encoding="utf-8"?>
 <p:sld xmlns:a="http://schemas.openxmlformats.org/drawingml/2006/main" xmlns:r="http://schemas.openxmlformats.org/officeDocument/2006/relationships" xmlns:p="http://schemas.openxmlformats.org/presentationml/2006/main">
   <p:cSld name="Slide 3">
+    <p:bg>
+      <p:bgPr>
+        <a:solidFill>
+          <a:srgbClr val="F7F5F0"/>
+        </a:solidFill>
+      </p:bgPr>
+    </p:bg>
+    <p:spTree>
+      <p:nvGrpSpPr>
+        <p:cNvPr id="1" name=""/>
+        <p:cNvGrpSpPr/>
+        <p:nvPr/>
+      </p:nvGrpSpPr>
+      <p:grpSpPr>
+        <a:xfrm>
+          <a:off x="0" y="0"/>
+          <a:ext cx="0" cy="0"/>
+          <a:chOff x="0" y="0"/>
+          <a:chExt cx="0" cy="0"/>
+        </a:xfrm>
+      </p:grpSpPr>
+      <p:sp>
+        <p:nvSpPr>
+          <p:cNvPr id="2" name="Text 0"/>
+          <p:cNvSpPr txBox="1"/>
+          <p:nvPr/>
+        </p:nvSpPr>
+        <p:spPr>
+          <a:xfrm>
+            <a:off x="548640" y="365760"/>
+            <a:ext cx="5486400" cy="274320"/>
+          </a:xfrm>
+          <a:prstGeom prst="rect">
+            <a:avLst/>
+          </a:prstGeom>
+          <a:noFill/>
+          <a:ln/>
+        </p:spPr>
+        <p:txBody>
+          <a:bodyPr wrap="square" lIns="0" tIns="0" rIns="0" bIns="0" rtlCol="0" anchor="ctr"/>
+          <a:lstStyle/>
+          <a:p>
+            <a:pPr indent="0" marL="0">
+              <a:buNone/>
+            </a:pPr>
+            <a:r>
+              <a:rPr lang="en-US" sz="1100" spc="800" kern="0" dirty="0">
+                <a:solidFill>
+                  <a:srgbClr val="A67C3D"/>
+                </a:solidFill>
+                <a:latin typeface="Arial" pitchFamily="34" charset="0"/>
+                <a:ea typeface="Arial" pitchFamily="34" charset="-122"/>
+                <a:cs typeface="Arial" pitchFamily="34" charset="-120"/>
+              </a:rPr>
+              <a:t>CĂN CỨ BIÊN SOẠN</a:t>
+            </a:r>
+            <a:endParaRPr lang="en-US" sz="1100" dirty="0"/>
+          </a:p>
+        </p:txBody>
+      </p:sp>
+      <p:sp>
+        <p:nvSpPr>
+          <p:cNvPr id="3" name="Text 1"/>
+          <p:cNvSpPr txBox="1"/>
+          <p:nvPr/>
+        </p:nvSpPr>
+        <p:spPr>
+          <a:xfrm>
+            <a:off x="548640" y="640080"/>
+            <a:ext cx="8046720" cy="548640"/>
+          </a:xfrm>
+          <a:prstGeom prst="rect">
+            <a:avLst/>
+          </a:prstGeom>
+          <a:noFill/>
+          <a:ln/>
+        </p:spPr>
+        <p:txBody>
+          <a:bodyPr wrap="square" lIns="0" tIns="0" rIns="0" bIns="0" rtlCol="0" anchor="ctr"/>
+          <a:lstStyle/>
+          <a:p>
+            <a:pPr indent="0" marL="0">
+              <a:buNone/>
+            </a:pPr>
+            <a:r>
+              <a:rPr lang="en-US" sz="2600" dirty="0">
+                <a:solidFill>
+                  <a:srgbClr val="1B1F24"/>
+                </a:solidFill>
+                <a:latin typeface="Cambria" pitchFamily="34" charset="0"/>
+                <a:ea typeface="Cambria" pitchFamily="34" charset="-122"/>
+                <a:cs typeface="Cambria" pitchFamily="34" charset="-120"/>
+              </a:rPr>
+              <a:t>Dựa trên văn bản 2025-2026, hướng tới 2030</a:t>
+            </a:r>
+            <a:endParaRPr lang="en-US" sz="2600" dirty="0"/>
+          </a:p>
+        </p:txBody>
+      </p:sp>
+      <p:graphicFrame>
+        <p:nvGraphicFramePr>
+          <p:cNvPr id="4" name="Table 0"/>
+          <p:cNvGraphicFramePr>
+            <a:graphicFrameLocks noGrp="1"/>
+          </p:cNvGraphicFramePr>
+          <p:nvPr>
+            <p:extLst>
+              <p:ext uri="{D42A27DB-BD31-4B8C-83A1-F6EECF244321}">
+                <p14:modId xmlns:p14="http://schemas.microsoft.com/office/powerpoint/2010/main" val="1579011935"/>
+              </p:ext>
+            </p:extLst>
+          </p:nvPr>
+        </p:nvGraphicFramePr>
+        <p:xfrm>
+          <a:off x="548640" y="1371600"/>
+          <a:ext cx="8046720" cy="914400"/>
+        </p:xfrm>
+        <a:graphic>
+          <a:graphicData uri="http://schemas.openxmlformats.org/drawingml/2006/table">
+            <a:tbl>
+              <a:tblPr/>
+              <a:tblGrid>
+                <a:gridCol w="2834640"/>
+                <a:gridCol w="2468880"/>
+                <a:gridCol w="2743200"/>
+              </a:tblGrid>
+              <a:tr h="365760">
+                <a:tc>
+                  <a:txBody>
+                    <a:bodyPr/>
+                    <a:lstStyle/>
+                    <a:p>
+                      <a:pPr indent="0" marL="0">
+                        <a:buNone/>
+                      </a:pPr>
+                      <a:r>
+                        <a:rPr lang="en-US" sz="1200" dirty="0">
+                          <a:solidFill>
+                            <a:srgbClr val="1B1F24"/>
+                          </a:solidFill>
+                          <a:latin typeface="Cambria" pitchFamily="34" charset="0"/>
+                          <a:ea typeface="Cambria" pitchFamily="34" charset="-122"/>
+                          <a:cs typeface="Cambria" pitchFamily="34" charset="-120"/>
+                        </a:rPr>
+                        <a:t>Chiến lược quốc gia về AI đến 2030</a:t>
+                      </a:r>
+                      <a:endParaRPr lang="en-US" sz="1200" dirty="0">
+                        <a:latin typeface="Cambria" charset="0"/>
+                        <a:ea typeface="Cambria" charset="0"/>
+                        <a:cs typeface="Cambria" charset="0"/>
+                      </a:endParaRPr>
+                    </a:p>
+                  </a:txBody>
+                  <a:tcPr marL="0" marR="54864" marT="0" marB="0" anchor="ctr">
+                    <a:lnL w="0" cap="flat" cmpd="sng" algn="ctr">
+                      <a:noFill/>
+                    </a:lnL>
+                    <a:lnR w="0" cap="flat" cmpd="sng" algn="ctr">
+                      <a:noFill/>
+                    </a:lnR>
+                    <a:lnT w="0" cap="flat" cmpd="sng" algn="ctr">
+                      <a:noFill/>
+                    </a:lnT>
+                    <a:lnB w="6350" cap="flat" cmpd="sng" algn="ctr">
+                      <a:solidFill>
+                        <a:srgbClr val="CFCAC0"/>
+                      </a:solidFill>
+                      <a:prstDash val="solid"/>
+                      <a:round/>
+                      <a:headEnd type="none" w="med" len="med"/>
+                      <a:tailEnd type="none" w="med" len="med"/>
+                    </a:lnB>
+                  </a:tcPr>
+                </a:tc>
+                <a:tc>
+                  <a:txBody>
+                    <a:bodyPr/>
+                    <a:lstStyle/>
+                    <a:p>
+                      <a:pPr indent="0" marL="0">
+                        <a:buNone/>
+                      </a:pPr>
+                      <a:r>
+                        <a:rPr lang="en-US" sz="1000" dirty="0">
+                          <a:solidFill>
+                            <a:srgbClr val="A67C3D"/>
+                          </a:solidFill>
+                          <a:latin typeface="Arial" pitchFamily="34" charset="0"/>
+                          <a:ea typeface="Arial" pitchFamily="34" charset="-122"/>
+                          <a:cs typeface="Arial" pitchFamily="34" charset="-120"/>
+                        </a:rPr>
+                        <a:t>QĐ 1671/QĐ-TTg · 28/8/2026</a:t>
+                      </a:r>
+                      <a:endParaRPr lang="en-US" sz="1000" dirty="0">
+                        <a:latin typeface="Arial" charset="0"/>
+                        <a:ea typeface="Arial" charset="0"/>
+                        <a:cs typeface="Arial" charset="0"/>
+                      </a:endParaRPr>
+                    </a:p>
+                  </a:txBody>
+                  <a:tcPr marL="0" marR="54864" marT="0" marB="0" anchor="ctr">
+                    <a:lnL w="0" cap="flat" cmpd="sng" algn="ctr">
+                      <a:noFill/>
+                    </a:lnL>
+                    <a:lnR w="0" cap="flat" cmpd="sng" algn="ctr">
+                      <a:noFill/>
+                    </a:lnR>
+                    <a:lnT w="0" cap="flat" cmpd="sng" algn="ctr">
+                      <a:noFill/>
+                    </a:lnT>
+                    <a:lnB w="6350" cap="flat" cmpd="sng" algn="ctr">
+                      <a:solidFill>
+                        <a:srgbClr val="CFCAC0"/>
+                      </a:solidFill>
+                      <a:prstDash val="solid"/>
+                      <a:round/>
+                      <a:headEnd type="none" w="med" len="med"/>
+                      <a:tailEnd type="none" w="med" len="med"/>
+                    </a:lnB>
+                  </a:tcPr>
+                </a:tc>
+                <a:tc>
+                  <a:txBody>
+                    <a:bodyPr/>
+                    <a:lstStyle/>
+                    <a:p>
+                      <a:pPr indent="0" marL="0">
+                        <a:buNone/>
+                      </a:pPr>
+                      <a:r>
+                        <a:rPr lang="en-US" sz="1000" dirty="0">
+                          <a:solidFill>
+                            <a:srgbClr val="1B1F24"/>
+                          </a:solidFill>
+                          <a:latin typeface="Arial" pitchFamily="34" charset="0"/>
+                          <a:ea typeface="Arial" pitchFamily="34" charset="-122"/>
+                          <a:cs typeface="Arial" pitchFamily="34" charset="-120"/>
+                        </a:rPr>
+                        <a:t>AI là năng lực cốt lõi quốc gia</a:t>
+                      </a:r>
+                      <a:endParaRPr lang="en-US" sz="1000" dirty="0">
+                        <a:latin typeface="Arial" charset="0"/>
+                        <a:ea typeface="Arial" charset="0"/>
+                        <a:cs typeface="Arial" charset="0"/>
+                      </a:endParaRPr>
+                    </a:p>
+                  </a:txBody>
+                  <a:tcPr marL="0" marR="54864" marT="0" marB="0" anchor="ctr">
+                    <a:lnL w="0" cap="flat" cmpd="sng" algn="ctr">
+                      <a:noFill/>
+                    </a:lnL>
+                    <a:lnR w="0" cap="flat" cmpd="sng" algn="ctr">
+                      <a:noFill/>
+                    </a:lnR>
+                    <a:lnT w="0" cap="flat" cmpd="sng" algn="ctr">
+                      <a:noFill/>
+                    </a:lnT>
+                    <a:lnB w="6350" cap="flat" cmpd="sng" algn="ctr">
+                      <a:solidFill>
+                        <a:srgbClr val="CFCAC0"/>
+                      </a:solidFill>
+                      <a:prstDash val="solid"/>
+                      <a:round/>
+                      <a:headEnd type="none" w="med" len="med"/>
+                      <a:tailEnd type="none" w="med" len="med"/>
+                    </a:lnB>
+                  </a:tcPr>
+                </a:tc>
+              </a:tr>
+              <a:tr h="365760">
+                <a:tc>
+                  <a:txBody>
+                    <a:bodyPr/>
+                    <a:lstStyle/>
+                    <a:p>
+                      <a:pPr indent="0" marL="0">
+                        <a:buNone/>
+                      </a:pPr>
+                      <a:r>
+                        <a:rPr lang="en-US" sz="1200" dirty="0">
+                          <a:solidFill>
+                            <a:srgbClr val="1B1F24"/>
+                          </a:solidFill>
+                          <a:latin typeface="Cambria" pitchFamily="34" charset="0"/>
+                          <a:ea typeface="Cambria" pitchFamily="34" charset="-122"/>
+                          <a:cs typeface="Cambria" pitchFamily="34" charset="-120"/>
+                        </a:rPr>
+                        <a:t>Phát triển nhân lực AI đến 2030</a:t>
+                      </a:r>
+                      <a:endParaRPr lang="en-US" sz="1200" dirty="0">
+                        <a:latin typeface="Cambria" charset="0"/>
+                        <a:ea typeface="Cambria" charset="0"/>
+                        <a:cs typeface="Cambria" charset="0"/>
+                      </a:endParaRPr>
+                    </a:p>
+                  </a:txBody>
+                  <a:tcPr marL="0" marR="54864" marT="0" marB="0" anchor="ctr">
+                    <a:lnL w="0" cap="flat" cmpd="sng" algn="ctr">
+                      <a:noFill/>
+                    </a:lnL>
+                    <a:lnR w="0" cap="flat" cmpd="sng" algn="ctr">
+                      <a:noFill/>
+                    </a:lnR>
+                    <a:lnT w="0" cap="flat" cmpd="sng" algn="ctr">
+                      <a:noFill/>
+                    </a:lnT>
+                    <a:lnB w="6350" cap="flat" cmpd="sng" algn="ctr">
+                      <a:solidFill>
+                        <a:srgbClr val="CFCAC0"/>
+                      </a:solidFill>
+                      <a:prstDash val="solid"/>
+                      <a:round/>
+                      <a:headEnd type="none" w="med" len="med"/>
+                      <a:tailEnd type="none" w="med" len="med"/>
+                    </a:lnB>
+                  </a:tcPr>
+                </a:tc>
+                <a:tc>
+                  <a:txBody>
+                    <a:bodyPr/>
+                    <a:lstStyle/>
+                    <a:p>
+                      <a:pPr indent="0" marL="0">
+                        <a:buNone/>
+                      </a:pPr>
+                      <a:r>
+                        <a:rPr lang="en-US" sz="1000" dirty="0">
+                          <a:solidFill>
+                            <a:srgbClr val="A67C3D"/>
+                          </a:solidFill>
+                          <a:latin typeface="Arial" pitchFamily="34" charset="0"/>
+                          <a:ea typeface="Arial" pitchFamily="34" charset="-122"/>
+                          <a:cs typeface="Arial" pitchFamily="34" charset="-120"/>
+                        </a:rPr>
+                        <a:t>QĐ 1528/QĐ-TTg · 2026</a:t>
+                      </a:r>
+                      <a:endParaRPr lang="en-US" sz="1000" dirty="0">
+                        <a:latin typeface="Arial" charset="0"/>
+                        <a:ea typeface="Arial" charset="0"/>
+                        <a:cs typeface="Arial" charset="0"/>
+                      </a:endParaRPr>
+                    </a:p>
+                  </a:txBody>
+                  <a:tcPr marL="0" marR="54864" marT="0" marB="0" anchor="ctr">
+                    <a:lnL w="0" cap="flat" cmpd="sng" algn="ctr">
+                      <a:noFill/>
+                    </a:lnL>
+                    <a:lnR w="0" cap="flat" cmpd="sng" algn="ctr">
+                      <a:noFill/>
+                    </a:lnR>
+                    <a:lnT w="0" cap="flat" cmpd="sng" algn="ctr">
+                      <a:noFill/>
+                    </a:lnT>
+                    <a:lnB w="6350" cap="flat" cmpd="sng" algn="ctr">
+                      <a:solidFill>
+                        <a:srgbClr val="CFCAC0"/>
+                      </a:solidFill>
+                      <a:prstDash val="solid"/>
+                      <a:round/>
+                      <a:headEnd type="none" w="med" len="med"/>
+                      <a:tailEnd type="none" w="med" len="med"/>
+                    </a:lnB>
+                  </a:tcPr>
+                </a:tc>
+                <a:tc>
+                  <a:txBody>
+                    <a:bodyPr/>
+                    <a:lstStyle/>
+                    <a:p>
+                      <a:pPr indent="0" marL="0">
+                        <a:buNone/>
+                      </a:pPr>
+                      <a:r>
+                        <a:rPr lang="en-US" sz="1000" dirty="0">
+                          <a:solidFill>
+                            <a:srgbClr val="1B1F24"/>
+                          </a:solidFill>
+                          <a:latin typeface="Arial" pitchFamily="34" charset="0"/>
+                          <a:ea typeface="Arial" pitchFamily="34" charset="-122"/>
+                          <a:cs typeface="Arial" pitchFamily="34" charset="-120"/>
+                        </a:rPr>
+                        <a:t>Nâng năng lực AI của người lao động</a:t>
+                      </a:r>
+                      <a:endParaRPr lang="en-US" sz="1000" dirty="0">
+                        <a:latin typeface="Arial" charset="0"/>
+                        <a:ea typeface="Arial" charset="0"/>
+                        <a:cs typeface="Arial" charset="0"/>
+                      </a:endParaRPr>
+                    </a:p>
+                  </a:txBody>
+                  <a:tcPr marL="0" marR="54864" marT="0" marB="0" anchor="ctr">
+                    <a:lnL w="0" cap="flat" cmpd="sng" algn="ctr">
+                      <a:noFill/>
+                    </a:lnL>
+                    <a:lnR w="0" cap="flat" cmpd="sng" algn="ctr">
+                      <a:noFill/>
+                    </a:lnR>
+                    <a:lnT w="0" cap="flat" cmpd="sng" algn="ctr">
+                      <a:noFill/>
+                    </a:lnT>
+                    <a:lnB w="6350" cap="flat" cmpd="sng" algn="ctr">
+                      <a:solidFill>
+                        <a:srgbClr val="CFCAC0"/>
+                      </a:solidFill>
+                      <a:prstDash val="solid"/>
+                      <a:round/>
+                      <a:headEnd type="none" w="med" len="med"/>
+                      <a:tailEnd type="none" w="med" len="med"/>
+                    </a:lnB>
+                  </a:tcPr>
+                </a:tc>
+              </a:tr>
+              <a:tr h="365760">
+                <a:tc>
+                  <a:txBody>
+                    <a:bodyPr/>
+                    <a:lstStyle/>
+                    <a:p>
+                      <a:pPr indent="0" marL="0">
+                        <a:buNone/>
+                      </a:pPr>
+                      <a:r>
+                        <a:rPr lang="en-US" sz="1200" dirty="0">
+                          <a:solidFill>
+                            <a:srgbClr val="1B1F24"/>
+                          </a:solidFill>
+                          <a:latin typeface="Cambria" pitchFamily="34" charset="0"/>
+                          <a:ea typeface="Cambria" pitchFamily="34" charset="-122"/>
+                          <a:cs typeface="Cambria" pitchFamily="34" charset="-120"/>
+                        </a:rPr>
+                        <a:t>Đột phá phát triển giáo dục</a:t>
+                      </a:r>
+                      <a:endParaRPr lang="en-US" sz="1200" dirty="0">
+                        <a:latin typeface="Cambria" charset="0"/>
+                        <a:ea typeface="Cambria" charset="0"/>
+                        <a:cs typeface="Cambria" charset="0"/>
+                      </a:endParaRPr>
+                    </a:p>
+                  </a:txBody>
+                  <a:tcPr marL="0" marR="54864" marT="0" marB="0" anchor="ctr">
+                    <a:lnL w="0" cap="flat" cmpd="sng" algn="ctr">
+                      <a:noFill/>
+                    </a:lnL>
+                    <a:lnR w="0" cap="flat" cmpd="sng" algn="ctr">
+                      <a:noFill/>
+                    </a:lnR>
+                    <a:lnT w="0" cap="flat" cmpd="sng" algn="ctr">
+                      <a:noFill/>
+                    </a:lnT>
+                    <a:lnB w="6350" cap="flat" cmpd="sng" algn="ctr">
+                      <a:solidFill>
+                        <a:srgbClr val="CFCAC0"/>
+                      </a:solidFill>
+                      <a:prstDash val="solid"/>
+                      <a:round/>
+                      <a:headEnd type="none" w="med" len="med"/>
+                      <a:tailEnd type="none" w="med" len="med"/>
+                    </a:lnB>
+                  </a:tcPr>
+                </a:tc>
+                <a:tc>
+                  <a:txBody>
+                    <a:bodyPr/>
+                    <a:lstStyle/>
+                    <a:p>
+                      <a:pPr indent="0" marL="0">
+                        <a:buNone/>
+                      </a:pPr>
+                      <a:r>
+                        <a:rPr lang="en-US" sz="1000" dirty="0">
+                          <a:solidFill>
+                            <a:srgbClr val="A67C3D"/>
+                          </a:solidFill>
+                          <a:latin typeface="Arial" pitchFamily="34" charset="0"/>
+                          <a:ea typeface="Arial" pitchFamily="34" charset="-122"/>
+                          <a:cs typeface="Arial" pitchFamily="34" charset="-120"/>
+                        </a:rPr>
+                        <a:t>NQ 71-NQ/TW · 22/8/2025</a:t>
+                      </a:r>
+                      <a:endParaRPr lang="en-US" sz="1000" dirty="0">
+                        <a:latin typeface="Arial" charset="0"/>
+                        <a:ea typeface="Arial" charset="0"/>
+                        <a:cs typeface="Arial" charset="0"/>
+                      </a:endParaRPr>
+                    </a:p>
+                  </a:txBody>
+                  <a:tcPr marL="0" marR="54864" marT="0" marB="0" anchor="ctr">
+                    <a:lnL w="0" cap="flat" cmpd="sng" algn="ctr">
+                      <a:noFill/>
+                    </a:lnL>
+                    <a:lnR w="0" cap="flat" cmpd="sng" algn="ctr">
+                      <a:noFill/>
+                    </a:lnR>
+                    <a:lnT w="0" cap="flat" cmpd="sng" algn="ctr">
+                      <a:noFill/>
+                    </a:lnT>
+                    <a:lnB w="6350" cap="flat" cmpd="sng" algn="ctr">
+                      <a:solidFill>
+                        <a:srgbClr val="CFCAC0"/>
+                      </a:solidFill>
+                      <a:prstDash val="solid"/>
+                      <a:round/>
+                      <a:headEnd type="none" w="med" len="med"/>
+                      <a:tailEnd type="none" w="med" len="med"/>
+                    </a:lnB>
+                  </a:tcPr>
+                </a:tc>
+                <a:tc>
+                  <a:txBody>
+                    <a:bodyPr/>
+                    <a:lstStyle/>
+                    <a:p>
+                      <a:pPr indent="0" marL="0">
+                        <a:buNone/>
+                      </a:pPr>
+                      <a:r>
+                        <a:rPr lang="en-US" sz="1000" dirty="0">
+                          <a:solidFill>
+                            <a:srgbClr val="1B1F24"/>
+                          </a:solidFill>
+                          <a:latin typeface="Arial" pitchFamily="34" charset="0"/>
+                          <a:ea typeface="Arial" pitchFamily="34" charset="-122"/>
+                          <a:cs typeface="Arial" pitchFamily="34" charset="-120"/>
+                        </a:rPr>
+                        <a:t>Mục tiêu giáo dục đến 2030, 2045</a:t>
+                      </a:r>
+                      <a:endParaRPr lang="en-US" sz="1000" dirty="0">
+                        <a:latin typeface="Arial" charset="0"/>
+                        <a:ea typeface="Arial" charset="0"/>
+                        <a:cs typeface="Arial" charset="0"/>
+                      </a:endParaRPr>
+                    </a:p>
+                  </a:txBody>
+                  <a:tcPr marL="0" marR="54864" marT="0" marB="0" anchor="ctr">
+                    <a:lnL w="0" cap="flat" cmpd="sng" algn="ctr">
+                      <a:noFill/>
+                    </a:lnL>
+                    <a:lnR w="0" cap="flat" cmpd="sng" algn="ctr">
+                      <a:noFill/>
+                    </a:lnR>
+                    <a:lnT w="0" cap="flat" cmpd="sng" algn="ctr">
+                      <a:noFill/>
+                    </a:lnT>
+                    <a:lnB w="6350" cap="flat" cmpd="sng" algn="ctr">
+                      <a:solidFill>
+                        <a:srgbClr val="CFCAC0"/>
+                      </a:solidFill>
+                      <a:prstDash val="solid"/>
+                      <a:round/>
+                      <a:headEnd type="none" w="med" len="med"/>
+                      <a:tailEnd type="none" w="med" len="med"/>
+                    </a:lnB>
+                  </a:tcPr>
+                </a:tc>
+              </a:tr>
+              <a:tr h="365760">
+                <a:tc>
+                  <a:txBody>
+                    <a:bodyPr/>
+                    <a:lstStyle/>
+                    <a:p>
+                      <a:pPr indent="0" marL="0">
+                        <a:buNone/>
+                      </a:pPr>
+                      <a:r>
+                        <a:rPr lang="en-US" sz="1200" dirty="0">
+                          <a:solidFill>
+                            <a:srgbClr val="1B1F24"/>
+                          </a:solidFill>
+                          <a:latin typeface="Cambria" pitchFamily="34" charset="0"/>
+                          <a:ea typeface="Cambria" pitchFamily="34" charset="-122"/>
+                          <a:cs typeface="Cambria" pitchFamily="34" charset="-120"/>
+                        </a:rPr>
+                        <a:t>Luật Trí tuệ nhân tạo</a:t>
+                      </a:r>
+                      <a:endParaRPr lang="en-US" sz="1200" dirty="0">
+                        <a:latin typeface="Cambria" charset="0"/>
+                        <a:ea typeface="Cambria" charset="0"/>
+                        <a:cs typeface="Cambria" charset="0"/>
+                      </a:endParaRPr>
+                    </a:p>
+                  </a:txBody>
+                  <a:tcPr marL="0" marR="54864" marT="0" marB="0" anchor="ctr">
+                    <a:lnL w="0" cap="flat" cmpd="sng" algn="ctr">
+                      <a:noFill/>
+                    </a:lnL>
+                    <a:lnR w="0" cap="flat" cmpd="sng" algn="ctr">
+                      <a:noFill/>
+                    </a:lnR>
+                    <a:lnT w="0" cap="flat" cmpd="sng" algn="ctr">
+                      <a:noFill/>
+                    </a:lnT>
+                    <a:lnB w="6350" cap="flat" cmpd="sng" algn="ctr">
+                      <a:solidFill>
+                        <a:srgbClr val="CFCAC0"/>
+                      </a:solidFill>
+                      <a:prstDash val="solid"/>
+                      <a:round/>
+                      <a:headEnd type="none" w="med" len="med"/>
+                      <a:tailEnd type="none" w="med" len="med"/>
+                    </a:lnB>
+                  </a:tcPr>
+                </a:tc>
+                <a:tc>
+                  <a:txBody>
+                    <a:bodyPr/>
+                    <a:lstStyle/>
+                    <a:p>
+                      <a:pPr indent="0" marL="0">
+                        <a:buNone/>
+                      </a:pPr>
+                      <a:r>
+                        <a:rPr lang="en-US" sz="1000" dirty="0">
+                          <a:solidFill>
+                            <a:srgbClr val="A67C3D"/>
+                          </a:solidFill>
+                          <a:latin typeface="Arial" pitchFamily="34" charset="0"/>
+                          <a:ea typeface="Arial" pitchFamily="34" charset="-122"/>
+                          <a:cs typeface="Arial" pitchFamily="34" charset="-120"/>
+                        </a:rPr>
+                        <a:t>134/2025/QH15 · hiệu lực 01/3/2026</a:t>
+                      </a:r>
+                      <a:endParaRPr lang="en-US" sz="1000" dirty="0">
+                        <a:latin typeface="Arial" charset="0"/>
+                        <a:ea typeface="Arial" charset="0"/>
+                        <a:cs typeface="Arial" charset="0"/>
+                      </a:endParaRPr>
+                    </a:p>
+                  </a:txBody>
+                  <a:tcPr marL="0" marR="54864" marT="0" marB="0" anchor="ctr">
+                    <a:lnL w="0" cap="flat" cmpd="sng" algn="ctr">
+                      <a:noFill/>
+                    </a:lnL>
+                    <a:lnR w="0" cap="flat" cmpd="sng" algn="ctr">
+                      <a:noFill/>
+                    </a:lnR>
+                    <a:lnT w="0" cap="flat" cmpd="sng" algn="ctr">
+                      <a:noFill/>
+                    </a:lnT>
+                    <a:lnB w="6350" cap="flat" cmpd="sng" algn="ctr">
+                      <a:solidFill>
+                        <a:srgbClr val="CFCAC0"/>
+                      </a:solidFill>
+                      <a:prstDash val="solid"/>
+                      <a:round/>
+                      <a:headEnd type="none" w="med" len="med"/>
+                      <a:tailEnd type="none" w="med" len="med"/>
+                    </a:lnB>
+                  </a:tcPr>
+                </a:tc>
+                <a:tc>
+                  <a:txBody>
+                    <a:bodyPr/>
+                    <a:lstStyle/>
+                    <a:p>
+                      <a:pPr indent="0" marL="0">
+                        <a:buNone/>
+                      </a:pPr>
+                      <a:r>
+                        <a:rPr lang="en-US" sz="1000" dirty="0">
+                          <a:solidFill>
+                            <a:srgbClr val="1B1F24"/>
+                          </a:solidFill>
+                          <a:latin typeface="Arial" pitchFamily="34" charset="0"/>
+                          <a:ea typeface="Arial" pitchFamily="34" charset="-122"/>
+                          <a:cs typeface="Arial" pitchFamily="34" charset="-120"/>
+                        </a:rPr>
+                        <a:t>Con người quyết định, gắn nhãn nội dung AI</a:t>
+                      </a:r>
+                      <a:endParaRPr lang="en-US" sz="1000" dirty="0">
+                        <a:latin typeface="Arial" charset="0"/>
+                        <a:ea typeface="Arial" charset="0"/>
+                        <a:cs typeface="Arial" charset="0"/>
+                      </a:endParaRPr>
+                    </a:p>
+                  </a:txBody>
+                  <a:tcPr marL="0" marR="54864" marT="0" marB="0" anchor="ctr">
+                    <a:lnL w="0" cap="flat" cmpd="sng" algn="ctr">
+                      <a:noFill/>
+                    </a:lnL>
+                    <a:lnR w="0" cap="flat" cmpd="sng" algn="ctr">
+                      <a:noFill/>
+                    </a:lnR>
+                    <a:lnT w="0" cap="flat" cmpd="sng" algn="ctr">
+                      <a:noFill/>
+                    </a:lnT>
+                    <a:lnB w="6350" cap="flat" cmpd="sng" algn="ctr">
+                      <a:solidFill>
+                        <a:srgbClr val="CFCAC0"/>
+                      </a:solidFill>
+                      <a:prstDash val="solid"/>
+                      <a:round/>
+                      <a:headEnd type="none" w="med" len="med"/>
+                      <a:tailEnd type="none" w="med" len="med"/>
+                    </a:lnB>
+                  </a:tcPr>
+                </a:tc>
+              </a:tr>
+              <a:tr h="365760">
+                <a:tc>
+                  <a:txBody>
+                    <a:bodyPr/>
+                    <a:lstStyle/>
+                    <a:p>
+                      <a:pPr indent="0" marL="0">
+                        <a:buNone/>
+                      </a:pPr>
+                      <a:r>
+                        <a:rPr lang="en-US" sz="1200" dirty="0">
+                          <a:solidFill>
+                            <a:srgbClr val="1B1F24"/>
+                          </a:solidFill>
+                          <a:latin typeface="Cambria" pitchFamily="34" charset="0"/>
+                          <a:ea typeface="Cambria" pitchFamily="34" charset="-122"/>
+                          <a:cs typeface="Cambria" pitchFamily="34" charset="-120"/>
+                        </a:rPr>
+                        <a:t>Luật Bảo vệ dữ liệu cá nhân</a:t>
+                      </a:r>
+                      <a:endParaRPr lang="en-US" sz="1200" dirty="0">
+                        <a:latin typeface="Cambria" charset="0"/>
+                        <a:ea typeface="Cambria" charset="0"/>
+                        <a:cs typeface="Cambria" charset="0"/>
+                      </a:endParaRPr>
+                    </a:p>
+                  </a:txBody>
+                  <a:tcPr marL="0" marR="54864" marT="0" marB="0" anchor="ctr">
+                    <a:lnL w="0" cap="flat" cmpd="sng" algn="ctr">
+                      <a:noFill/>
+                    </a:lnL>
+                    <a:lnR w="0" cap="flat" cmpd="sng" algn="ctr">
+                      <a:noFill/>
+                    </a:lnR>
+                    <a:lnT w="0" cap="flat" cmpd="sng" algn="ctr">
+                      <a:noFill/>
+                    </a:lnT>
+                    <a:lnB w="6350" cap="flat" cmpd="sng" algn="ctr">
+                      <a:solidFill>
+                        <a:srgbClr val="CFCAC0"/>
+                      </a:solidFill>
+                      <a:prstDash val="solid"/>
+                      <a:round/>
+                      <a:headEnd type="none" w="med" len="med"/>
+                      <a:tailEnd type="none" w="med" len="med"/>
+                    </a:lnB>
+                  </a:tcPr>
+                </a:tc>
+                <a:tc>
+                  <a:txBody>
+                    <a:bodyPr/>
+                    <a:lstStyle/>
+                    <a:p>
+                      <a:pPr indent="0" marL="0">
+                        <a:buNone/>
+                      </a:pPr>
+                      <a:r>
+                        <a:rPr lang="en-US" sz="1000" dirty="0">
+                          <a:solidFill>
+                            <a:srgbClr val="A67C3D"/>
+                          </a:solidFill>
+                          <a:latin typeface="Arial" pitchFamily="34" charset="0"/>
+                          <a:ea typeface="Arial" pitchFamily="34" charset="-122"/>
+                          <a:cs typeface="Arial" pitchFamily="34" charset="-120"/>
+                        </a:rPr>
+                        <a:t>91/2025/QH15 · hiệu lực 01/1/2026</a:t>
+                      </a:r>
+                      <a:endParaRPr lang="en-US" sz="1000" dirty="0">
+                        <a:latin typeface="Arial" charset="0"/>
+                        <a:ea typeface="Arial" charset="0"/>
+                        <a:cs typeface="Arial" charset="0"/>
+                      </a:endParaRPr>
+                    </a:p>
+                  </a:txBody>
+                  <a:tcPr marL="0" marR="54864" marT="0" marB="0" anchor="ctr">
+                    <a:lnL w="0" cap="flat" cmpd="sng" algn="ctr">
+                      <a:noFill/>
+                    </a:lnL>
+                    <a:lnR w="0" cap="flat" cmpd="sng" algn="ctr">
+                      <a:noFill/>
+                    </a:lnR>
+                    <a:lnT w="0" cap="flat" cmpd="sng" algn="ctr">
+                      <a:noFill/>
+                    </a:lnT>
+                    <a:lnB w="6350" cap="flat" cmpd="sng" algn="ctr">
+                      <a:solidFill>
+                        <a:srgbClr val="CFCAC0"/>
+                      </a:solidFill>
+                      <a:prstDash val="solid"/>
+                      <a:round/>
+                      <a:headEnd type="none" w="med" len="med"/>
+                      <a:tailEnd type="none" w="med" len="med"/>
+                    </a:lnB>
+                  </a:tcPr>
+                </a:tc>
+                <a:tc>
+                  <a:txBody>
+                    <a:bodyPr/>
+                    <a:lstStyle/>
+                    <a:p>
+                      <a:pPr indent="0" marL="0">
+                        <a:buNone/>
+                      </a:pPr>
+                      <a:r>
+                        <a:rPr lang="en-US" sz="1000" dirty="0">
+                          <a:solidFill>
+                            <a:srgbClr val="1B1F24"/>
+                          </a:solidFill>
+                          <a:latin typeface="Arial" pitchFamily="34" charset="0"/>
+                          <a:ea typeface="Arial" pitchFamily="34" charset="-122"/>
+                          <a:cs typeface="Arial" pitchFamily="34" charset="-120"/>
+                        </a:rPr>
+                        <a:t>Không đưa dữ liệu học sinh vào AI</a:t>
+                      </a:r>
+                      <a:endParaRPr lang="en-US" sz="1000" dirty="0">
+                        <a:latin typeface="Arial" charset="0"/>
+                        <a:ea typeface="Arial" charset="0"/>
+                        <a:cs typeface="Arial" charset="0"/>
+                      </a:endParaRPr>
+                    </a:p>
+                  </a:txBody>
+                  <a:tcPr marL="0" marR="54864" marT="0" marB="0" anchor="ctr">
+                    <a:lnL w="0" cap="flat" cmpd="sng" algn="ctr">
+                      <a:noFill/>
+                    </a:lnL>
+                    <a:lnR w="0" cap="flat" cmpd="sng" algn="ctr">
+                      <a:noFill/>
+                    </a:lnR>
+                    <a:lnT w="0" cap="flat" cmpd="sng" algn="ctr">
+                      <a:noFill/>
+                    </a:lnT>
+                    <a:lnB w="6350" cap="flat" cmpd="sng" algn="ctr">
+                      <a:solidFill>
+                        <a:srgbClr val="CFCAC0"/>
+                      </a:solidFill>
+                      <a:prstDash val="solid"/>
+                      <a:round/>
+                      <a:headEnd type="none" w="med" len="med"/>
+                      <a:tailEnd type="none" w="med" len="med"/>
+                    </a:lnB>
+                  </a:tcPr>
+                </a:tc>
+              </a:tr>
+              <a:tr h="365760">
+                <a:tc>
+                  <a:txBody>
+                    <a:bodyPr/>
+                    <a:lstStyle/>
+                    <a:p>
+                      <a:pPr indent="0" marL="0">
+                        <a:buNone/>
+                      </a:pPr>
+                      <a:r>
+                        <a:rPr lang="en-US" sz="1200" dirty="0">
+                          <a:solidFill>
+                            <a:srgbClr val="1B1F24"/>
+                          </a:solidFill>
+                          <a:latin typeface="Cambria" pitchFamily="34" charset="0"/>
+                          <a:ea typeface="Cambria" pitchFamily="34" charset="-122"/>
+                          <a:cs typeface="Cambria" pitchFamily="34" charset="-120"/>
+                        </a:rPr>
+                        <a:t>Khung năng lực số cho người học</a:t>
+                      </a:r>
+                      <a:endParaRPr lang="en-US" sz="1200" dirty="0">
+                        <a:latin typeface="Cambria" charset="0"/>
+                        <a:ea typeface="Cambria" charset="0"/>
+                        <a:cs typeface="Cambria" charset="0"/>
+                      </a:endParaRPr>
+                    </a:p>
+                  </a:txBody>
+                  <a:tcPr marL="0" marR="54864" marT="0" marB="0" anchor="ctr">
+                    <a:lnL w="0" cap="flat" cmpd="sng" algn="ctr">
+                      <a:noFill/>
+                    </a:lnL>
+                    <a:lnR w="0" cap="flat" cmpd="sng" algn="ctr">
+                      <a:noFill/>
+                    </a:lnR>
+                    <a:lnT w="0" cap="flat" cmpd="sng" algn="ctr">
+                      <a:noFill/>
+                    </a:lnT>
+                    <a:lnB w="6350" cap="flat" cmpd="sng" algn="ctr">
+                      <a:solidFill>
+                        <a:srgbClr val="CFCAC0"/>
+                      </a:solidFill>
+                      <a:prstDash val="solid"/>
+                      <a:round/>
+                      <a:headEnd type="none" w="med" len="med"/>
+                      <a:tailEnd type="none" w="med" len="med"/>
+                    </a:lnB>
+                  </a:tcPr>
+                </a:tc>
+                <a:tc>
+                  <a:txBody>
+                    <a:bodyPr/>
+                    <a:lstStyle/>
+                    <a:p>
+                      <a:pPr indent="0" marL="0">
+                        <a:buNone/>
+                      </a:pPr>
+                      <a:r>
+                        <a:rPr lang="en-US" sz="1000" dirty="0">
+                          <a:solidFill>
+                            <a:srgbClr val="A67C3D"/>
+                          </a:solidFill>
+                          <a:latin typeface="Arial" pitchFamily="34" charset="0"/>
+                          <a:ea typeface="Arial" pitchFamily="34" charset="-122"/>
+                          <a:cs typeface="Arial" pitchFamily="34" charset="-120"/>
+                        </a:rPr>
+                        <a:t>TT 02/2025/TT-BGDĐT</a:t>
+                      </a:r>
+                      <a:endParaRPr lang="en-US" sz="1000" dirty="0">
+                        <a:latin typeface="Arial" charset="0"/>
+                        <a:ea typeface="Arial" charset="0"/>
+                        <a:cs typeface="Arial" charset="0"/>
+                      </a:endParaRPr>
+                    </a:p>
+                  </a:txBody>
+                  <a:tcPr marL="0" marR="54864" marT="0" marB="0" anchor="ctr">
+                    <a:lnL w="0" cap="flat" cmpd="sng" algn="ctr">
+                      <a:noFill/>
+                    </a:lnL>
+                    <a:lnR w="0" cap="flat" cmpd="sng" algn="ctr">
+                      <a:noFill/>
+                    </a:lnR>
+                    <a:lnT w="0" cap="flat" cmpd="sng" algn="ctr">
+                      <a:noFill/>
+                    </a:lnT>
+                    <a:lnB w="6350" cap="flat" cmpd="sng" algn="ctr">
+                      <a:solidFill>
+                        <a:srgbClr val="CFCAC0"/>
+                      </a:solidFill>
+                      <a:prstDash val="solid"/>
+                      <a:round/>
+                      <a:headEnd type="none" w="med" len="med"/>
+                      <a:tailEnd type="none" w="med" len="med"/>
+                    </a:lnB>
+                  </a:tcPr>
+                </a:tc>
+                <a:tc>
+                  <a:txBody>
+                    <a:bodyPr/>
+                    <a:lstStyle/>
+                    <a:p>
+                      <a:pPr indent="0" marL="0">
+                        <a:buNone/>
+                      </a:pPr>
+                      <a:r>
+                        <a:rPr lang="en-US" sz="1000" dirty="0">
+                          <a:solidFill>
+                            <a:srgbClr val="1B1F24"/>
+                          </a:solidFill>
+                          <a:latin typeface="Arial" pitchFamily="34" charset="0"/>
+                          <a:ea typeface="Arial" pitchFamily="34" charset="-122"/>
+                          <a:cs typeface="Arial" pitchFamily="34" charset="-120"/>
+                        </a:rPr>
+                        <a:t>Học sinh dùng AI an toàn, trung thực</a:t>
+                      </a:r>
+                      <a:endParaRPr lang="en-US" sz="1000" dirty="0">
+                        <a:latin typeface="Arial" charset="0"/>
+                        <a:ea typeface="Arial" charset="0"/>
+                        <a:cs typeface="Arial" charset="0"/>
+                      </a:endParaRPr>
+                    </a:p>
+                  </a:txBody>
+                  <a:tcPr marL="0" marR="54864" marT="0" marB="0" anchor="ctr">
+                    <a:lnL w="0" cap="flat" cmpd="sng" algn="ctr">
+                      <a:noFill/>
+                    </a:lnL>
+                    <a:lnR w="0" cap="flat" cmpd="sng" algn="ctr">
+                      <a:noFill/>
+                    </a:lnR>
+                    <a:lnT w="0" cap="flat" cmpd="sng" algn="ctr">
+                      <a:noFill/>
+                    </a:lnT>
+                    <a:lnB w="6350" cap="flat" cmpd="sng" algn="ctr">
+                      <a:solidFill>
+                        <a:srgbClr val="CFCAC0"/>
+                      </a:solidFill>
+                      <a:prstDash val="solid"/>
+                      <a:round/>
+                      <a:headEnd type="none" w="med" len="med"/>
+                      <a:tailEnd type="none" w="med" len="med"/>
+                    </a:lnB>
+                  </a:tcPr>
+                </a:tc>
+              </a:tr>
+              <a:tr h="365760">
+                <a:tc>
+                  <a:txBody>
+                    <a:bodyPr/>
+                    <a:lstStyle/>
+                    <a:p>
+                      <a:pPr indent="0" marL="0">
+                        <a:buNone/>
+                      </a:pPr>
+                      <a:r>
+                        <a:rPr lang="en-US" sz="1200" dirty="0">
+                          <a:solidFill>
+                            <a:srgbClr val="1B1F24"/>
+                          </a:solidFill>
+                          <a:latin typeface="Cambria" pitchFamily="34" charset="0"/>
+                          <a:ea typeface="Cambria" pitchFamily="34" charset="-122"/>
+                          <a:cs typeface="Cambria" pitchFamily="34" charset="-120"/>
+                        </a:rPr>
+                        <a:t>Hướng dẫn dùng AI dạy học</a:t>
+                      </a:r>
+                      <a:endParaRPr lang="en-US" sz="1200" dirty="0">
+                        <a:latin typeface="Cambria" charset="0"/>
+                        <a:ea typeface="Cambria" charset="0"/>
+                        <a:cs typeface="Cambria" charset="0"/>
+                      </a:endParaRPr>
+                    </a:p>
+                  </a:txBody>
+                  <a:tcPr marL="0" marR="54864" marT="0" marB="0" anchor="ctr">
+                    <a:lnL w="0" cap="flat" cmpd="sng" algn="ctr">
+                      <a:noFill/>
+                    </a:lnL>
+                    <a:lnR w="0" cap="flat" cmpd="sng" algn="ctr">
+                      <a:noFill/>
+                    </a:lnR>
+                    <a:lnT w="0" cap="flat" cmpd="sng" algn="ctr">
+                      <a:noFill/>
+                    </a:lnT>
+                    <a:lnB w="6350" cap="flat" cmpd="sng" algn="ctr">
+                      <a:solidFill>
+                        <a:srgbClr val="CFCAC0"/>
+                      </a:solidFill>
+                      <a:prstDash val="solid"/>
+                      <a:round/>
+                      <a:headEnd type="none" w="med" len="med"/>
+                      <a:tailEnd type="none" w="med" len="med"/>
+                    </a:lnB>
+                  </a:tcPr>
+                </a:tc>
+                <a:tc>
+                  <a:txBody>
+                    <a:bodyPr/>
+                    <a:lstStyle/>
+                    <a:p>
+                      <a:pPr indent="0" marL="0">
+                        <a:buNone/>
+                      </a:pPr>
+                      <a:r>
+                        <a:rPr lang="en-US" sz="1000" dirty="0">
+                          <a:solidFill>
+                            <a:srgbClr val="A67C3D"/>
+                          </a:solidFill>
+                          <a:latin typeface="Arial" pitchFamily="34" charset="0"/>
+                          <a:ea typeface="Arial" pitchFamily="34" charset="-122"/>
+                          <a:cs typeface="Arial" pitchFamily="34" charset="-120"/>
+                        </a:rPr>
+                        <a:t>CV 2250 · CV 5835 (2025)</a:t>
+                      </a:r>
+                      <a:endParaRPr lang="en-US" sz="1000" dirty="0">
+                        <a:latin typeface="Arial" charset="0"/>
+                        <a:ea typeface="Arial" charset="0"/>
+                        <a:cs typeface="Arial" charset="0"/>
+                      </a:endParaRPr>
+                    </a:p>
+                  </a:txBody>
+                  <a:tcPr marL="0" marR="54864" marT="0" marB="0" anchor="ctr">
+                    <a:lnL w="0" cap="flat" cmpd="sng" algn="ctr">
+                      <a:noFill/>
+                    </a:lnL>
+                    <a:lnR w="0" cap="flat" cmpd="sng" algn="ctr">
+                      <a:noFill/>
+                    </a:lnR>
+                    <a:lnT w="0" cap="flat" cmpd="sng" algn="ctr">
+                      <a:noFill/>
+                    </a:lnT>
+                    <a:lnB w="6350" cap="flat" cmpd="sng" algn="ctr">
+                      <a:solidFill>
+                        <a:srgbClr val="CFCAC0"/>
+                      </a:solidFill>
+                      <a:prstDash val="solid"/>
+                      <a:round/>
+                      <a:headEnd type="none" w="med" len="med"/>
+                      <a:tailEnd type="none" w="med" len="med"/>
+                    </a:lnB>
+                  </a:tcPr>
+                </a:tc>
+                <a:tc>
+                  <a:txBody>
+                    <a:bodyPr/>
+                    <a:lstStyle/>
+                    <a:p>
+                      <a:pPr indent="0" marL="0">
+                        <a:buNone/>
+                      </a:pPr>
+                      <a:r>
+                        <a:rPr lang="en-US" sz="1000" dirty="0">
+                          <a:solidFill>
+                            <a:srgbClr val="1B1F24"/>
+                          </a:solidFill>
+                          <a:latin typeface="Arial" pitchFamily="34" charset="0"/>
+                          <a:ea typeface="Arial" pitchFamily="34" charset="-122"/>
+                          <a:cs typeface="Arial" pitchFamily="34" charset="-120"/>
+                        </a:rPr>
+                        <a:t>Bồi dưỡng giáo viên ứng dụng AI</a:t>
+                      </a:r>
+                      <a:endParaRPr lang="en-US" sz="1000" dirty="0">
+                        <a:latin typeface="Arial" charset="0"/>
+                        <a:ea typeface="Arial" charset="0"/>
+                        <a:cs typeface="Arial" charset="0"/>
+                      </a:endParaRPr>
+                    </a:p>
+                  </a:txBody>
+                  <a:tcPr marL="0" marR="54864" marT="0" marB="0" anchor="ctr">
+                    <a:lnL w="0" cap="flat" cmpd="sng" algn="ctr">
+                      <a:noFill/>
+                    </a:lnL>
+                    <a:lnR w="0" cap="flat" cmpd="sng" algn="ctr">
+                      <a:noFill/>
+                    </a:lnR>
+                    <a:lnT w="0" cap="flat" cmpd="sng" algn="ctr">
+                      <a:noFill/>
+                    </a:lnT>
+                    <a:lnB w="6350" cap="flat" cmpd="sng" algn="ctr">
+                      <a:solidFill>
+                        <a:srgbClr val="CFCAC0"/>
+                      </a:solidFill>
+                      <a:prstDash val="solid"/>
+                      <a:round/>
+                      <a:headEnd type="none" w="med" len="med"/>
+                      <a:tailEnd type="none" w="med" len="med"/>
+                    </a:lnB>
+                  </a:tcPr>
+                </a:tc>
+              </a:tr>
+            </a:tbl>
+          </a:graphicData>
+        </a:graphic>
+      </p:graphicFrame>
+      <p:sp>
+        <p:nvSpPr>
+          <p:cNvPr id="5" name="Text 2"/>
+          <p:cNvSpPr txBox="1"/>
+          <p:nvPr/>
+        </p:nvSpPr>
+        <p:spPr>
+          <a:xfrm>
+            <a:off x="548640" y="4343400"/>
+            <a:ext cx="8046720" cy="274320"/>
+          </a:xfrm>
+          <a:prstGeom prst="rect">
+            <a:avLst/>
+          </a:prstGeom>
+          <a:noFill/>
+          <a:ln/>
+        </p:spPr>
+        <p:txBody>
+          <a:bodyPr wrap="square" lIns="0" tIns="0" rIns="0" bIns="0" rtlCol="0" anchor="ctr"/>
+          <a:lstStyle/>
+          <a:p>
+            <a:pPr indent="0" marL="0">
+              <a:buNone/>
+            </a:pPr>
+            <a:r>
+              <a:rPr lang="en-US" sz="1000" i="1" dirty="0">
+                <a:solidFill>
+                  <a:srgbClr val="6B6B6B"/>
+                </a:solidFill>
+                <a:latin typeface="Arial" pitchFamily="34" charset="0"/>
+                <a:ea typeface="Arial" pitchFamily="34" charset="-122"/>
+                <a:cs typeface="Arial" pitchFamily="34" charset="-120"/>
+              </a:rPr>
+              <a:t>Danh mục đầy đủ 17 văn bản: trang 4 của sách. Dưới tên mỗi bài có dòng CĂN CỨ.</a:t>
+            </a:r>
+            <a:endParaRPr lang="en-US" sz="1000" dirty="0"/>
+          </a:p>
+        </p:txBody>
+      </p:sp>
+    </p:spTree>
+  </p:cSld>
+  <p:clrMapOvr>
+    <a:masterClrMapping/>
+  </p:clrMapOvr>
+</p:sld>
+</file>
+
+<file path=ppt/slides/slide4.xml><?xml version="1.0" encoding="utf-8"?>
+<p:sld xmlns:a="http://schemas.openxmlformats.org/drawingml/2006/main" xmlns:r="http://schemas.openxmlformats.org/officeDocument/2006/relationships" xmlns:p="http://schemas.openxmlformats.org/presentationml/2006/main">
+  <p:cSld name="Slide 4">
     <p:bg>
       <p:bgPr>
         <a:solidFill>
@@ -5251,9 +6577,9 @@
 </p:sld>
 </file>
 
-<file path=ppt/slides/slide4.xml><?xml version="1.0" encoding="utf-8"?>
+<file path=ppt/slides/slide5.xml><?xml version="1.0" encoding="utf-8"?>
 <p:sld xmlns:a="http://schemas.openxmlformats.org/drawingml/2006/main" xmlns:r="http://schemas.openxmlformats.org/officeDocument/2006/relationships" xmlns:p="http://schemas.openxmlformats.org/presentationml/2006/main">
-  <p:cSld name="Slide 4">
+  <p:cSld name="Slide 5">
     <p:bg>
       <p:bgPr>
         <a:solidFill>
@@ -5307,9 +6633,9 @@
 </p:sld>
 </file>
 
-<file path=ppt/slides/slide5.xml><?xml version="1.0" encoding="utf-8"?>
+<file path=ppt/slides/slide6.xml><?xml version="1.0" encoding="utf-8"?>
 <p:sld xmlns:a="http://schemas.openxmlformats.org/drawingml/2006/main" xmlns:r="http://schemas.openxmlformats.org/officeDocument/2006/relationships" xmlns:p="http://schemas.openxmlformats.org/presentationml/2006/main">
-  <p:cSld name="Slide 5">
+  <p:cSld name="Slide 6">
     <p:bg>
       <p:bgPr>
         <a:solidFill>
@@ -5363,9 +6689,9 @@
 </p:sld>
 </file>
 
-<file path=ppt/slides/slide6.xml><?xml version="1.0" encoding="utf-8"?>
+<file path=ppt/slides/slide7.xml><?xml version="1.0" encoding="utf-8"?>
 <p:sld xmlns:a="http://schemas.openxmlformats.org/drawingml/2006/main" xmlns:r="http://schemas.openxmlformats.org/officeDocument/2006/relationships" xmlns:p="http://schemas.openxmlformats.org/presentationml/2006/main">
-  <p:cSld name="Slide 6">
+  <p:cSld name="Slide 7">
     <p:bg>
       <p:bgPr>
         <a:solidFill>
@@ -5576,9 +6902,9 @@
 </p:sld>
 </file>
 
-<file path=ppt/slides/slide7.xml><?xml version="1.0" encoding="utf-8"?>
+<file path=ppt/slides/slide8.xml><?xml version="1.0" encoding="utf-8"?>
 <p:sld xmlns:a="http://schemas.openxmlformats.org/drawingml/2006/main" xmlns:r="http://schemas.openxmlformats.org/officeDocument/2006/relationships" xmlns:p="http://schemas.openxmlformats.org/presentationml/2006/main">
-  <p:cSld name="Slide 7">
+  <p:cSld name="Slide 8">
     <p:bg>
       <p:bgPr>
         <a:solidFill>
@@ -5632,62 +6958,6 @@
 </p:sld>
 </file>
 
-<file path=ppt/slides/slide8.xml><?xml version="1.0" encoding="utf-8"?>
-<p:sld xmlns:a="http://schemas.openxmlformats.org/drawingml/2006/main" xmlns:r="http://schemas.openxmlformats.org/officeDocument/2006/relationships" xmlns:p="http://schemas.openxmlformats.org/presentationml/2006/main">
-  <p:cSld name="Slide 8">
-    <p:bg>
-      <p:bgPr>
-        <a:solidFill>
-          <a:srgbClr val="F7F5F0"/>
-        </a:solidFill>
-      </p:bgPr>
-    </p:bg>
-    <p:spTree>
-      <p:nvGrpSpPr>
-        <p:cNvPr id="1" name=""/>
-        <p:cNvGrpSpPr/>
-        <p:nvPr/>
-      </p:nvGrpSpPr>
-      <p:grpSpPr>
-        <a:xfrm>
-          <a:off x="0" y="0"/>
-          <a:ext cx="0" cy="0"/>
-          <a:chOff x="0" y="0"/>
-          <a:chExt cx="0" cy="0"/>
-        </a:xfrm>
-      </p:grpSpPr>
-      <p:pic>
-        <p:nvPicPr>
-          <p:cNvPr id="2" name="Image 0" descr="Đánh giá prompt: đối chiếu 6 mảnh ghép, thiếu gì thêm nấy">    </p:cNvPr>
-          <p:cNvPicPr>
-            <a:picLocks noChangeAspect="1"/>
-          </p:cNvPicPr>
-          <p:nvPr/>
-        </p:nvPicPr>
-        <p:blipFill>
-          <a:blip r:embed="rId1"/>
-          <a:stretch>
-            <a:fillRect/>
-          </a:stretch>
-        </p:blipFill>
-        <p:spPr>
-          <a:xfrm>
-            <a:off x="0" y="0"/>
-            <a:ext cx="9144000" cy="5143500"/>
-          </a:xfrm>
-          <a:prstGeom prst="rect">
-            <a:avLst/>
-          </a:prstGeom>
-        </p:spPr>
-      </p:pic>
-    </p:spTree>
-  </p:cSld>
-  <p:clrMapOvr>
-    <a:masterClrMapping/>
-  </p:clrMapOvr>
-</p:sld>
-</file>
-
 <file path=ppt/slides/slide9.xml><?xml version="1.0" encoding="utf-8"?>
 <p:sld xmlns:a="http://schemas.openxmlformats.org/drawingml/2006/main" xmlns:r="http://schemas.openxmlformats.org/officeDocument/2006/relationships" xmlns:p="http://schemas.openxmlformats.org/presentationml/2006/main">
   <p:cSld name="Slide 9">
@@ -5714,7 +6984,7 @@
       </p:grpSpPr>
       <p:pic>
         <p:nvPicPr>
-          <p:cNvPr id="2" name="Image 0" descr="TPACK: điền đủ 3 dòng CK, PK, TK trong câu lệnh">    </p:cNvPr>
+          <p:cNvPr id="2" name="Image 0" descr="Đánh giá prompt: đối chiếu 6 mảnh ghép, thiếu gì thêm nấy">    </p:cNvPr>
           <p:cNvPicPr>
             <a:picLocks noChangeAspect="1"/>
           </p:cNvPicPr>

</xml_diff>